<commit_message>
Update final kimi_k3_infer_insight slides
Co-Authored-By: Claude Fable 5 <noreply@anthropic.com>
</commit_message>
<xml_diff>
--- a/slides/kimi_k3_infer_insight_final.pptx
+++ b/slides/kimi_k3_infer_insight_final.pptx
@@ -126,1118 +126,6 @@
     </p:extLst>
   </p:cmAuthor>
 </p:cmAuthorLst>
-</file>
-
-<file path=ppt/charts/chart1.xml><?xml version="1.0" encoding="utf-8"?>
-<c:chartSpace xmlns:c="http://schemas.openxmlformats.org/drawingml/2006/chart" xmlns:a="http://schemas.openxmlformats.org/drawingml/2006/main" xmlns:r="http://schemas.openxmlformats.org/officeDocument/2006/relationships" xmlns:c16r2="http://schemas.microsoft.com/office/drawing/2015/06/chart">
-  <c:date1904 val="0"/>
-  <c:lang val="zh-CN"/>
-  <c:roundedCorners val="1"/>
-  <mc:AlternateContent xmlns:mc="http://schemas.openxmlformats.org/markup-compatibility/2006">
-    <mc:Choice xmlns:c14="http://schemas.microsoft.com/office/drawing/2007/8/2/chart" Requires="c14">
-      <c14:style val="102"/>
-    </mc:Choice>
-    <mc:Fallback>
-      <c:style val="2"/>
-    </mc:Fallback>
-  </mc:AlternateContent>
-  <c:chart>
-    <c:autoTitleDeleted val="1"/>
-    <c:plotArea>
-      <c:layout/>
-      <c:doughnutChart>
-        <c:varyColors val="1"/>
-        <c:ser>
-          <c:idx val="0"/>
-          <c:order val="0"/>
-          <c:tx>
-            <c:strRef>
-              <c:f>Sheet1!$B$1</c:f>
-              <c:strCache>
-                <c:ptCount val="1"/>
-                <c:pt idx="0">
-                  <c:v>share</c:v>
-                </c:pt>
-              </c:strCache>
-            </c:strRef>
-          </c:tx>
-          <c:spPr>
-            <a:solidFill>
-              <a:srgbClr val="1783FF"/>
-            </a:solidFill>
-            <a:ln w="25400">
-              <a:solidFill>
-                <a:srgbClr val="FFFFFF"/>
-              </a:solidFill>
-            </a:ln>
-          </c:spPr>
-          <c:dPt>
-            <c:idx val="0"/>
-            <c:bubble3D val="0"/>
-            <c:spPr>
-              <a:solidFill>
-                <a:srgbClr val="4C78A8"/>
-              </a:solidFill>
-              <a:ln>
-                <a:noFill/>
-              </a:ln>
-            </c:spPr>
-            <c:extLst>
-              <c:ext xmlns:c16="http://schemas.microsoft.com/office/drawing/2014/chart" uri="{C3380CC4-5D6E-409C-BE32-E72D297353CC}">
-                <c16:uniqueId val="{00000001-6249-43D3-B7A7-2E1085F879B3}"/>
-              </c:ext>
-            </c:extLst>
-          </c:dPt>
-          <c:dPt>
-            <c:idx val="1"/>
-            <c:bubble3D val="0"/>
-            <c:spPr>
-              <a:solidFill>
-                <a:srgbClr val="F2A93B"/>
-              </a:solidFill>
-              <a:ln>
-                <a:noFill/>
-              </a:ln>
-            </c:spPr>
-            <c:extLst>
-              <c:ext xmlns:c16="http://schemas.microsoft.com/office/drawing/2014/chart" uri="{C3380CC4-5D6E-409C-BE32-E72D297353CC}">
-                <c16:uniqueId val="{00000003-6249-43D3-B7A7-2E1085F879B3}"/>
-              </c:ext>
-            </c:extLst>
-          </c:dPt>
-          <c:dPt>
-            <c:idx val="2"/>
-            <c:bubble3D val="0"/>
-            <c:spPr>
-              <a:solidFill>
-                <a:srgbClr val="C9C9C9"/>
-              </a:solidFill>
-              <a:ln>
-                <a:noFill/>
-              </a:ln>
-            </c:spPr>
-            <c:extLst>
-              <c:ext xmlns:c16="http://schemas.microsoft.com/office/drawing/2014/chart" uri="{C3380CC4-5D6E-409C-BE32-E72D297353CC}">
-                <c16:uniqueId val="{00000005-6249-43D3-B7A7-2E1085F879B3}"/>
-              </c:ext>
-            </c:extLst>
-          </c:dPt>
-          <c:dLbls>
-            <c:dLbl>
-              <c:idx val="1"/>
-              <c:numFmt formatCode="0.0%" sourceLinked="0"/>
-              <c:spPr>
-                <a:noFill/>
-                <a:ln>
-                  <a:noFill/>
-                </a:ln>
-                <a:effectLst/>
-              </c:spPr>
-              <c:txPr>
-                <a:bodyPr/>
-                <a:lstStyle/>
-                <a:p>
-                  <a:pPr>
-                    <a:defRPr sz="650" b="1" i="0" u="none" strike="noStrike" noProof="1">
-                      <a:solidFill>
-                        <a:srgbClr val="262626"/>
-                      </a:solidFill>
-                      <a:latin typeface="Arial"/>
-                    </a:defRPr>
-                  </a:pPr>
-                  <a:endParaRPr lang="zh-CN"/>
-                </a:p>
-              </c:txPr>
-              <c:showLegendKey val="0"/>
-              <c:showVal val="0"/>
-              <c:showCatName val="0"/>
-              <c:showSerName val="0"/>
-              <c:showPercent val="1"/>
-              <c:showBubbleSize val="0"/>
-              <c:extLst>
-                <c:ext xmlns:c16="http://schemas.microsoft.com/office/drawing/2014/chart" uri="{C3380CC4-5D6E-409C-BE32-E72D297353CC}">
-                  <c16:uniqueId val="{00000003-6249-43D3-B7A7-2E1085F879B3}"/>
-                </c:ext>
-              </c:extLst>
-            </c:dLbl>
-            <c:numFmt formatCode="0.0%" sourceLinked="0"/>
-            <c:spPr>
-              <a:noFill/>
-              <a:ln>
-                <a:noFill/>
-              </a:ln>
-              <a:effectLst/>
-            </c:spPr>
-            <c:txPr>
-              <a:bodyPr/>
-              <a:lstStyle/>
-              <a:p>
-                <a:pPr>
-                  <a:defRPr sz="650" b="0" i="0" u="none" strike="noStrike" noProof="1">
-                    <a:solidFill>
-                      <a:srgbClr val="262626"/>
-                    </a:solidFill>
-                    <a:latin typeface="Arial"/>
-                  </a:defRPr>
-                </a:pPr>
-                <a:endParaRPr lang="zh-CN"/>
-              </a:p>
-            </c:txPr>
-            <c:showLegendKey val="0"/>
-            <c:showVal val="0"/>
-            <c:showCatName val="0"/>
-            <c:showSerName val="0"/>
-            <c:showPercent val="1"/>
-            <c:showBubbleSize val="0"/>
-            <c:showLeaderLines val="1"/>
-            <c:extLst>
-              <c:ext xmlns:c15="http://schemas.microsoft.com/office/drawing/2012/chart" uri="{CE6537A1-D6FC-4f65-9D91-7224C49458BB}"/>
-            </c:extLst>
-          </c:dLbls>
-          <c:cat>
-            <c:strRef>
-              <c:f>Sheet1!$A$2:$A$4</c:f>
-              <c:strCache>
-                <c:ptCount val="3"/>
-                <c:pt idx="0">
-                  <c:v>ChunkKdaFwd</c:v>
-                </c:pt>
-                <c:pt idx="1">
-                  <c:v>FusedInferAttnScore</c:v>
-                </c:pt>
-                <c:pt idx="2">
-                  <c:v>其他</c:v>
-                </c:pt>
-              </c:strCache>
-            </c:strRef>
-          </c:cat>
-          <c:val>
-            <c:numRef>
-              <c:f>Sheet1!$B$2:$B$4</c:f>
-              <c:numCache>
-                <c:formatCode>General</c:formatCode>
-                <c:ptCount val="3"/>
-                <c:pt idx="0">
-                  <c:v>66.5</c:v>
-                </c:pt>
-                <c:pt idx="1">
-                  <c:v>24.3</c:v>
-                </c:pt>
-                <c:pt idx="2">
-                  <c:v>9.1999999999999993</c:v>
-                </c:pt>
-              </c:numCache>
-            </c:numRef>
-          </c:val>
-          <c:extLst>
-            <c:ext xmlns:c16="http://schemas.microsoft.com/office/drawing/2014/chart" uri="{C3380CC4-5D6E-409C-BE32-E72D297353CC}">
-              <c16:uniqueId val="{00000006-6249-43D3-B7A7-2E1085F879B3}"/>
-            </c:ext>
-          </c:extLst>
-        </c:ser>
-        <c:dLbls>
-          <c:showLegendKey val="0"/>
-          <c:showVal val="0"/>
-          <c:showCatName val="0"/>
-          <c:showSerName val="0"/>
-          <c:showPercent val="0"/>
-          <c:showBubbleSize val="0"/>
-          <c:showLeaderLines val="1"/>
-        </c:dLbls>
-        <c:firstSliceAng val="90"/>
-        <c:holeSize val="35"/>
-      </c:doughnutChart>
-      <c:spPr>
-        <a:noFill/>
-        <a:ln>
-          <a:noFill/>
-        </a:ln>
-      </c:spPr>
-    </c:plotArea>
-    <c:plotVisOnly val="1"/>
-    <c:dispBlanksAs val="gap"/>
-    <c:showDLblsOverMax val="1"/>
-  </c:chart>
-  <c:spPr>
-    <a:noFill/>
-    <a:ln>
-      <a:noFill/>
-    </a:ln>
-  </c:spPr>
-  <c:txPr>
-    <a:bodyPr/>
-    <a:lstStyle/>
-    <a:p>
-      <a:pPr>
-        <a:defRPr b="0" i="0" u="none" strike="noStrike" noProof="1">
-          <a:latin typeface="微软雅黑"/>
-        </a:defRPr>
-      </a:pPr>
-      <a:endParaRPr lang="zh-CN"/>
-    </a:p>
-  </c:txPr>
-  <c:externalData r:id="rId1">
-    <c:autoUpdate val="0"/>
-  </c:externalData>
-</c:chartSpace>
-</file>
-
-<file path=ppt/charts/chart2.xml><?xml version="1.0" encoding="utf-8"?>
-<c:chartSpace xmlns:c="http://schemas.openxmlformats.org/drawingml/2006/chart" xmlns:a="http://schemas.openxmlformats.org/drawingml/2006/main" xmlns:r="http://schemas.openxmlformats.org/officeDocument/2006/relationships" xmlns:c16r2="http://schemas.microsoft.com/office/drawing/2015/06/chart">
-  <c:date1904 val="0"/>
-  <c:lang val="zh-CN"/>
-  <c:roundedCorners val="1"/>
-  <mc:AlternateContent xmlns:mc="http://schemas.openxmlformats.org/markup-compatibility/2006">
-    <mc:Choice xmlns:c14="http://schemas.microsoft.com/office/drawing/2007/8/2/chart" Requires="c14">
-      <c14:style val="102"/>
-    </mc:Choice>
-    <mc:Fallback>
-      <c:style val="2"/>
-    </mc:Fallback>
-  </mc:AlternateContent>
-  <c:chart>
-    <c:autoTitleDeleted val="1"/>
-    <c:plotArea>
-      <c:layout/>
-      <c:doughnutChart>
-        <c:varyColors val="1"/>
-        <c:ser>
-          <c:idx val="0"/>
-          <c:order val="0"/>
-          <c:tx>
-            <c:strRef>
-              <c:f>Sheet1!$B$1</c:f>
-              <c:strCache>
-                <c:ptCount val="1"/>
-                <c:pt idx="0">
-                  <c:v>share</c:v>
-                </c:pt>
-              </c:strCache>
-            </c:strRef>
-          </c:tx>
-          <c:spPr>
-            <a:solidFill>
-              <a:srgbClr val="1783FF"/>
-            </a:solidFill>
-            <a:ln w="25400">
-              <a:solidFill>
-                <a:srgbClr val="FFFFFF"/>
-              </a:solidFill>
-            </a:ln>
-          </c:spPr>
-          <c:dPt>
-            <c:idx val="0"/>
-            <c:bubble3D val="0"/>
-            <c:spPr>
-              <a:solidFill>
-                <a:srgbClr val="4C78A8"/>
-              </a:solidFill>
-              <a:ln>
-                <a:noFill/>
-              </a:ln>
-            </c:spPr>
-            <c:extLst>
-              <c:ext xmlns:c16="http://schemas.microsoft.com/office/drawing/2014/chart" uri="{C3380CC4-5D6E-409C-BE32-E72D297353CC}">
-                <c16:uniqueId val="{00000001-D0F6-4E29-9C9D-5D1F97331919}"/>
-              </c:ext>
-            </c:extLst>
-          </c:dPt>
-          <c:dPt>
-            <c:idx val="1"/>
-            <c:bubble3D val="0"/>
-            <c:spPr>
-              <a:solidFill>
-                <a:srgbClr val="4C78A8"/>
-              </a:solidFill>
-              <a:ln>
-                <a:noFill/>
-              </a:ln>
-            </c:spPr>
-            <c:extLst>
-              <c:ext xmlns:c16="http://schemas.microsoft.com/office/drawing/2014/chart" uri="{C3380CC4-5D6E-409C-BE32-E72D297353CC}">
-                <c16:uniqueId val="{00000003-D0F6-4E29-9C9D-5D1F97331919}"/>
-              </c:ext>
-            </c:extLst>
-          </c:dPt>
-          <c:dPt>
-            <c:idx val="2"/>
-            <c:bubble3D val="0"/>
-            <c:spPr>
-              <a:solidFill>
-                <a:srgbClr val="F2A93B"/>
-              </a:solidFill>
-              <a:ln>
-                <a:noFill/>
-              </a:ln>
-            </c:spPr>
-            <c:extLst>
-              <c:ext xmlns:c16="http://schemas.microsoft.com/office/drawing/2014/chart" uri="{C3380CC4-5D6E-409C-BE32-E72D297353CC}">
-                <c16:uniqueId val="{00000005-D0F6-4E29-9C9D-5D1F97331919}"/>
-              </c:ext>
-            </c:extLst>
-          </c:dPt>
-          <c:dPt>
-            <c:idx val="3"/>
-            <c:bubble3D val="0"/>
-            <c:spPr>
-              <a:solidFill>
-                <a:srgbClr val="F2A93B"/>
-              </a:solidFill>
-              <a:ln>
-                <a:noFill/>
-              </a:ln>
-            </c:spPr>
-            <c:extLst>
-              <c:ext xmlns:c16="http://schemas.microsoft.com/office/drawing/2014/chart" uri="{C3380CC4-5D6E-409C-BE32-E72D297353CC}">
-                <c16:uniqueId val="{00000007-D0F6-4E29-9C9D-5D1F97331919}"/>
-              </c:ext>
-            </c:extLst>
-          </c:dPt>
-          <c:dPt>
-            <c:idx val="4"/>
-            <c:bubble3D val="0"/>
-            <c:spPr>
-              <a:solidFill>
-                <a:srgbClr val="C9C9C9"/>
-              </a:solidFill>
-              <a:ln>
-                <a:noFill/>
-              </a:ln>
-            </c:spPr>
-            <c:extLst>
-              <c:ext xmlns:c16="http://schemas.microsoft.com/office/drawing/2014/chart" uri="{C3380CC4-5D6E-409C-BE32-E72D297353CC}">
-                <c16:uniqueId val="{00000009-D0F6-4E29-9C9D-5D1F97331919}"/>
-              </c:ext>
-            </c:extLst>
-          </c:dPt>
-          <c:dLbls>
-            <c:numFmt formatCode="0.0%" sourceLinked="0"/>
-            <c:spPr>
-              <a:noFill/>
-              <a:ln>
-                <a:noFill/>
-              </a:ln>
-              <a:effectLst/>
-            </c:spPr>
-            <c:txPr>
-              <a:bodyPr/>
-              <a:lstStyle/>
-              <a:p>
-                <a:pPr>
-                  <a:defRPr sz="650" b="0" i="0" u="none" strike="noStrike" noProof="1">
-                    <a:solidFill>
-                      <a:srgbClr val="262626"/>
-                    </a:solidFill>
-                    <a:latin typeface="Arial"/>
-                  </a:defRPr>
-                </a:pPr>
-                <a:endParaRPr lang="zh-CN"/>
-              </a:p>
-            </c:txPr>
-            <c:showLegendKey val="0"/>
-            <c:showVal val="0"/>
-            <c:showCatName val="0"/>
-            <c:showSerName val="0"/>
-            <c:showPercent val="1"/>
-            <c:showBubbleSize val="0"/>
-            <c:showLeaderLines val="1"/>
-            <c:extLst>
-              <c:ext xmlns:c15="http://schemas.microsoft.com/office/drawing/2012/chart" uri="{CE6537A1-D6FC-4f65-9D91-7224C49458BB}"/>
-            </c:extLst>
-          </c:dLbls>
-          <c:cat>
-            <c:strRef>
-              <c:f>Sheet1!$A$2:$A$6</c:f>
-              <c:strCache>
-                <c:ptCount val="5"/>
-                <c:pt idx="0">
-                  <c:v>GroupedMatmul</c:v>
-                </c:pt>
-                <c:pt idx="1">
-                  <c:v>QuantBatchMatmulV3</c:v>
-                </c:pt>
-                <c:pt idx="2">
-                  <c:v>DequantSituQuant</c:v>
-                </c:pt>
-                <c:pt idx="3">
-                  <c:v>DynamicQuant</c:v>
-                </c:pt>
-                <c:pt idx="4">
-                  <c:v>其他</c:v>
-                </c:pt>
-              </c:strCache>
-            </c:strRef>
-          </c:cat>
-          <c:val>
-            <c:numRef>
-              <c:f>Sheet1!$B$2:$B$6</c:f>
-              <c:numCache>
-                <c:formatCode>General</c:formatCode>
-                <c:ptCount val="5"/>
-                <c:pt idx="0">
-                  <c:v>34.5</c:v>
-                </c:pt>
-                <c:pt idx="1">
-                  <c:v>18.600000000000001</c:v>
-                </c:pt>
-                <c:pt idx="2">
-                  <c:v>19.399999999999999</c:v>
-                </c:pt>
-                <c:pt idx="3">
-                  <c:v>16.5</c:v>
-                </c:pt>
-                <c:pt idx="4">
-                  <c:v>11</c:v>
-                </c:pt>
-              </c:numCache>
-            </c:numRef>
-          </c:val>
-          <c:extLst>
-            <c:ext xmlns:c16="http://schemas.microsoft.com/office/drawing/2014/chart" uri="{C3380CC4-5D6E-409C-BE32-E72D297353CC}">
-              <c16:uniqueId val="{0000000A-D0F6-4E29-9C9D-5D1F97331919}"/>
-            </c:ext>
-          </c:extLst>
-        </c:ser>
-        <c:dLbls>
-          <c:showLegendKey val="0"/>
-          <c:showVal val="0"/>
-          <c:showCatName val="0"/>
-          <c:showSerName val="0"/>
-          <c:showPercent val="0"/>
-          <c:showBubbleSize val="0"/>
-          <c:showLeaderLines val="1"/>
-        </c:dLbls>
-        <c:firstSliceAng val="90"/>
-        <c:holeSize val="35"/>
-      </c:doughnutChart>
-      <c:spPr>
-        <a:noFill/>
-        <a:ln>
-          <a:noFill/>
-        </a:ln>
-      </c:spPr>
-    </c:plotArea>
-    <c:plotVisOnly val="1"/>
-    <c:dispBlanksAs val="gap"/>
-    <c:showDLblsOverMax val="1"/>
-  </c:chart>
-  <c:spPr>
-    <a:noFill/>
-    <a:ln>
-      <a:noFill/>
-    </a:ln>
-  </c:spPr>
-  <c:txPr>
-    <a:bodyPr/>
-    <a:lstStyle/>
-    <a:p>
-      <a:pPr>
-        <a:defRPr b="0" i="0" u="none" strike="noStrike" noProof="1">
-          <a:latin typeface="微软雅黑"/>
-        </a:defRPr>
-      </a:pPr>
-      <a:endParaRPr lang="zh-CN"/>
-    </a:p>
-  </c:txPr>
-  <c:externalData r:id="rId1">
-    <c:autoUpdate val="0"/>
-  </c:externalData>
-</c:chartSpace>
-</file>
-
-<file path=ppt/charts/chart3.xml><?xml version="1.0" encoding="utf-8"?>
-<c:chartSpace xmlns:c="http://schemas.openxmlformats.org/drawingml/2006/chart" xmlns:a="http://schemas.openxmlformats.org/drawingml/2006/main" xmlns:r="http://schemas.openxmlformats.org/officeDocument/2006/relationships" xmlns:c16r2="http://schemas.microsoft.com/office/drawing/2015/06/chart">
-  <c:date1904 val="0"/>
-  <c:lang val="zh-CN"/>
-  <c:roundedCorners val="1"/>
-  <mc:AlternateContent xmlns:mc="http://schemas.openxmlformats.org/markup-compatibility/2006">
-    <mc:Choice xmlns:c14="http://schemas.microsoft.com/office/drawing/2007/8/2/chart" Requires="c14">
-      <c14:style val="102"/>
-    </mc:Choice>
-    <mc:Fallback>
-      <c:style val="2"/>
-    </mc:Fallback>
-  </mc:AlternateContent>
-  <c:chart>
-    <c:autoTitleDeleted val="1"/>
-    <c:plotArea>
-      <c:layout/>
-      <c:doughnutChart>
-        <c:varyColors val="1"/>
-        <c:ser>
-          <c:idx val="0"/>
-          <c:order val="0"/>
-          <c:tx>
-            <c:strRef>
-              <c:f>Sheet1!$B$1</c:f>
-              <c:strCache>
-                <c:ptCount val="1"/>
-                <c:pt idx="0">
-                  <c:v>share</c:v>
-                </c:pt>
-              </c:strCache>
-            </c:strRef>
-          </c:tx>
-          <c:spPr>
-            <a:solidFill>
-              <a:srgbClr val="1783FF"/>
-            </a:solidFill>
-            <a:ln w="25400">
-              <a:solidFill>
-                <a:srgbClr val="FFFFFF"/>
-              </a:solidFill>
-            </a:ln>
-          </c:spPr>
-          <c:dPt>
-            <c:idx val="0"/>
-            <c:bubble3D val="0"/>
-            <c:spPr>
-              <a:solidFill>
-                <a:srgbClr val="F2A93B"/>
-              </a:solidFill>
-              <a:ln>
-                <a:noFill/>
-              </a:ln>
-            </c:spPr>
-            <c:extLst>
-              <c:ext xmlns:c16="http://schemas.microsoft.com/office/drawing/2014/chart" uri="{C3380CC4-5D6E-409C-BE32-E72D297353CC}">
-                <c16:uniqueId val="{00000001-2E32-46FA-A9A1-415F3F324614}"/>
-              </c:ext>
-            </c:extLst>
-          </c:dPt>
-          <c:dPt>
-            <c:idx val="1"/>
-            <c:bubble3D val="0"/>
-            <c:spPr>
-              <a:solidFill>
-                <a:srgbClr val="F2A93B"/>
-              </a:solidFill>
-              <a:ln>
-                <a:noFill/>
-              </a:ln>
-            </c:spPr>
-            <c:extLst>
-              <c:ext xmlns:c16="http://schemas.microsoft.com/office/drawing/2014/chart" uri="{C3380CC4-5D6E-409C-BE32-E72D297353CC}">
-                <c16:uniqueId val="{00000003-2E32-46FA-A9A1-415F3F324614}"/>
-              </c:ext>
-            </c:extLst>
-          </c:dPt>
-          <c:dPt>
-            <c:idx val="2"/>
-            <c:bubble3D val="0"/>
-            <c:spPr>
-              <a:solidFill>
-                <a:srgbClr val="F2A93B"/>
-              </a:solidFill>
-              <a:ln>
-                <a:noFill/>
-              </a:ln>
-            </c:spPr>
-            <c:extLst>
-              <c:ext xmlns:c16="http://schemas.microsoft.com/office/drawing/2014/chart" uri="{C3380CC4-5D6E-409C-BE32-E72D297353CC}">
-                <c16:uniqueId val="{00000005-2E32-46FA-A9A1-415F3F324614}"/>
-              </c:ext>
-            </c:extLst>
-          </c:dPt>
-          <c:dPt>
-            <c:idx val="3"/>
-            <c:bubble3D val="0"/>
-            <c:spPr>
-              <a:solidFill>
-                <a:srgbClr val="4C78A8"/>
-              </a:solidFill>
-              <a:ln>
-                <a:noFill/>
-              </a:ln>
-            </c:spPr>
-            <c:extLst>
-              <c:ext xmlns:c16="http://schemas.microsoft.com/office/drawing/2014/chart" uri="{C3380CC4-5D6E-409C-BE32-E72D297353CC}">
-                <c16:uniqueId val="{00000007-2E32-46FA-A9A1-415F3F324614}"/>
-              </c:ext>
-            </c:extLst>
-          </c:dPt>
-          <c:dPt>
-            <c:idx val="4"/>
-            <c:bubble3D val="0"/>
-            <c:spPr>
-              <a:solidFill>
-                <a:srgbClr val="C9C9C9"/>
-              </a:solidFill>
-              <a:ln>
-                <a:noFill/>
-              </a:ln>
-            </c:spPr>
-            <c:extLst>
-              <c:ext xmlns:c16="http://schemas.microsoft.com/office/drawing/2014/chart" uri="{C3380CC4-5D6E-409C-BE32-E72D297353CC}">
-                <c16:uniqueId val="{00000009-2E32-46FA-A9A1-415F3F324614}"/>
-              </c:ext>
-            </c:extLst>
-          </c:dPt>
-          <c:dLbls>
-            <c:numFmt formatCode="0.0%" sourceLinked="0"/>
-            <c:spPr>
-              <a:noFill/>
-              <a:ln>
-                <a:noFill/>
-              </a:ln>
-              <a:effectLst/>
-            </c:spPr>
-            <c:txPr>
-              <a:bodyPr/>
-              <a:lstStyle/>
-              <a:p>
-                <a:pPr>
-                  <a:defRPr sz="650" b="0" i="0" u="none" strike="noStrike" noProof="1">
-                    <a:solidFill>
-                      <a:srgbClr val="262626"/>
-                    </a:solidFill>
-                    <a:latin typeface="Arial"/>
-                  </a:defRPr>
-                </a:pPr>
-                <a:endParaRPr lang="zh-CN"/>
-              </a:p>
-            </c:txPr>
-            <c:showLegendKey val="0"/>
-            <c:showVal val="0"/>
-            <c:showCatName val="0"/>
-            <c:showSerName val="0"/>
-            <c:showPercent val="1"/>
-            <c:showBubbleSize val="0"/>
-            <c:showLeaderLines val="1"/>
-            <c:extLst>
-              <c:ext xmlns:c15="http://schemas.microsoft.com/office/drawing/2012/chart" uri="{CE6537A1-D6FC-4f65-9D91-7224C49458BB}"/>
-            </c:extLst>
-          </c:dLbls>
-          <c:cat>
-            <c:strRef>
-              <c:f>Sheet1!$A$2:$A$6</c:f>
-              <c:strCache>
-                <c:ptCount val="5"/>
-                <c:pt idx="0">
-                  <c:v>FlashMlaWithKvcache</c:v>
-                </c:pt>
-                <c:pt idx="1">
-                  <c:v>AttnResFwdFused</c:v>
-                </c:pt>
-                <c:pt idx="2">
-                  <c:v>MlaPrologV3</c:v>
-                </c:pt>
-                <c:pt idx="3">
-                  <c:v>RecurrentKda</c:v>
-                </c:pt>
-                <c:pt idx="4">
-                  <c:v>其他</c:v>
-                </c:pt>
-              </c:strCache>
-            </c:strRef>
-          </c:cat>
-          <c:val>
-            <c:numRef>
-              <c:f>Sheet1!$B$2:$B$6</c:f>
-              <c:numCache>
-                <c:formatCode>General</c:formatCode>
-                <c:ptCount val="5"/>
-                <c:pt idx="0">
-                  <c:v>51.5</c:v>
-                </c:pt>
-                <c:pt idx="1">
-                  <c:v>13.4</c:v>
-                </c:pt>
-                <c:pt idx="2">
-                  <c:v>7.9</c:v>
-                </c:pt>
-                <c:pt idx="3">
-                  <c:v>14.7</c:v>
-                </c:pt>
-                <c:pt idx="4">
-                  <c:v>12.5</c:v>
-                </c:pt>
-              </c:numCache>
-            </c:numRef>
-          </c:val>
-          <c:extLst>
-            <c:ext xmlns:c16="http://schemas.microsoft.com/office/drawing/2014/chart" uri="{C3380CC4-5D6E-409C-BE32-E72D297353CC}">
-              <c16:uniqueId val="{0000000A-2E32-46FA-A9A1-415F3F324614}"/>
-            </c:ext>
-          </c:extLst>
-        </c:ser>
-        <c:dLbls>
-          <c:showLegendKey val="0"/>
-          <c:showVal val="0"/>
-          <c:showCatName val="0"/>
-          <c:showSerName val="0"/>
-          <c:showPercent val="0"/>
-          <c:showBubbleSize val="0"/>
-          <c:showLeaderLines val="1"/>
-        </c:dLbls>
-        <c:firstSliceAng val="90"/>
-        <c:holeSize val="35"/>
-      </c:doughnutChart>
-      <c:spPr>
-        <a:noFill/>
-        <a:ln>
-          <a:noFill/>
-        </a:ln>
-      </c:spPr>
-    </c:plotArea>
-    <c:plotVisOnly val="1"/>
-    <c:dispBlanksAs val="gap"/>
-    <c:showDLblsOverMax val="1"/>
-  </c:chart>
-  <c:spPr>
-    <a:noFill/>
-    <a:ln>
-      <a:noFill/>
-    </a:ln>
-  </c:spPr>
-  <c:txPr>
-    <a:bodyPr/>
-    <a:lstStyle/>
-    <a:p>
-      <a:pPr>
-        <a:defRPr b="0" i="0" u="none" strike="noStrike" noProof="1">
-          <a:latin typeface="微软雅黑"/>
-        </a:defRPr>
-      </a:pPr>
-      <a:endParaRPr lang="zh-CN"/>
-    </a:p>
-  </c:txPr>
-  <c:externalData r:id="rId1">
-    <c:autoUpdate val="0"/>
-  </c:externalData>
-</c:chartSpace>
-</file>
-
-<file path=ppt/charts/chart4.xml><?xml version="1.0" encoding="utf-8"?>
-<c:chartSpace xmlns:c="http://schemas.openxmlformats.org/drawingml/2006/chart" xmlns:a="http://schemas.openxmlformats.org/drawingml/2006/main" xmlns:r="http://schemas.openxmlformats.org/officeDocument/2006/relationships" xmlns:c16r2="http://schemas.microsoft.com/office/drawing/2015/06/chart">
-  <c:date1904 val="0"/>
-  <c:lang val="zh-CN"/>
-  <c:roundedCorners val="1"/>
-  <mc:AlternateContent xmlns:mc="http://schemas.openxmlformats.org/markup-compatibility/2006">
-    <mc:Choice xmlns:c14="http://schemas.microsoft.com/office/drawing/2007/8/2/chart" Requires="c14">
-      <c14:style val="102"/>
-    </mc:Choice>
-    <mc:Fallback>
-      <c:style val="2"/>
-    </mc:Fallback>
-  </mc:AlternateContent>
-  <c:chart>
-    <c:autoTitleDeleted val="1"/>
-    <c:plotArea>
-      <c:layout/>
-      <c:doughnutChart>
-        <c:varyColors val="1"/>
-        <c:ser>
-          <c:idx val="0"/>
-          <c:order val="0"/>
-          <c:tx>
-            <c:strRef>
-              <c:f>Sheet1!$B$1</c:f>
-              <c:strCache>
-                <c:ptCount val="1"/>
-                <c:pt idx="0">
-                  <c:v>share</c:v>
-                </c:pt>
-              </c:strCache>
-            </c:strRef>
-          </c:tx>
-          <c:spPr>
-            <a:solidFill>
-              <a:srgbClr val="1783FF"/>
-            </a:solidFill>
-            <a:ln w="25400">
-              <a:solidFill>
-                <a:srgbClr val="FFFFFF"/>
-              </a:solidFill>
-            </a:ln>
-          </c:spPr>
-          <c:dPt>
-            <c:idx val="0"/>
-            <c:bubble3D val="0"/>
-            <c:spPr>
-              <a:solidFill>
-                <a:srgbClr val="4C78A8"/>
-              </a:solidFill>
-              <a:ln>
-                <a:noFill/>
-              </a:ln>
-            </c:spPr>
-            <c:extLst>
-              <c:ext xmlns:c16="http://schemas.microsoft.com/office/drawing/2014/chart" uri="{C3380CC4-5D6E-409C-BE32-E72D297353CC}">
-                <c16:uniqueId val="{00000001-20D1-40CA-AE76-025CDE55CDD6}"/>
-              </c:ext>
-            </c:extLst>
-          </c:dPt>
-          <c:dPt>
-            <c:idx val="1"/>
-            <c:bubble3D val="0"/>
-            <c:spPr>
-              <a:solidFill>
-                <a:srgbClr val="4C78A8"/>
-              </a:solidFill>
-              <a:ln>
-                <a:noFill/>
-              </a:ln>
-            </c:spPr>
-            <c:extLst>
-              <c:ext xmlns:c16="http://schemas.microsoft.com/office/drawing/2014/chart" uri="{C3380CC4-5D6E-409C-BE32-E72D297353CC}">
-                <c16:uniqueId val="{00000003-20D1-40CA-AE76-025CDE55CDD6}"/>
-              </c:ext>
-            </c:extLst>
-          </c:dPt>
-          <c:dPt>
-            <c:idx val="2"/>
-            <c:bubble3D val="0"/>
-            <c:spPr>
-              <a:solidFill>
-                <a:srgbClr val="4C78A8"/>
-              </a:solidFill>
-              <a:ln>
-                <a:noFill/>
-              </a:ln>
-            </c:spPr>
-            <c:extLst>
-              <c:ext xmlns:c16="http://schemas.microsoft.com/office/drawing/2014/chart" uri="{C3380CC4-5D6E-409C-BE32-E72D297353CC}">
-                <c16:uniqueId val="{00000005-20D1-40CA-AE76-025CDE55CDD6}"/>
-              </c:ext>
-            </c:extLst>
-          </c:dPt>
-          <c:dPt>
-            <c:idx val="3"/>
-            <c:bubble3D val="0"/>
-            <c:spPr>
-              <a:solidFill>
-                <a:srgbClr val="4C78A8"/>
-              </a:solidFill>
-              <a:ln>
-                <a:noFill/>
-              </a:ln>
-            </c:spPr>
-            <c:extLst>
-              <c:ext xmlns:c16="http://schemas.microsoft.com/office/drawing/2014/chart" uri="{C3380CC4-5D6E-409C-BE32-E72D297353CC}">
-                <c16:uniqueId val="{00000007-20D1-40CA-AE76-025CDE55CDD6}"/>
-              </c:ext>
-            </c:extLst>
-          </c:dPt>
-          <c:dPt>
-            <c:idx val="4"/>
-            <c:bubble3D val="0"/>
-            <c:spPr>
-              <a:solidFill>
-                <a:srgbClr val="E45756"/>
-              </a:solidFill>
-              <a:ln>
-                <a:noFill/>
-              </a:ln>
-            </c:spPr>
-            <c:extLst>
-              <c:ext xmlns:c16="http://schemas.microsoft.com/office/drawing/2014/chart" uri="{C3380CC4-5D6E-409C-BE32-E72D297353CC}">
-                <c16:uniqueId val="{00000009-20D1-40CA-AE76-025CDE55CDD6}"/>
-              </c:ext>
-            </c:extLst>
-          </c:dPt>
-          <c:dPt>
-            <c:idx val="5"/>
-            <c:bubble3D val="0"/>
-            <c:spPr>
-              <a:solidFill>
-                <a:srgbClr val="C9C9C9"/>
-              </a:solidFill>
-              <a:ln>
-                <a:noFill/>
-              </a:ln>
-            </c:spPr>
-            <c:extLst>
-              <c:ext xmlns:c16="http://schemas.microsoft.com/office/drawing/2014/chart" uri="{C3380CC4-5D6E-409C-BE32-E72D297353CC}">
-                <c16:uniqueId val="{0000000B-20D1-40CA-AE76-025CDE55CDD6}"/>
-              </c:ext>
-            </c:extLst>
-          </c:dPt>
-          <c:dLbls>
-            <c:numFmt formatCode="0.0%" sourceLinked="0"/>
-            <c:spPr>
-              <a:noFill/>
-              <a:ln>
-                <a:noFill/>
-              </a:ln>
-              <a:effectLst/>
-            </c:spPr>
-            <c:txPr>
-              <a:bodyPr/>
-              <a:lstStyle/>
-              <a:p>
-                <a:pPr>
-                  <a:defRPr sz="650" b="0" i="0" u="none" strike="noStrike" noProof="1">
-                    <a:solidFill>
-                      <a:srgbClr val="262626"/>
-                    </a:solidFill>
-                    <a:latin typeface="Arial"/>
-                  </a:defRPr>
-                </a:pPr>
-                <a:endParaRPr lang="zh-CN"/>
-              </a:p>
-            </c:txPr>
-            <c:showLegendKey val="0"/>
-            <c:showVal val="0"/>
-            <c:showCatName val="0"/>
-            <c:showSerName val="0"/>
-            <c:showPercent val="1"/>
-            <c:showBubbleSize val="0"/>
-            <c:showLeaderLines val="1"/>
-            <c:extLst>
-              <c:ext xmlns:c15="http://schemas.microsoft.com/office/drawing/2012/chart" uri="{CE6537A1-D6FC-4f65-9D91-7224C49458BB}"/>
-            </c:extLst>
-          </c:dLbls>
-          <c:cat>
-            <c:strRef>
-              <c:f>Sheet1!$A$2:$A$7</c:f>
-              <c:strCache>
-                <c:ptCount val="6"/>
-                <c:pt idx="0">
-                  <c:v>GroupedMatmulSituQuant</c:v>
-                </c:pt>
-                <c:pt idx="1">
-                  <c:v>GroupedMatmul</c:v>
-                </c:pt>
-                <c:pt idx="2">
-                  <c:v>QuantBatchMatmulV4</c:v>
-                </c:pt>
-                <c:pt idx="3">
-                  <c:v>QuantBatchMatmulV3</c:v>
-                </c:pt>
-                <c:pt idx="4">
-                  <c:v>Dispatch/Combine</c:v>
-                </c:pt>
-                <c:pt idx="5">
-                  <c:v>其他</c:v>
-                </c:pt>
-              </c:strCache>
-            </c:strRef>
-          </c:cat>
-          <c:val>
-            <c:numRef>
-              <c:f>Sheet1!$B$2:$B$7</c:f>
-              <c:numCache>
-                <c:formatCode>General</c:formatCode>
-                <c:ptCount val="6"/>
-                <c:pt idx="0">
-                  <c:v>35</c:v>
-                </c:pt>
-                <c:pt idx="1">
-                  <c:v>18.600000000000001</c:v>
-                </c:pt>
-                <c:pt idx="2">
-                  <c:v>14.3</c:v>
-                </c:pt>
-                <c:pt idx="3">
-                  <c:v>13.6</c:v>
-                </c:pt>
-                <c:pt idx="4">
-                  <c:v>14.3</c:v>
-                </c:pt>
-                <c:pt idx="5">
-                  <c:v>4.2</c:v>
-                </c:pt>
-              </c:numCache>
-            </c:numRef>
-          </c:val>
-          <c:extLst>
-            <c:ext xmlns:c16="http://schemas.microsoft.com/office/drawing/2014/chart" uri="{C3380CC4-5D6E-409C-BE32-E72D297353CC}">
-              <c16:uniqueId val="{0000000C-20D1-40CA-AE76-025CDE55CDD6}"/>
-            </c:ext>
-          </c:extLst>
-        </c:ser>
-        <c:dLbls>
-          <c:showLegendKey val="0"/>
-          <c:showVal val="0"/>
-          <c:showCatName val="0"/>
-          <c:showSerName val="0"/>
-          <c:showPercent val="0"/>
-          <c:showBubbleSize val="0"/>
-          <c:showLeaderLines val="1"/>
-        </c:dLbls>
-        <c:firstSliceAng val="90"/>
-        <c:holeSize val="35"/>
-      </c:doughnutChart>
-      <c:spPr>
-        <a:noFill/>
-        <a:ln>
-          <a:noFill/>
-        </a:ln>
-      </c:spPr>
-    </c:plotArea>
-    <c:plotVisOnly val="1"/>
-    <c:dispBlanksAs val="gap"/>
-    <c:showDLblsOverMax val="1"/>
-  </c:chart>
-  <c:spPr>
-    <a:noFill/>
-    <a:ln>
-      <a:noFill/>
-    </a:ln>
-  </c:spPr>
-  <c:txPr>
-    <a:bodyPr/>
-    <a:lstStyle/>
-    <a:p>
-      <a:pPr>
-        <a:defRPr b="0" i="0" u="none" strike="noStrike" noProof="1">
-          <a:latin typeface="微软雅黑"/>
-        </a:defRPr>
-      </a:pPr>
-      <a:endParaRPr lang="zh-CN"/>
-    </a:p>
-  </c:txPr>
-  <c:externalData r:id="rId1">
-    <c:autoUpdate val="0"/>
-  </c:externalData>
-</c:chartSpace>
-</file>
-
-<file path=ppt/comments/comment1.xml><?xml version="1.0" encoding="utf-8"?>
-<p:cmLst xmlns:a="http://schemas.openxmlformats.org/drawingml/2006/main" xmlns:r="http://schemas.openxmlformats.org/officeDocument/2006/relationships" xmlns:p="http://schemas.openxmlformats.org/presentationml/2006/main">
-  <p:cm authorId="1" dt="2026-10-21T10:49:56.985" idx="13">
-    <p:pos x="2069" y="1484"/>
-    <p:text>图</p:text>
-    <p:extLst>
-      <p:ext uri="{C676402C-5697-4E1C-873F-D02D1690AC5C}">
-        <p15:threadingInfo xmlns:p15="http://schemas.microsoft.com/office/powerpoint/2012/main" timeZoneBias="-480"/>
-      </p:ext>
-    </p:extLst>
-  </p:cm>
-  <p:cm authorId="1" dt="2026-10-21T10:50:44.657" idx="15">
-    <p:pos x="2799" y="3860"/>
-    <p:text>Prefill: MoE -&gt; 通信占比高 -&gt; 长序列无Prefix Cache</p:text>
-    <p:extLst>
-      <p:ext uri="{C676402C-5697-4E1C-873F-D02D1690AC5C}">
-        <p15:threadingInfo xmlns:p15="http://schemas.microsoft.com/office/powerpoint/2012/main" timeZoneBias="-480"/>
-      </p:ext>
-    </p:extLst>
-  </p:cm>
-  <p:cm authorId="1" dt="2026-10-21T10:53:24.608" idx="17">
-    <p:pos x="2794" y="4023"/>
-    <p:text>Decode: 计算访存都占比较高，访存-&gt; MoE 权重搬运；Attn KV gather, 计算-&gt;高并发，bs较大</p:text>
-    <p:extLst>
-      <p:ext uri="{C676402C-5697-4E1C-873F-D02D1690AC5C}">
-        <p15:threadingInfo xmlns:p15="http://schemas.microsoft.com/office/powerpoint/2012/main" timeZoneBias="-480"/>
-      </p:ext>
-    </p:extLst>
-  </p:cm>
-</p:cmLst>
-</file>
-
-<file path=ppt/comments/comment2.xml><?xml version="1.0" encoding="utf-8"?>
-<p:cmLst xmlns:a="http://schemas.openxmlformats.org/drawingml/2006/main" xmlns:r="http://schemas.openxmlformats.org/officeDocument/2006/relationships" xmlns:p="http://schemas.openxmlformats.org/presentationml/2006/main">
-  <p:cm authorId="1" dt="2026-10-21T11:09:53.525" idx="18">
-    <p:pos x="6489" y="699"/>
-    <p:text>在哪里存储，在哪里计算哪些东西，加上公式解释为什么只需要这些</p:text>
-    <p:extLst>
-      <p:ext uri="{C676402C-5697-4E1C-873F-D02D1690AC5C}">
-        <p15:threadingInfo xmlns:p15="http://schemas.microsoft.com/office/powerpoint/2012/main" timeZoneBias="-480"/>
-      </p:ext>
-    </p:extLst>
-  </p:cm>
-</p:cmLst>
 </file>
 
 <file path=ppt/notesMasters/notesMaster1.xml><?xml version="1.0" encoding="utf-8"?>
@@ -6166,8 +5054,8 @@
         </p:nvGrpSpPr>
         <p:grpSpPr>
           <a:xfrm>
-            <a:off x="231725" y="1205093"/>
-            <a:ext cx="4830092" cy="1074815"/>
+            <a:off x="231724" y="1205094"/>
+            <a:ext cx="4950253" cy="978204"/>
             <a:chOff x="2359219" y="1643545"/>
             <a:chExt cx="4765479" cy="5043177"/>
           </a:xfrm>
@@ -6502,10 +5390,10 @@
         </p:nvGrpSpPr>
         <p:grpSpPr>
           <a:xfrm>
-            <a:off x="206167" y="2349775"/>
-            <a:ext cx="4854645" cy="4317715"/>
-            <a:chOff x="2359219" y="1643545"/>
-            <a:chExt cx="4765479" cy="5043177"/>
+            <a:off x="206167" y="2226915"/>
+            <a:ext cx="4981102" cy="5402462"/>
+            <a:chOff x="2359220" y="1407121"/>
+            <a:chExt cx="4765481" cy="5279601"/>
           </a:xfrm>
         </p:grpSpPr>
         <p:sp>
@@ -6522,8 +5410,8 @@
           </p:nvSpPr>
           <p:spPr>
             <a:xfrm>
-              <a:off x="2359219" y="1647570"/>
-              <a:ext cx="4761052" cy="5035128"/>
+              <a:off x="2359220" y="1410567"/>
+              <a:ext cx="4761053" cy="4382419"/>
             </a:xfrm>
             <a:prstGeom prst="rect">
               <a:avLst/>
@@ -6573,7 +5461,7 @@
           </p:nvCxnSpPr>
           <p:spPr>
             <a:xfrm>
-              <a:off x="2359219" y="1647570"/>
+              <a:off x="2359220" y="1410567"/>
               <a:ext cx="195024" cy="0"/>
             </a:xfrm>
             <a:prstGeom prst="line">
@@ -6606,7 +5494,7 @@
           </p:nvCxnSpPr>
           <p:spPr>
             <a:xfrm>
-              <a:off x="2359219" y="6678673"/>
+              <a:off x="2359221" y="5717945"/>
               <a:ext cx="195024" cy="0"/>
             </a:xfrm>
             <a:prstGeom prst="line">
@@ -6639,8 +5527,41 @@
           </p:nvCxnSpPr>
           <p:spPr>
             <a:xfrm>
-              <a:off x="6929674" y="1647570"/>
+              <a:off x="6929677" y="1410567"/>
               <a:ext cx="195024" cy="0"/>
+            </a:xfrm>
+            <a:prstGeom prst="line">
+              <a:avLst/>
+            </a:prstGeom>
+            <a:solidFill>
+              <a:srgbClr val="FFFFFF"/>
+            </a:solidFill>
+            <a:ln w="22225" cap="flat" cmpd="sng" algn="ctr">
+              <a:solidFill>
+                <a:srgbClr val="C00000"/>
+              </a:solidFill>
+              <a:prstDash val="solid"/>
+              <a:miter lim="800000"/>
+            </a:ln>
+            <a:effectLst/>
+          </p:spPr>
+        </p:cxnSp>
+        <p:cxnSp>
+          <p:nvCxnSpPr>
+            <p:cNvPr id="295" name="直接连接符 132">
+              <a:extLst>
+                <a:ext uri="{FF2B5EF4-FFF2-40B4-BE49-F238E27FC236}">
+                  <a16:creationId xmlns:a16="http://schemas.microsoft.com/office/drawing/2014/main" id="{FB0374A5-A0FE-4778-BABD-30E9BE35CE23}"/>
+                </a:ext>
+              </a:extLst>
+            </p:cNvPr>
+            <p:cNvCxnSpPr/>
+            <p:nvPr/>
+          </p:nvCxnSpPr>
+          <p:spPr>
+            <a:xfrm flipH="1">
+              <a:off x="2360160" y="1407121"/>
+              <a:ext cx="668" cy="669194"/>
             </a:xfrm>
             <a:prstGeom prst="line">
               <a:avLst/>
@@ -6672,41 +5593,8 @@
           </p:nvCxnSpPr>
           <p:spPr>
             <a:xfrm flipH="1">
-              <a:off x="7119869" y="1643545"/>
-              <a:ext cx="1" cy="781632"/>
-            </a:xfrm>
-            <a:prstGeom prst="line">
-              <a:avLst/>
-            </a:prstGeom>
-            <a:solidFill>
-              <a:srgbClr val="FFFFFF"/>
-            </a:solidFill>
-            <a:ln w="22225" cap="flat" cmpd="sng" algn="ctr">
-              <a:solidFill>
-                <a:srgbClr val="C00000"/>
-              </a:solidFill>
-              <a:prstDash val="solid"/>
-              <a:miter lim="800000"/>
-            </a:ln>
-            <a:effectLst/>
-          </p:spPr>
-        </p:cxnSp>
-        <p:cxnSp>
-          <p:nvCxnSpPr>
-            <p:cNvPr id="295" name="直接连接符 132">
-              <a:extLst>
-                <a:ext uri="{FF2B5EF4-FFF2-40B4-BE49-F238E27FC236}">
-                  <a16:creationId xmlns:a16="http://schemas.microsoft.com/office/drawing/2014/main" id="{FB0374A5-A0FE-4778-BABD-30E9BE35CE23}"/>
-                </a:ext>
-              </a:extLst>
-            </p:cNvPr>
-            <p:cNvCxnSpPr/>
-            <p:nvPr/>
-          </p:nvCxnSpPr>
-          <p:spPr>
-            <a:xfrm flipH="1">
-              <a:off x="2360159" y="1643545"/>
-              <a:ext cx="668" cy="781632"/>
+              <a:off x="7119872" y="1407121"/>
+              <a:ext cx="1" cy="669194"/>
             </a:xfrm>
             <a:prstGeom prst="line">
               <a:avLst/>
@@ -6738,8 +5626,8 @@
           </p:nvCxnSpPr>
           <p:spPr>
             <a:xfrm flipH="1">
-              <a:off x="2360826" y="5892869"/>
-              <a:ext cx="1" cy="781632"/>
+              <a:off x="2360827" y="5045179"/>
+              <a:ext cx="1" cy="669194"/>
             </a:xfrm>
             <a:prstGeom prst="line">
               <a:avLst/>
@@ -6771,8 +5659,8 @@
           </p:nvCxnSpPr>
           <p:spPr>
             <a:xfrm flipH="1">
-              <a:off x="7119642" y="5905090"/>
-              <a:ext cx="1" cy="781632"/>
+              <a:off x="7119644" y="5055642"/>
+              <a:ext cx="1" cy="669194"/>
             </a:xfrm>
             <a:prstGeom prst="line">
               <a:avLst/>
@@ -7058,7 +5946,7 @@
         </p:nvSpPr>
         <p:spPr>
           <a:xfrm>
-            <a:off x="510415" y="1058630"/>
+            <a:off x="510415" y="1038923"/>
             <a:ext cx="4002854" cy="276999"/>
           </a:xfrm>
           <a:prstGeom prst="rect">
@@ -7285,7 +6173,7 @@
                 <a:latin typeface="微软雅黑" panose="020B0503020204020204" pitchFamily="34" charset="-122"/>
                 <a:ea typeface="微软雅黑" panose="020B0503020204020204" pitchFamily="34" charset="-122"/>
               </a:rPr>
-              <a:t>；通过减小</a:t>
+              <a:t>，大</a:t>
             </a:r>
             <a:r>
               <a:rPr lang="en-US" altLang="zh-CN" sz="1399" b="1" kern="0" dirty="0">
@@ -7305,7 +6193,7 @@
                 <a:latin typeface="微软雅黑" panose="020B0503020204020204" pitchFamily="34" charset="-122"/>
                 <a:ea typeface="微软雅黑" panose="020B0503020204020204" pitchFamily="34" charset="-122"/>
               </a:rPr>
-              <a:t>缓解负载不均</a:t>
+              <a:t>受限于负载不均</a:t>
             </a:r>
             <a:endParaRPr lang="en-US" altLang="zh-CN" sz="1399" b="1" kern="0" dirty="0">
               <a:solidFill>
@@ -7604,124 +6492,6 @@
       </p:grpSp>
       <p:sp>
         <p:nvSpPr>
-          <p:cNvPr id="37" name="pie-legend">
-            <a:extLst>
-              <a:ext uri="{FF2B5EF4-FFF2-40B4-BE49-F238E27FC236}">
-                <a16:creationId xmlns:a16="http://schemas.microsoft.com/office/drawing/2014/main" id="{4FA41C38-24E8-4C85-A05E-A244668AE097}"/>
-              </a:ext>
-            </a:extLst>
-          </p:cNvPr>
-          <p:cNvSpPr txBox="1"/>
-          <p:nvPr/>
-        </p:nvSpPr>
-        <p:spPr>
-          <a:xfrm>
-            <a:off x="2831559" y="2486010"/>
-            <a:ext cx="2082800" cy="190500"/>
-          </a:xfrm>
-          <a:prstGeom prst="rect">
-            <a:avLst/>
-          </a:prstGeom>
-          <a:noFill/>
-          <a:ln>
-            <a:noFill/>
-          </a:ln>
-        </p:spPr>
-        <p:txBody>
-          <a:bodyPr wrap="none" lIns="0" tIns="0" rIns="0" bIns="0" rtlCol="0" anchor="ctr"/>
-          <a:lstStyle/>
-          <a:p>
-            <a:pPr algn="r">
-              <a:lnSpc>
-                <a:spcPct val="120000"/>
-              </a:lnSpc>
-            </a:pPr>
-            <a:r>
-              <a:rPr lang="en-US" sz="750" noProof="1">
-                <a:solidFill>
-                  <a:srgbClr val="4C78A8"/>
-                </a:solidFill>
-                <a:latin typeface="微软雅黑"/>
-                <a:ea typeface="微软雅黑"/>
-              </a:rPr>
-              <a:t>■ </a:t>
-            </a:r>
-            <a:r>
-              <a:rPr lang="en-US" sz="750" b="1" noProof="1">
-                <a:solidFill>
-                  <a:srgbClr val="4C78A8"/>
-                </a:solidFill>
-                <a:latin typeface="微软雅黑"/>
-                <a:ea typeface="微软雅黑"/>
-              </a:rPr>
-              <a:t>计算</a:t>
-            </a:r>
-            <a:r>
-              <a:rPr lang="en-US" sz="750" b="1" noProof="1">
-                <a:solidFill>
-                  <a:srgbClr val="262626"/>
-                </a:solidFill>
-                <a:latin typeface="微软雅黑"/>
-                <a:ea typeface="微软雅黑"/>
-              </a:rPr>
-              <a:t> </a:t>
-            </a:r>
-            <a:r>
-              <a:rPr lang="en-US" sz="750" b="1" noProof="1">
-                <a:solidFill>
-                  <a:srgbClr val="F2A93B"/>
-                </a:solidFill>
-                <a:latin typeface="微软雅黑"/>
-                <a:ea typeface="微软雅黑"/>
-              </a:rPr>
-              <a:t>■ 访存</a:t>
-            </a:r>
-            <a:r>
-              <a:rPr lang="en-US" sz="750" b="1" noProof="1">
-                <a:solidFill>
-                  <a:srgbClr val="262626"/>
-                </a:solidFill>
-                <a:latin typeface="微软雅黑"/>
-                <a:ea typeface="微软雅黑"/>
-              </a:rPr>
-              <a:t> </a:t>
-            </a:r>
-            <a:r>
-              <a:rPr lang="en-US" sz="750" b="1" noProof="1">
-                <a:solidFill>
-                  <a:srgbClr val="E45756"/>
-                </a:solidFill>
-                <a:latin typeface="微软雅黑"/>
-                <a:ea typeface="微软雅黑"/>
-              </a:rPr>
-              <a:t>■ 通信</a:t>
-            </a:r>
-            <a:r>
-              <a:rPr lang="en-US" sz="750" b="1" noProof="1">
-                <a:solidFill>
-                  <a:srgbClr val="262626"/>
-                </a:solidFill>
-                <a:latin typeface="微软雅黑"/>
-                <a:ea typeface="微软雅黑"/>
-              </a:rPr>
-              <a:t> </a:t>
-            </a:r>
-            <a:r>
-              <a:rPr lang="en-US" sz="750" b="1" noProof="1">
-                <a:solidFill>
-                  <a:srgbClr val="C9C9C9"/>
-                </a:solidFill>
-                <a:latin typeface="微软雅黑"/>
-                <a:ea typeface="微软雅黑"/>
-              </a:rPr>
-              <a:t>■ 其他</a:t>
-            </a:r>
-            <a:endParaRPr lang="en-US" sz="750" b="1" noProof="1"/>
-          </a:p>
-        </p:txBody>
-      </p:sp>
-      <p:sp>
-        <p:nvSpPr>
           <p:cNvPr id="38" name="pie-title-p-attn">
             <a:extLst>
               <a:ext uri="{FF2B5EF4-FFF2-40B4-BE49-F238E27FC236}">
@@ -7734,7 +6504,7 @@
         </p:nvSpPr>
         <p:spPr>
           <a:xfrm>
-            <a:off x="-246060" y="2722792"/>
+            <a:off x="-269069" y="2518097"/>
             <a:ext cx="2717800" cy="165100"/>
           </a:xfrm>
           <a:prstGeom prst="rect">
@@ -7768,725 +6538,6 @@
           </a:p>
         </p:txBody>
       </p:sp>
-      <p:graphicFrame>
-        <p:nvGraphicFramePr>
-          <p:cNvPr id="39" name="pie-p-attn">
-            <a:extLst>
-              <a:ext uri="{FF2B5EF4-FFF2-40B4-BE49-F238E27FC236}">
-                <a16:creationId xmlns:a16="http://schemas.microsoft.com/office/drawing/2014/main" id="{502D24D4-EFC5-48A4-B6DC-437547264C2C}"/>
-              </a:ext>
-            </a:extLst>
-          </p:cNvPr>
-          <p:cNvGraphicFramePr/>
-          <p:nvPr>
-            <p:extLst>
-              <p:ext uri="{D42A27DB-BD31-4B8C-83A1-F6EECF244321}">
-                <p14:modId xmlns:p14="http://schemas.microsoft.com/office/powerpoint/2010/main" val="4176776378"/>
-              </p:ext>
-            </p:extLst>
-          </p:nvPr>
-        </p:nvGraphicFramePr>
-        <p:xfrm>
-          <a:off x="113759" y="2661692"/>
-          <a:ext cx="1651000" cy="1778000"/>
-        </p:xfrm>
-        <a:graphic>
-          <a:graphicData uri="http://schemas.openxmlformats.org/drawingml/2006/chart">
-            <c:chart xmlns:c="http://schemas.openxmlformats.org/drawingml/2006/chart" xmlns:r="http://schemas.openxmlformats.org/officeDocument/2006/relationships" r:id="rId3"/>
-          </a:graphicData>
-        </a:graphic>
-      </p:graphicFrame>
-      <p:sp>
-        <p:nvSpPr>
-          <p:cNvPr id="40" name="pie-p-attn-legend">
-            <a:extLst>
-              <a:ext uri="{FF2B5EF4-FFF2-40B4-BE49-F238E27FC236}">
-                <a16:creationId xmlns:a16="http://schemas.microsoft.com/office/drawing/2014/main" id="{264E29C4-BC73-4488-A1CB-08F3036202D3}"/>
-              </a:ext>
-            </a:extLst>
-          </p:cNvPr>
-          <p:cNvSpPr txBox="1"/>
-          <p:nvPr/>
-        </p:nvSpPr>
-        <p:spPr>
-          <a:xfrm>
-            <a:off x="1688559" y="2712492"/>
-            <a:ext cx="1143000" cy="1676400"/>
-          </a:xfrm>
-          <a:prstGeom prst="rect">
-            <a:avLst/>
-          </a:prstGeom>
-          <a:noFill/>
-          <a:ln>
-            <a:noFill/>
-          </a:ln>
-        </p:spPr>
-        <p:txBody>
-          <a:bodyPr wrap="square" lIns="0" tIns="0" rIns="0" bIns="0" rtlCol="0" anchor="ctr"/>
-          <a:lstStyle/>
-          <a:p>
-            <a:pPr algn="l">
-              <a:lnSpc>
-                <a:spcPct val="180000"/>
-              </a:lnSpc>
-            </a:pPr>
-            <a:r>
-              <a:rPr lang="en-US" sz="600" noProof="1">
-                <a:solidFill>
-                  <a:srgbClr val="4C78A8"/>
-                </a:solidFill>
-                <a:latin typeface="微软雅黑"/>
-                <a:ea typeface="微软雅黑"/>
-              </a:rPr>
-              <a:t>■</a:t>
-            </a:r>
-            <a:r>
-              <a:rPr lang="en-US" sz="600" noProof="1">
-                <a:solidFill>
-                  <a:srgbClr val="262626"/>
-                </a:solidFill>
-                <a:latin typeface="微软雅黑"/>
-                <a:ea typeface="微软雅黑"/>
-              </a:rPr>
-              <a:t> ChunkKdaFwd</a:t>
-            </a:r>
-            <a:endParaRPr lang="en-US" sz="600" noProof="1"/>
-          </a:p>
-          <a:p>
-            <a:pPr algn="l">
-              <a:lnSpc>
-                <a:spcPct val="180000"/>
-              </a:lnSpc>
-            </a:pPr>
-            <a:r>
-              <a:rPr lang="en-US" sz="600" noProof="1">
-                <a:solidFill>
-                  <a:srgbClr val="F2A93B"/>
-                </a:solidFill>
-                <a:latin typeface="微软雅黑"/>
-                <a:ea typeface="微软雅黑"/>
-              </a:rPr>
-              <a:t>■</a:t>
-            </a:r>
-            <a:r>
-              <a:rPr lang="en-US" sz="600" noProof="1">
-                <a:solidFill>
-                  <a:srgbClr val="262626"/>
-                </a:solidFill>
-                <a:latin typeface="微软雅黑"/>
-                <a:ea typeface="微软雅黑"/>
-              </a:rPr>
-              <a:t> FL</a:t>
-            </a:r>
-            <a:r>
-              <a:rPr lang="en-US" altLang="zh-CN" sz="600" noProof="1">
-                <a:solidFill>
-                  <a:srgbClr val="262626"/>
-                </a:solidFill>
-                <a:latin typeface="微软雅黑"/>
-                <a:ea typeface="微软雅黑"/>
-              </a:rPr>
-              <a:t>ashMlaWithKvcache</a:t>
-            </a:r>
-            <a:endParaRPr lang="en-US" sz="600" noProof="1"/>
-          </a:p>
-          <a:p>
-            <a:pPr algn="l">
-              <a:lnSpc>
-                <a:spcPct val="180000"/>
-              </a:lnSpc>
-            </a:pPr>
-            <a:r>
-              <a:rPr lang="en-US" sz="600" noProof="1">
-                <a:solidFill>
-                  <a:srgbClr val="C9C9C9"/>
-                </a:solidFill>
-                <a:latin typeface="微软雅黑"/>
-                <a:ea typeface="微软雅黑"/>
-              </a:rPr>
-              <a:t>■</a:t>
-            </a:r>
-            <a:r>
-              <a:rPr lang="en-US" sz="600" noProof="1">
-                <a:solidFill>
-                  <a:srgbClr val="262626"/>
-                </a:solidFill>
-                <a:latin typeface="微软雅黑"/>
-                <a:ea typeface="微软雅黑"/>
-              </a:rPr>
-              <a:t> 其他</a:t>
-            </a:r>
-            <a:endParaRPr lang="en-US" sz="600" noProof="1"/>
-          </a:p>
-        </p:txBody>
-      </p:sp>
-      <p:sp>
-        <p:nvSpPr>
-          <p:cNvPr id="41" name="pie-title-p-moe">
-            <a:extLst>
-              <a:ext uri="{FF2B5EF4-FFF2-40B4-BE49-F238E27FC236}">
-                <a16:creationId xmlns:a16="http://schemas.microsoft.com/office/drawing/2014/main" id="{B7ECFC09-0B01-42DF-B84B-43669633CD51}"/>
-              </a:ext>
-            </a:extLst>
-          </p:cNvPr>
-          <p:cNvSpPr txBox="1"/>
-          <p:nvPr/>
-        </p:nvSpPr>
-        <p:spPr>
-          <a:xfrm>
-            <a:off x="1988400" y="2746376"/>
-            <a:ext cx="2717800" cy="165100"/>
-          </a:xfrm>
-          <a:prstGeom prst="rect">
-            <a:avLst/>
-          </a:prstGeom>
-          <a:noFill/>
-          <a:ln>
-            <a:noFill/>
-          </a:ln>
-        </p:spPr>
-        <p:txBody>
-          <a:bodyPr wrap="none" lIns="0" tIns="0" rIns="0" bIns="0" rtlCol="0" anchor="ctr"/>
-          <a:lstStyle/>
-          <a:p>
-            <a:pPr algn="ctr">
-              <a:lnSpc>
-                <a:spcPct val="120000"/>
-              </a:lnSpc>
-            </a:pPr>
-            <a:r>
-              <a:rPr lang="en-US" sz="900" b="1" noProof="1">
-                <a:solidFill>
-                  <a:srgbClr val="262626"/>
-                </a:solidFill>
-                <a:latin typeface="微软雅黑"/>
-                <a:ea typeface="微软雅黑"/>
-              </a:rPr>
-              <a:t>P · MoE（50.6%）</a:t>
-            </a:r>
-            <a:endParaRPr lang="en-US" sz="900" noProof="1"/>
-          </a:p>
-        </p:txBody>
-      </p:sp>
-      <p:graphicFrame>
-        <p:nvGraphicFramePr>
-          <p:cNvPr id="42" name="pie-p-moe">
-            <a:extLst>
-              <a:ext uri="{FF2B5EF4-FFF2-40B4-BE49-F238E27FC236}">
-                <a16:creationId xmlns:a16="http://schemas.microsoft.com/office/drawing/2014/main" id="{C8208E48-489F-456B-A4EA-B4348866E9D8}"/>
-              </a:ext>
-            </a:extLst>
-          </p:cNvPr>
-          <p:cNvGraphicFramePr/>
-          <p:nvPr>
-            <p:extLst>
-              <p:ext uri="{D42A27DB-BD31-4B8C-83A1-F6EECF244321}">
-                <p14:modId xmlns:p14="http://schemas.microsoft.com/office/powerpoint/2010/main" val="392254908"/>
-              </p:ext>
-            </p:extLst>
-          </p:nvPr>
-        </p:nvGraphicFramePr>
-        <p:xfrm>
-          <a:off x="2397727" y="2661692"/>
-          <a:ext cx="1651000" cy="1778000"/>
-        </p:xfrm>
-        <a:graphic>
-          <a:graphicData uri="http://schemas.openxmlformats.org/drawingml/2006/chart">
-            <c:chart xmlns:c="http://schemas.openxmlformats.org/drawingml/2006/chart" xmlns:r="http://schemas.openxmlformats.org/officeDocument/2006/relationships" r:id="rId4"/>
-          </a:graphicData>
-        </a:graphic>
-      </p:graphicFrame>
-      <p:sp>
-        <p:nvSpPr>
-          <p:cNvPr id="43" name="pie-p-moe-legend">
-            <a:extLst>
-              <a:ext uri="{FF2B5EF4-FFF2-40B4-BE49-F238E27FC236}">
-                <a16:creationId xmlns:a16="http://schemas.microsoft.com/office/drawing/2014/main" id="{2AF4EA27-E81E-4B0A-A212-793F266DCE6A}"/>
-              </a:ext>
-            </a:extLst>
-          </p:cNvPr>
-          <p:cNvSpPr txBox="1"/>
-          <p:nvPr/>
-        </p:nvSpPr>
-        <p:spPr>
-          <a:xfrm>
-            <a:off x="3922014" y="2697563"/>
-            <a:ext cx="1143000" cy="1676400"/>
-          </a:xfrm>
-          <a:prstGeom prst="rect">
-            <a:avLst/>
-          </a:prstGeom>
-          <a:noFill/>
-          <a:ln>
-            <a:noFill/>
-          </a:ln>
-        </p:spPr>
-        <p:txBody>
-          <a:bodyPr wrap="square" lIns="0" tIns="0" rIns="0" bIns="0" rtlCol="0" anchor="ctr"/>
-          <a:lstStyle/>
-          <a:p>
-            <a:pPr algn="l">
-              <a:lnSpc>
-                <a:spcPct val="180000"/>
-              </a:lnSpc>
-            </a:pPr>
-            <a:r>
-              <a:rPr lang="en-US" sz="600" noProof="1">
-                <a:solidFill>
-                  <a:srgbClr val="4C78A8"/>
-                </a:solidFill>
-                <a:latin typeface="微软雅黑"/>
-                <a:ea typeface="微软雅黑"/>
-              </a:rPr>
-              <a:t>■</a:t>
-            </a:r>
-            <a:r>
-              <a:rPr lang="en-US" sz="600" noProof="1">
-                <a:solidFill>
-                  <a:srgbClr val="262626"/>
-                </a:solidFill>
-                <a:latin typeface="微软雅黑"/>
-                <a:ea typeface="微软雅黑"/>
-              </a:rPr>
-              <a:t> GroupedMatmul</a:t>
-            </a:r>
-            <a:endParaRPr lang="en-US" sz="600" noProof="1"/>
-          </a:p>
-          <a:p>
-            <a:pPr algn="l">
-              <a:lnSpc>
-                <a:spcPct val="180000"/>
-              </a:lnSpc>
-            </a:pPr>
-            <a:r>
-              <a:rPr lang="en-US" sz="600" noProof="1">
-                <a:solidFill>
-                  <a:srgbClr val="4C78A8"/>
-                </a:solidFill>
-                <a:latin typeface="微软雅黑"/>
-                <a:ea typeface="微软雅黑"/>
-              </a:rPr>
-              <a:t>■</a:t>
-            </a:r>
-            <a:r>
-              <a:rPr lang="en-US" sz="600" noProof="1">
-                <a:solidFill>
-                  <a:srgbClr val="262626"/>
-                </a:solidFill>
-                <a:latin typeface="微软雅黑"/>
-                <a:ea typeface="微软雅黑"/>
-              </a:rPr>
-              <a:t> QuantBatchMatmulV3</a:t>
-            </a:r>
-            <a:endParaRPr lang="en-US" sz="600" noProof="1"/>
-          </a:p>
-          <a:p>
-            <a:pPr algn="l">
-              <a:lnSpc>
-                <a:spcPct val="180000"/>
-              </a:lnSpc>
-            </a:pPr>
-            <a:r>
-              <a:rPr lang="en-US" sz="600" noProof="1">
-                <a:solidFill>
-                  <a:srgbClr val="F2A93B"/>
-                </a:solidFill>
-                <a:latin typeface="微软雅黑"/>
-                <a:ea typeface="微软雅黑"/>
-              </a:rPr>
-              <a:t>■</a:t>
-            </a:r>
-            <a:r>
-              <a:rPr lang="en-US" sz="600" noProof="1">
-                <a:solidFill>
-                  <a:srgbClr val="262626"/>
-                </a:solidFill>
-                <a:latin typeface="微软雅黑"/>
-                <a:ea typeface="微软雅黑"/>
-              </a:rPr>
-              <a:t> DequantSituQuant</a:t>
-            </a:r>
-            <a:endParaRPr lang="en-US" sz="600" noProof="1"/>
-          </a:p>
-          <a:p>
-            <a:pPr algn="l">
-              <a:lnSpc>
-                <a:spcPct val="180000"/>
-              </a:lnSpc>
-            </a:pPr>
-            <a:r>
-              <a:rPr lang="en-US" sz="600" noProof="1">
-                <a:solidFill>
-                  <a:srgbClr val="F2A93B"/>
-                </a:solidFill>
-                <a:latin typeface="微软雅黑"/>
-                <a:ea typeface="微软雅黑"/>
-              </a:rPr>
-              <a:t>■</a:t>
-            </a:r>
-            <a:r>
-              <a:rPr lang="en-US" sz="600" noProof="1">
-                <a:solidFill>
-                  <a:srgbClr val="262626"/>
-                </a:solidFill>
-                <a:latin typeface="微软雅黑"/>
-                <a:ea typeface="微软雅黑"/>
-              </a:rPr>
-              <a:t> DynamicQuant</a:t>
-            </a:r>
-            <a:endParaRPr lang="en-US" sz="600" noProof="1"/>
-          </a:p>
-          <a:p>
-            <a:pPr algn="l">
-              <a:lnSpc>
-                <a:spcPct val="180000"/>
-              </a:lnSpc>
-            </a:pPr>
-            <a:r>
-              <a:rPr lang="en-US" sz="600" noProof="1">
-                <a:solidFill>
-                  <a:srgbClr val="C9C9C9"/>
-                </a:solidFill>
-                <a:latin typeface="微软雅黑"/>
-                <a:ea typeface="微软雅黑"/>
-              </a:rPr>
-              <a:t>■</a:t>
-            </a:r>
-            <a:r>
-              <a:rPr lang="en-US" sz="600" noProof="1">
-                <a:solidFill>
-                  <a:srgbClr val="262626"/>
-                </a:solidFill>
-                <a:latin typeface="微软雅黑"/>
-                <a:ea typeface="微软雅黑"/>
-              </a:rPr>
-              <a:t> 其他</a:t>
-            </a:r>
-            <a:endParaRPr lang="en-US" sz="600" noProof="1"/>
-          </a:p>
-        </p:txBody>
-      </p:sp>
-      <p:sp>
-        <p:nvSpPr>
-          <p:cNvPr id="44" name="pie-title-d-attn">
-            <a:extLst>
-              <a:ext uri="{FF2B5EF4-FFF2-40B4-BE49-F238E27FC236}">
-                <a16:creationId xmlns:a16="http://schemas.microsoft.com/office/drawing/2014/main" id="{EF42CF0D-2FCD-4F0D-9C00-E72CA5BF31EF}"/>
-              </a:ext>
-            </a:extLst>
-          </p:cNvPr>
-          <p:cNvSpPr txBox="1"/>
-          <p:nvPr/>
-        </p:nvSpPr>
-        <p:spPr>
-          <a:xfrm>
-            <a:off x="-344992" y="4213093"/>
-            <a:ext cx="2717800" cy="165100"/>
-          </a:xfrm>
-          <a:prstGeom prst="rect">
-            <a:avLst/>
-          </a:prstGeom>
-          <a:noFill/>
-          <a:ln>
-            <a:noFill/>
-          </a:ln>
-        </p:spPr>
-        <p:txBody>
-          <a:bodyPr wrap="none" lIns="0" tIns="0" rIns="0" bIns="0" rtlCol="0" anchor="ctr"/>
-          <a:lstStyle/>
-          <a:p>
-            <a:pPr algn="ctr">
-              <a:lnSpc>
-                <a:spcPct val="120000"/>
-              </a:lnSpc>
-            </a:pPr>
-            <a:r>
-              <a:rPr lang="en-US" sz="900" b="1" noProof="1">
-                <a:solidFill>
-                  <a:srgbClr val="262626"/>
-                </a:solidFill>
-                <a:latin typeface="微软雅黑"/>
-                <a:ea typeface="微软雅黑"/>
-              </a:rPr>
-              <a:t>D · Attention（20.0%）</a:t>
-            </a:r>
-            <a:endParaRPr lang="en-US" sz="900" noProof="1"/>
-          </a:p>
-        </p:txBody>
-      </p:sp>
-      <p:graphicFrame>
-        <p:nvGraphicFramePr>
-          <p:cNvPr id="45" name="pie-d-attn">
-            <a:extLst>
-              <a:ext uri="{FF2B5EF4-FFF2-40B4-BE49-F238E27FC236}">
-                <a16:creationId xmlns:a16="http://schemas.microsoft.com/office/drawing/2014/main" id="{AEB62C04-3C2E-4F2A-A273-A01DB5E61E7C}"/>
-              </a:ext>
-            </a:extLst>
-          </p:cNvPr>
-          <p:cNvGraphicFramePr/>
-          <p:nvPr>
-            <p:extLst>
-              <p:ext uri="{D42A27DB-BD31-4B8C-83A1-F6EECF244321}">
-                <p14:modId xmlns:p14="http://schemas.microsoft.com/office/powerpoint/2010/main" val="2607117937"/>
-              </p:ext>
-            </p:extLst>
-          </p:nvPr>
-        </p:nvGraphicFramePr>
-        <p:xfrm>
-          <a:off x="97516" y="4104622"/>
-          <a:ext cx="1651000" cy="1778000"/>
-        </p:xfrm>
-        <a:graphic>
-          <a:graphicData uri="http://schemas.openxmlformats.org/drawingml/2006/chart">
-            <c:chart xmlns:c="http://schemas.openxmlformats.org/drawingml/2006/chart" xmlns:r="http://schemas.openxmlformats.org/officeDocument/2006/relationships" r:id="rId5"/>
-          </a:graphicData>
-        </a:graphic>
-      </p:graphicFrame>
-      <p:sp>
-        <p:nvSpPr>
-          <p:cNvPr id="46" name="pie-d-attn-legend">
-            <a:extLst>
-              <a:ext uri="{FF2B5EF4-FFF2-40B4-BE49-F238E27FC236}">
-                <a16:creationId xmlns:a16="http://schemas.microsoft.com/office/drawing/2014/main" id="{035972B3-38DB-449F-B53E-5EE1945D9064}"/>
-              </a:ext>
-            </a:extLst>
-          </p:cNvPr>
-          <p:cNvSpPr txBox="1"/>
-          <p:nvPr/>
-        </p:nvSpPr>
-        <p:spPr>
-          <a:xfrm>
-            <a:off x="1672316" y="4155422"/>
-            <a:ext cx="1143000" cy="1676400"/>
-          </a:xfrm>
-          <a:prstGeom prst="rect">
-            <a:avLst/>
-          </a:prstGeom>
-          <a:noFill/>
-          <a:ln>
-            <a:noFill/>
-          </a:ln>
-        </p:spPr>
-        <p:txBody>
-          <a:bodyPr wrap="square" lIns="0" tIns="0" rIns="0" bIns="0" rtlCol="0" anchor="ctr"/>
-          <a:lstStyle/>
-          <a:p>
-            <a:pPr>
-              <a:lnSpc>
-                <a:spcPct val="180000"/>
-              </a:lnSpc>
-            </a:pPr>
-            <a:r>
-              <a:rPr lang="en-US" sz="600" noProof="1">
-                <a:solidFill>
-                  <a:srgbClr val="F2A93B"/>
-                </a:solidFill>
-                <a:latin typeface="微软雅黑"/>
-                <a:ea typeface="微软雅黑"/>
-              </a:rPr>
-              <a:t>■</a:t>
-            </a:r>
-            <a:r>
-              <a:rPr lang="en-US" sz="600" noProof="1">
-                <a:solidFill>
-                  <a:srgbClr val="262626"/>
-                </a:solidFill>
-                <a:latin typeface="微软雅黑"/>
-                <a:ea typeface="微软雅黑"/>
-              </a:rPr>
-              <a:t> AttnResFwdFu</a:t>
-            </a:r>
-          </a:p>
-          <a:p>
-            <a:pPr>
-              <a:lnSpc>
-                <a:spcPct val="180000"/>
-              </a:lnSpc>
-            </a:pPr>
-            <a:r>
-              <a:rPr lang="en-US" altLang="zh-CN" sz="600" noProof="1">
-                <a:solidFill>
-                  <a:srgbClr val="F2A93B"/>
-                </a:solidFill>
-                <a:latin typeface="微软雅黑"/>
-                <a:ea typeface="微软雅黑"/>
-              </a:rPr>
-              <a:t>■</a:t>
-            </a:r>
-            <a:r>
-              <a:rPr lang="en-US" altLang="zh-CN" sz="600" noProof="1">
-                <a:solidFill>
-                  <a:srgbClr val="262626"/>
-                </a:solidFill>
-                <a:latin typeface="微软雅黑"/>
-                <a:ea typeface="微软雅黑"/>
-              </a:rPr>
-              <a:t> FlashMlaWithKvcache</a:t>
-            </a:r>
-            <a:endParaRPr lang="en-US" sz="600" noProof="1"/>
-          </a:p>
-          <a:p>
-            <a:pPr algn="l">
-              <a:lnSpc>
-                <a:spcPct val="180000"/>
-              </a:lnSpc>
-            </a:pPr>
-            <a:r>
-              <a:rPr lang="en-US" sz="600" noProof="1">
-                <a:solidFill>
-                  <a:srgbClr val="F2A93B"/>
-                </a:solidFill>
-                <a:latin typeface="微软雅黑"/>
-                <a:ea typeface="微软雅黑"/>
-              </a:rPr>
-              <a:t>■</a:t>
-            </a:r>
-            <a:r>
-              <a:rPr lang="en-US" sz="600" noProof="1">
-                <a:solidFill>
-                  <a:srgbClr val="262626"/>
-                </a:solidFill>
-                <a:latin typeface="微软雅黑"/>
-                <a:ea typeface="微软雅黑"/>
-              </a:rPr>
-              <a:t> MlaPrologV3</a:t>
-            </a:r>
-            <a:endParaRPr lang="en-US" sz="600" noProof="1"/>
-          </a:p>
-          <a:p>
-            <a:pPr algn="l">
-              <a:lnSpc>
-                <a:spcPct val="180000"/>
-              </a:lnSpc>
-            </a:pPr>
-            <a:r>
-              <a:rPr lang="en-US" sz="600" noProof="1">
-                <a:solidFill>
-                  <a:srgbClr val="4C78A8"/>
-                </a:solidFill>
-                <a:latin typeface="微软雅黑"/>
-                <a:ea typeface="微软雅黑"/>
-              </a:rPr>
-              <a:t>■</a:t>
-            </a:r>
-            <a:r>
-              <a:rPr lang="en-US" sz="600" noProof="1">
-                <a:solidFill>
-                  <a:srgbClr val="262626"/>
-                </a:solidFill>
-                <a:latin typeface="微软雅黑"/>
-                <a:ea typeface="微软雅黑"/>
-              </a:rPr>
-              <a:t> RecurrentKda</a:t>
-            </a:r>
-            <a:endParaRPr lang="en-US" sz="600" noProof="1"/>
-          </a:p>
-          <a:p>
-            <a:pPr algn="l">
-              <a:lnSpc>
-                <a:spcPct val="180000"/>
-              </a:lnSpc>
-            </a:pPr>
-            <a:r>
-              <a:rPr lang="en-US" sz="600" noProof="1">
-                <a:solidFill>
-                  <a:srgbClr val="C9C9C9"/>
-                </a:solidFill>
-                <a:latin typeface="微软雅黑"/>
-                <a:ea typeface="微软雅黑"/>
-              </a:rPr>
-              <a:t>■</a:t>
-            </a:r>
-            <a:r>
-              <a:rPr lang="en-US" sz="600" noProof="1">
-                <a:solidFill>
-                  <a:srgbClr val="262626"/>
-                </a:solidFill>
-                <a:latin typeface="微软雅黑"/>
-                <a:ea typeface="微软雅黑"/>
-              </a:rPr>
-              <a:t> 其他</a:t>
-            </a:r>
-            <a:endParaRPr lang="en-US" sz="600" noProof="1"/>
-          </a:p>
-        </p:txBody>
-      </p:sp>
-      <p:sp>
-        <p:nvSpPr>
-          <p:cNvPr id="47" name="pie-title-d-moe">
-            <a:extLst>
-              <a:ext uri="{FF2B5EF4-FFF2-40B4-BE49-F238E27FC236}">
-                <a16:creationId xmlns:a16="http://schemas.microsoft.com/office/drawing/2014/main" id="{EF0DD825-8B2D-4152-A1D5-040CC4233478}"/>
-              </a:ext>
-            </a:extLst>
-          </p:cNvPr>
-          <p:cNvSpPr txBox="1"/>
-          <p:nvPr/>
-        </p:nvSpPr>
-        <p:spPr>
-          <a:xfrm>
-            <a:off x="1926276" y="4206997"/>
-            <a:ext cx="2717800" cy="165100"/>
-          </a:xfrm>
-          <a:prstGeom prst="rect">
-            <a:avLst/>
-          </a:prstGeom>
-          <a:noFill/>
-          <a:ln>
-            <a:noFill/>
-          </a:ln>
-        </p:spPr>
-        <p:txBody>
-          <a:bodyPr wrap="none" lIns="0" tIns="0" rIns="0" bIns="0" rtlCol="0" anchor="ctr"/>
-          <a:lstStyle/>
-          <a:p>
-            <a:pPr algn="ctr">
-              <a:lnSpc>
-                <a:spcPct val="120000"/>
-              </a:lnSpc>
-            </a:pPr>
-            <a:r>
-              <a:rPr lang="en-US" sz="900" b="1" noProof="1">
-                <a:solidFill>
-                  <a:srgbClr val="262626"/>
-                </a:solidFill>
-                <a:latin typeface="微软雅黑"/>
-                <a:ea typeface="微软雅黑"/>
-              </a:rPr>
-              <a:t>D · MoE（47.9%）</a:t>
-            </a:r>
-            <a:endParaRPr lang="en-US" sz="900" noProof="1"/>
-          </a:p>
-        </p:txBody>
-      </p:sp>
-      <p:graphicFrame>
-        <p:nvGraphicFramePr>
-          <p:cNvPr id="48" name="pie-d-moe">
-            <a:extLst>
-              <a:ext uri="{FF2B5EF4-FFF2-40B4-BE49-F238E27FC236}">
-                <a16:creationId xmlns:a16="http://schemas.microsoft.com/office/drawing/2014/main" id="{8A414A20-0FCE-4AD9-A987-E2A751CA15EC}"/>
-              </a:ext>
-            </a:extLst>
-          </p:cNvPr>
-          <p:cNvGraphicFramePr/>
-          <p:nvPr>
-            <p:extLst>
-              <p:ext uri="{D42A27DB-BD31-4B8C-83A1-F6EECF244321}">
-                <p14:modId xmlns:p14="http://schemas.microsoft.com/office/powerpoint/2010/main" val="4014920903"/>
-              </p:ext>
-            </p:extLst>
-          </p:nvPr>
-        </p:nvGraphicFramePr>
-        <p:xfrm>
-          <a:off x="2393676" y="4104622"/>
-          <a:ext cx="1651000" cy="1778000"/>
-        </p:xfrm>
-        <a:graphic>
-          <a:graphicData uri="http://schemas.openxmlformats.org/drawingml/2006/chart">
-            <c:chart xmlns:c="http://schemas.openxmlformats.org/drawingml/2006/chart" xmlns:r="http://schemas.openxmlformats.org/officeDocument/2006/relationships" r:id="rId6"/>
-          </a:graphicData>
-        </a:graphic>
-      </p:graphicFrame>
       <p:sp>
         <p:nvSpPr>
           <p:cNvPr id="90" name="文本框 89">
@@ -8501,7 +6552,7 @@
         </p:nvSpPr>
         <p:spPr>
           <a:xfrm>
-            <a:off x="1364451" y="2333948"/>
+            <a:off x="1484651" y="2128718"/>
             <a:ext cx="2295575" cy="276999"/>
           </a:xfrm>
           <a:prstGeom prst="rect">
@@ -8564,7 +6615,7 @@
         </p:nvSpPr>
         <p:spPr>
           <a:xfrm>
-            <a:off x="335215" y="1306735"/>
+            <a:off x="328709" y="1238073"/>
             <a:ext cx="4663559" cy="930768"/>
           </a:xfrm>
           <a:prstGeom prst="rect">
@@ -8924,7 +6975,7 @@
         </p:nvSpPr>
         <p:spPr>
           <a:xfrm>
-            <a:off x="387481" y="5620310"/>
+            <a:off x="308091" y="5122183"/>
             <a:ext cx="2530292" cy="306054"/>
           </a:xfrm>
           <a:prstGeom prst="rect">
@@ -8964,204 +7015,6 @@
           </a:p>
         </p:txBody>
       </p:sp>
-      <p:sp>
-        <p:nvSpPr>
-          <p:cNvPr id="83" name="pie-d-moe-legend">
-            <a:extLst>
-              <a:ext uri="{FF2B5EF4-FFF2-40B4-BE49-F238E27FC236}">
-                <a16:creationId xmlns:a16="http://schemas.microsoft.com/office/drawing/2014/main" id="{AE64F56E-0F80-417C-ACB6-E598710E298D}"/>
-              </a:ext>
-            </a:extLst>
-          </p:cNvPr>
-          <p:cNvSpPr txBox="1"/>
-          <p:nvPr/>
-        </p:nvSpPr>
-        <p:spPr>
-          <a:xfrm>
-            <a:off x="3905771" y="4159033"/>
-            <a:ext cx="1143000" cy="1676400"/>
-          </a:xfrm>
-          <a:prstGeom prst="rect">
-            <a:avLst/>
-          </a:prstGeom>
-          <a:noFill/>
-          <a:ln>
-            <a:noFill/>
-          </a:ln>
-        </p:spPr>
-        <p:txBody>
-          <a:bodyPr wrap="square" lIns="0" tIns="0" rIns="0" bIns="0" rtlCol="0" anchor="ctr"/>
-          <a:lstStyle/>
-          <a:p>
-            <a:pPr algn="l">
-              <a:lnSpc>
-                <a:spcPct val="180000"/>
-              </a:lnSpc>
-            </a:pPr>
-            <a:r>
-              <a:rPr lang="en-US" sz="600" noProof="1">
-                <a:solidFill>
-                  <a:srgbClr val="4C78A8"/>
-                </a:solidFill>
-                <a:latin typeface="微软雅黑"/>
-                <a:ea typeface="微软雅黑"/>
-              </a:rPr>
-              <a:t>■</a:t>
-            </a:r>
-            <a:r>
-              <a:rPr lang="en-US" sz="600" noProof="1">
-                <a:solidFill>
-                  <a:srgbClr val="262626"/>
-                </a:solidFill>
-                <a:latin typeface="微软雅黑"/>
-                <a:ea typeface="微软雅黑"/>
-              </a:rPr>
-              <a:t> GroupedMatmulSituQuant</a:t>
-            </a:r>
-            <a:endParaRPr lang="en-US" sz="600" noProof="1"/>
-          </a:p>
-          <a:p>
-            <a:pPr algn="l">
-              <a:lnSpc>
-                <a:spcPct val="180000"/>
-              </a:lnSpc>
-            </a:pPr>
-            <a:r>
-              <a:rPr lang="en-US" sz="600" noProof="1">
-                <a:solidFill>
-                  <a:srgbClr val="4C78A8"/>
-                </a:solidFill>
-                <a:latin typeface="微软雅黑"/>
-                <a:ea typeface="微软雅黑"/>
-              </a:rPr>
-              <a:t>■</a:t>
-            </a:r>
-            <a:r>
-              <a:rPr lang="en-US" sz="600" noProof="1">
-                <a:solidFill>
-                  <a:srgbClr val="262626"/>
-                </a:solidFill>
-                <a:latin typeface="微软雅黑"/>
-                <a:ea typeface="微软雅黑"/>
-              </a:rPr>
-              <a:t> GroupedMatmul</a:t>
-            </a:r>
-            <a:endParaRPr lang="en-US" sz="600" noProof="1"/>
-          </a:p>
-          <a:p>
-            <a:pPr algn="l">
-              <a:lnSpc>
-                <a:spcPct val="180000"/>
-              </a:lnSpc>
-            </a:pPr>
-            <a:r>
-              <a:rPr lang="en-US" sz="600" noProof="1">
-                <a:solidFill>
-                  <a:srgbClr val="4C78A8"/>
-                </a:solidFill>
-                <a:latin typeface="微软雅黑"/>
-                <a:ea typeface="微软雅黑"/>
-              </a:rPr>
-              <a:t>■</a:t>
-            </a:r>
-            <a:r>
-              <a:rPr lang="en-US" sz="600" noProof="1">
-                <a:solidFill>
-                  <a:srgbClr val="262626"/>
-                </a:solidFill>
-                <a:latin typeface="微软雅黑"/>
-                <a:ea typeface="微软雅黑"/>
-              </a:rPr>
-              <a:t> QuantBatchMatmulV4</a:t>
-            </a:r>
-            <a:endParaRPr lang="en-US" sz="600" noProof="1"/>
-          </a:p>
-          <a:p>
-            <a:pPr algn="l">
-              <a:lnSpc>
-                <a:spcPct val="180000"/>
-              </a:lnSpc>
-            </a:pPr>
-            <a:r>
-              <a:rPr lang="en-US" sz="600" noProof="1">
-                <a:solidFill>
-                  <a:srgbClr val="4C78A8"/>
-                </a:solidFill>
-                <a:latin typeface="微软雅黑"/>
-                <a:ea typeface="微软雅黑"/>
-              </a:rPr>
-              <a:t>■</a:t>
-            </a:r>
-            <a:r>
-              <a:rPr lang="en-US" sz="600" noProof="1">
-                <a:solidFill>
-                  <a:srgbClr val="262626"/>
-                </a:solidFill>
-                <a:latin typeface="微软雅黑"/>
-                <a:ea typeface="微软雅黑"/>
-              </a:rPr>
-              <a:t> QuantBatchMatmulV3</a:t>
-            </a:r>
-            <a:endParaRPr lang="en-US" sz="600" noProof="1"/>
-          </a:p>
-          <a:p>
-            <a:pPr algn="l">
-              <a:lnSpc>
-                <a:spcPct val="180000"/>
-              </a:lnSpc>
-            </a:pPr>
-            <a:r>
-              <a:rPr lang="en-US" sz="600" noProof="1">
-                <a:solidFill>
-                  <a:srgbClr val="E45756"/>
-                </a:solidFill>
-                <a:latin typeface="微软雅黑"/>
-                <a:ea typeface="微软雅黑"/>
-              </a:rPr>
-              <a:t>■</a:t>
-            </a:r>
-            <a:r>
-              <a:rPr lang="en-US" sz="600" noProof="1">
-                <a:solidFill>
-                  <a:srgbClr val="262626"/>
-                </a:solidFill>
-                <a:latin typeface="微软雅黑"/>
-                <a:ea typeface="微软雅黑"/>
-              </a:rPr>
-              <a:t> Dispatch/Combine</a:t>
-            </a:r>
-            <a:endParaRPr lang="en-US" sz="600" noProof="1"/>
-          </a:p>
-          <a:p>
-            <a:pPr algn="l">
-              <a:lnSpc>
-                <a:spcPct val="180000"/>
-              </a:lnSpc>
-            </a:pPr>
-            <a:r>
-              <a:rPr lang="en-US" sz="600" noProof="1">
-                <a:solidFill>
-                  <a:srgbClr val="C9C9C9"/>
-                </a:solidFill>
-                <a:latin typeface="微软雅黑"/>
-                <a:ea typeface="微软雅黑"/>
-              </a:rPr>
-              <a:t>■</a:t>
-            </a:r>
-            <a:r>
-              <a:rPr lang="en-US" sz="600" noProof="1">
-                <a:solidFill>
-                  <a:srgbClr val="262626"/>
-                </a:solidFill>
-                <a:latin typeface="微软雅黑"/>
-                <a:ea typeface="微软雅黑"/>
-              </a:rPr>
-              <a:t> 其他</a:t>
-            </a:r>
-            <a:endParaRPr lang="en-US" sz="600" noProof="1"/>
-          </a:p>
-        </p:txBody>
-      </p:sp>
       <p:grpSp>
         <p:nvGrpSpPr>
           <p:cNvPr id="85" name="组合 84">
@@ -9176,8 +7029,8 @@
         </p:nvGrpSpPr>
         <p:grpSpPr>
           <a:xfrm>
-            <a:off x="5213470" y="1196652"/>
-            <a:ext cx="6748118" cy="2587250"/>
+            <a:off x="5268482" y="1196652"/>
+            <a:ext cx="6693105" cy="2564509"/>
             <a:chOff x="2359219" y="1643545"/>
             <a:chExt cx="4765479" cy="5043177"/>
           </a:xfrm>
@@ -9575,8 +7428,8 @@
         </p:nvSpPr>
         <p:spPr>
           <a:xfrm>
-            <a:off x="412530" y="5862818"/>
-            <a:ext cx="4489942" cy="766620"/>
+            <a:off x="721023" y="5144969"/>
+            <a:ext cx="4320562" cy="1515543"/>
           </a:xfrm>
           <a:prstGeom prst="rect">
             <a:avLst/>
@@ -9607,7 +7460,7 @@
                 <a:latin typeface="微软雅黑" panose="020B0503020204020204" pitchFamily="34" charset="-122"/>
                 <a:ea typeface="微软雅黑" panose="020B0503020204020204" pitchFamily="34" charset="-122"/>
               </a:rPr>
-              <a:t>Attention </a:t>
+              <a:t>P</a:t>
             </a:r>
             <a:r>
               <a:rPr lang="zh-CN" altLang="en-US" sz="1000" b="1" noProof="1">
@@ -9617,7 +7470,7 @@
                 <a:latin typeface="微软雅黑" panose="020B0503020204020204" pitchFamily="34" charset="-122"/>
                 <a:ea typeface="微软雅黑" panose="020B0503020204020204" pitchFamily="34" charset="-122"/>
               </a:rPr>
-              <a:t>算子</a:t>
+              <a:t>阶段</a:t>
             </a:r>
             <a:r>
               <a:rPr lang="en-US" altLang="zh-CN" sz="1000" b="1" noProof="1">
@@ -9627,17 +7480,27 @@
                 <a:latin typeface="微软雅黑" panose="020B0503020204020204" pitchFamily="34" charset="-122"/>
                 <a:ea typeface="微软雅黑" panose="020B0503020204020204" pitchFamily="34" charset="-122"/>
               </a:rPr>
-              <a:t>高度集中</a:t>
-            </a:r>
-            <a:r>
-              <a:rPr lang="en-US" altLang="zh-CN" sz="1000" noProof="1">
+              <a:t>:</a:t>
+            </a:r>
+            <a:r>
+              <a:rPr lang="zh-CN" altLang="en-US" sz="1000" noProof="1">
                 <a:solidFill>
                   <a:srgbClr val="262626"/>
                 </a:solidFill>
                 <a:latin typeface="微软雅黑" panose="020B0503020204020204" pitchFamily="34" charset="-122"/>
                 <a:ea typeface="微软雅黑" panose="020B0503020204020204" pitchFamily="34" charset="-122"/>
               </a:rPr>
-              <a:t>：Preill 集中于 KDA </a:t>
+              <a:t> </a:t>
+            </a:r>
+            <a:r>
+              <a:rPr lang="zh-CN" altLang="en-US" sz="1000" b="1" noProof="1">
+                <a:solidFill>
+                  <a:srgbClr val="C00000"/>
+                </a:solidFill>
+                <a:latin typeface="微软雅黑" panose="020B0503020204020204" pitchFamily="34" charset="-122"/>
+                <a:ea typeface="微软雅黑" panose="020B0503020204020204" pitchFamily="34" charset="-122"/>
+              </a:rPr>
+              <a:t>通信</a:t>
             </a:r>
             <a:r>
               <a:rPr lang="zh-CN" altLang="en-US" sz="1000" noProof="1">
@@ -9647,17 +7510,34 @@
                 <a:latin typeface="微软雅黑" panose="020B0503020204020204" pitchFamily="34" charset="-122"/>
                 <a:ea typeface="微软雅黑" panose="020B0503020204020204" pitchFamily="34" charset="-122"/>
               </a:rPr>
-              <a:t>算子</a:t>
-            </a:r>
-            <a:r>
-              <a:rPr lang="en-US" altLang="zh-CN" sz="1000" noProof="1">
+              <a:t>占比较高，主要原因：</a:t>
+            </a:r>
+            <a:endParaRPr lang="en-US" altLang="zh-CN" sz="1000" noProof="1">
+              <a:solidFill>
+                <a:srgbClr val="262626"/>
+              </a:solidFill>
+              <a:latin typeface="微软雅黑" panose="020B0503020204020204" pitchFamily="34" charset="-122"/>
+              <a:ea typeface="微软雅黑" panose="020B0503020204020204" pitchFamily="34" charset="-122"/>
+            </a:endParaRPr>
+          </a:p>
+          <a:p>
+            <a:pPr marL="311400" lvl="1">
+              <a:lnSpc>
+                <a:spcPct val="140000"/>
+              </a:lnSpc>
+              <a:spcBef>
+                <a:spcPts val="400"/>
+              </a:spcBef>
+            </a:pPr>
+            <a:r>
+              <a:rPr lang="en-US" altLang="zh-CN" sz="1000" b="1" noProof="1">
                 <a:solidFill>
                   <a:srgbClr val="262626"/>
                 </a:solidFill>
                 <a:latin typeface="微软雅黑" panose="020B0503020204020204" pitchFamily="34" charset="-122"/>
                 <a:ea typeface="微软雅黑" panose="020B0503020204020204" pitchFamily="34" charset="-122"/>
               </a:rPr>
-              <a:t>，Decode </a:t>
+              <a:t>Attenton: </a:t>
             </a:r>
             <a:r>
               <a:rPr lang="zh-CN" altLang="en-US" sz="1000" noProof="1">
@@ -9667,17 +7547,17 @@
                 <a:latin typeface="微软雅黑" panose="020B0503020204020204" pitchFamily="34" charset="-122"/>
                 <a:ea typeface="微软雅黑" panose="020B0503020204020204" pitchFamily="34" charset="-122"/>
               </a:rPr>
-              <a:t>受限于长上下文计算非线性注意力，耗时主要</a:t>
-            </a:r>
-            <a:r>
-              <a:rPr lang="en-US" altLang="zh-CN" sz="1000" noProof="1">
+              <a:t>长序列无命中，计算占比高符合预期；</a:t>
+            </a:r>
+            <a:r>
+              <a:rPr lang="en-US" altLang="zh-CN" sz="1000" b="1" noProof="1">
                 <a:solidFill>
                   <a:srgbClr val="262626"/>
                 </a:solidFill>
                 <a:latin typeface="微软雅黑" panose="020B0503020204020204" pitchFamily="34" charset="-122"/>
                 <a:ea typeface="微软雅黑" panose="020B0503020204020204" pitchFamily="34" charset="-122"/>
               </a:rPr>
-              <a:t>集中</a:t>
+              <a:t>Sequnce Parallel </a:t>
             </a:r>
             <a:r>
               <a:rPr lang="zh-CN" altLang="en-US" sz="1000" noProof="1">
@@ -9687,17 +7567,37 @@
                 <a:latin typeface="微软雅黑" panose="020B0503020204020204" pitchFamily="34" charset="-122"/>
                 <a:ea typeface="微软雅黑" panose="020B0503020204020204" pitchFamily="34" charset="-122"/>
               </a:rPr>
-              <a:t>在</a:t>
-            </a:r>
-            <a:r>
-              <a:rPr lang="en-US" altLang="zh-CN" sz="1000" noProof="1">
+              <a:t>使得通信占比较高</a:t>
+            </a:r>
+            <a:r>
+              <a:rPr lang="en-US" altLang="zh-CN" sz="1000" b="1" noProof="1">
                 <a:solidFill>
                   <a:srgbClr val="262626"/>
                 </a:solidFill>
                 <a:latin typeface="微软雅黑" panose="020B0503020204020204" pitchFamily="34" charset="-122"/>
                 <a:ea typeface="微软雅黑" panose="020B0503020204020204" pitchFamily="34" charset="-122"/>
               </a:rPr>
-              <a:t> MLA </a:t>
+              <a:t> </a:t>
+            </a:r>
+            <a:r>
+              <a:rPr lang="zh-CN" altLang="en-US" sz="1000" b="1" noProof="1">
+                <a:solidFill>
+                  <a:srgbClr val="262626"/>
+                </a:solidFill>
+                <a:latin typeface="微软雅黑" panose="020B0503020204020204" pitchFamily="34" charset="-122"/>
+                <a:ea typeface="微软雅黑" panose="020B0503020204020204" pitchFamily="34" charset="-122"/>
+              </a:rPr>
+              <a:t>；</a:t>
+            </a:r>
+            <a:r>
+              <a:rPr lang="en-US" altLang="zh-CN" sz="1000" b="1" noProof="1">
+                <a:solidFill>
+                  <a:srgbClr val="262626"/>
+                </a:solidFill>
+                <a:latin typeface="微软雅黑" panose="020B0503020204020204" pitchFamily="34" charset="-122"/>
+                <a:ea typeface="微软雅黑" panose="020B0503020204020204" pitchFamily="34" charset="-122"/>
+              </a:rPr>
+              <a:t>MoE: </a:t>
             </a:r>
             <a:r>
               <a:rPr lang="zh-CN" altLang="en-US" sz="1000" noProof="1">
@@ -9707,9 +7607,12 @@
                 <a:latin typeface="微软雅黑" panose="020B0503020204020204" pitchFamily="34" charset="-122"/>
                 <a:ea typeface="微软雅黑" panose="020B0503020204020204" pitchFamily="34" charset="-122"/>
               </a:rPr>
-              <a:t>算子</a:t>
+              <a:t>长序列无命中，通信量较高</a:t>
             </a:r>
             <a:endParaRPr lang="en-US" altLang="zh-CN" sz="1000" noProof="1">
+              <a:solidFill>
+                <a:srgbClr val="262626"/>
+              </a:solidFill>
               <a:latin typeface="微软雅黑" panose="020B0503020204020204" pitchFamily="34" charset="-122"/>
               <a:ea typeface="微软雅黑" panose="020B0503020204020204" pitchFamily="34" charset="-122"/>
             </a:endParaRPr>
@@ -9733,7 +7636,7 @@
                 <a:latin typeface="微软雅黑" panose="020B0503020204020204" pitchFamily="34" charset="-122"/>
                 <a:ea typeface="微软雅黑" panose="020B0503020204020204" pitchFamily="34" charset="-122"/>
               </a:rPr>
-              <a:t>MoE </a:t>
+              <a:t>D</a:t>
             </a:r>
             <a:r>
               <a:rPr lang="zh-CN" altLang="en-US" sz="1000" b="1" noProof="1">
@@ -9743,41 +7646,168 @@
                 <a:latin typeface="微软雅黑" panose="020B0503020204020204" pitchFamily="34" charset="-122"/>
                 <a:ea typeface="微软雅黑" panose="020B0503020204020204" pitchFamily="34" charset="-122"/>
               </a:rPr>
-              <a:t>耗时</a:t>
+              <a:t>阶段：</a:t>
+            </a:r>
+            <a:r>
+              <a:rPr lang="zh-CN" altLang="en-US" sz="1000" b="1" noProof="1">
+                <a:solidFill>
+                  <a:srgbClr val="C00000"/>
+                </a:solidFill>
+                <a:latin typeface="微软雅黑" panose="020B0503020204020204" pitchFamily="34" charset="-122"/>
+                <a:ea typeface="微软雅黑" panose="020B0503020204020204" pitchFamily="34" charset="-122"/>
+              </a:rPr>
+              <a:t>计算</a:t>
             </a:r>
             <a:r>
               <a:rPr lang="en-US" altLang="zh-CN" sz="1000" b="1" noProof="1">
                 <a:solidFill>
+                  <a:srgbClr val="C00000"/>
+                </a:solidFill>
+                <a:latin typeface="微软雅黑" panose="020B0503020204020204" pitchFamily="34" charset="-122"/>
+                <a:ea typeface="微软雅黑" panose="020B0503020204020204" pitchFamily="34" charset="-122"/>
+              </a:rPr>
+              <a:t>/</a:t>
+            </a:r>
+            <a:r>
+              <a:rPr lang="zh-CN" altLang="en-US" sz="1000" b="1" noProof="1">
+                <a:solidFill>
+                  <a:srgbClr val="C00000"/>
+                </a:solidFill>
+                <a:latin typeface="微软雅黑" panose="020B0503020204020204" pitchFamily="34" charset="-122"/>
+                <a:ea typeface="微软雅黑" panose="020B0503020204020204" pitchFamily="34" charset="-122"/>
+              </a:rPr>
+              <a:t>访存</a:t>
+            </a:r>
+            <a:r>
+              <a:rPr lang="zh-CN" altLang="en-US" sz="1000" noProof="1">
+                <a:solidFill>
                   <a:srgbClr val="262626"/>
                 </a:solidFill>
                 <a:latin typeface="微软雅黑" panose="020B0503020204020204" pitchFamily="34" charset="-122"/>
                 <a:ea typeface="微软雅黑" panose="020B0503020204020204" pitchFamily="34" charset="-122"/>
               </a:rPr>
-              <a:t>以矩阵乘 + 量化为主</a:t>
-            </a:r>
-            <a:r>
-              <a:rPr lang="en-US" altLang="zh-CN" sz="1000" noProof="1">
-                <a:solidFill>
-                  <a:srgbClr val="262626"/>
-                </a:solidFill>
-                <a:latin typeface="微软雅黑" panose="020B0503020204020204" pitchFamily="34" charset="-122"/>
-                <a:ea typeface="微软雅黑" panose="020B0503020204020204" pitchFamily="34" charset="-122"/>
-              </a:rPr>
-              <a:t>：</a:t>
-            </a:r>
-            <a:r>
-              <a:rPr lang="zh-CN" altLang="en-US" sz="1000" noProof="1">
-                <a:solidFill>
-                  <a:srgbClr val="262626"/>
-                </a:solidFill>
-                <a:latin typeface="微软雅黑" panose="020B0503020204020204" pitchFamily="34" charset="-122"/>
-                <a:ea typeface="微软雅黑" panose="020B0503020204020204" pitchFamily="34" charset="-122"/>
-              </a:rPr>
-              <a:t>计算，访存占比都较高</a:t>
+              <a:t>占比较高，主要原因：</a:t>
             </a:r>
             <a:endParaRPr lang="en-US" altLang="zh-CN" sz="1000" noProof="1">
               <a:solidFill>
-                <a:srgbClr val="0F1115"/>
+                <a:srgbClr val="262626"/>
+              </a:solidFill>
+              <a:latin typeface="微软雅黑" panose="020B0503020204020204" pitchFamily="34" charset="-122"/>
+              <a:ea typeface="微软雅黑" panose="020B0503020204020204" pitchFamily="34" charset="-122"/>
+            </a:endParaRPr>
+          </a:p>
+          <a:p>
+            <a:pPr marL="311400" lvl="1">
+              <a:lnSpc>
+                <a:spcPct val="140000"/>
+              </a:lnSpc>
+              <a:spcBef>
+                <a:spcPts val="400"/>
+              </a:spcBef>
+            </a:pPr>
+            <a:r>
+              <a:rPr lang="en-US" altLang="zh-CN" sz="1000" b="1" noProof="1">
+                <a:solidFill>
+                  <a:srgbClr val="262626"/>
+                </a:solidFill>
+                <a:latin typeface="微软雅黑" panose="020B0503020204020204" pitchFamily="34" charset="-122"/>
+                <a:ea typeface="微软雅黑" panose="020B0503020204020204" pitchFamily="34" charset="-122"/>
+              </a:rPr>
+              <a:t>Attention</a:t>
+            </a:r>
+            <a:r>
+              <a:rPr lang="zh-CN" altLang="en-US" sz="1000" b="1" noProof="1">
+                <a:solidFill>
+                  <a:srgbClr val="262626"/>
+                </a:solidFill>
+                <a:latin typeface="微软雅黑" panose="020B0503020204020204" pitchFamily="34" charset="-122"/>
+                <a:ea typeface="微软雅黑" panose="020B0503020204020204" pitchFamily="34" charset="-122"/>
+              </a:rPr>
+              <a:t>：</a:t>
+            </a:r>
+            <a:r>
+              <a:rPr lang="zh-CN" altLang="en-US" sz="1000" noProof="1">
+                <a:solidFill>
+                  <a:srgbClr val="262626"/>
+                </a:solidFill>
+                <a:latin typeface="微软雅黑" panose="020B0503020204020204" pitchFamily="34" charset="-122"/>
+                <a:ea typeface="微软雅黑" panose="020B0503020204020204" pitchFamily="34" charset="-122"/>
+              </a:rPr>
+              <a:t>高吞吐</a:t>
+            </a:r>
+            <a:r>
+              <a:rPr lang="zh-CN" altLang="en-US" sz="1000" b="1" noProof="1">
+                <a:solidFill>
+                  <a:srgbClr val="262626"/>
+                </a:solidFill>
+                <a:latin typeface="微软雅黑" panose="020B0503020204020204" pitchFamily="34" charset="-122"/>
+                <a:ea typeface="微软雅黑" panose="020B0503020204020204" pitchFamily="34" charset="-122"/>
+              </a:rPr>
+              <a:t>大并发</a:t>
+            </a:r>
+            <a:r>
+              <a:rPr lang="zh-CN" altLang="en-US" sz="1000" noProof="1">
+                <a:solidFill>
+                  <a:srgbClr val="262626"/>
+                </a:solidFill>
+                <a:latin typeface="微软雅黑" panose="020B0503020204020204" pitchFamily="34" charset="-122"/>
+                <a:ea typeface="微软雅黑" panose="020B0503020204020204" pitchFamily="34" charset="-122"/>
+              </a:rPr>
+              <a:t>场景，计算占比高符合预期；</a:t>
+            </a:r>
+            <a:r>
+              <a:rPr lang="en-US" altLang="zh-CN" sz="1000" b="1" noProof="1">
+                <a:solidFill>
+                  <a:srgbClr val="262626"/>
+                </a:solidFill>
+                <a:latin typeface="微软雅黑" panose="020B0503020204020204" pitchFamily="34" charset="-122"/>
+                <a:ea typeface="微软雅黑" panose="020B0503020204020204" pitchFamily="34" charset="-122"/>
+              </a:rPr>
+              <a:t>DCP</a:t>
+            </a:r>
+            <a:r>
+              <a:rPr lang="en-US" altLang="zh-CN" sz="1000" noProof="1">
+                <a:solidFill>
+                  <a:srgbClr val="262626"/>
+                </a:solidFill>
+                <a:latin typeface="微软雅黑" panose="020B0503020204020204" pitchFamily="34" charset="-122"/>
+                <a:ea typeface="微软雅黑" panose="020B0503020204020204" pitchFamily="34" charset="-122"/>
+              </a:rPr>
+              <a:t> allGather KV </a:t>
+            </a:r>
+            <a:r>
+              <a:rPr lang="zh-CN" altLang="en-US" sz="1000" noProof="1">
+                <a:solidFill>
+                  <a:srgbClr val="262626"/>
+                </a:solidFill>
+                <a:latin typeface="微软雅黑" panose="020B0503020204020204" pitchFamily="34" charset="-122"/>
+                <a:ea typeface="微软雅黑" panose="020B0503020204020204" pitchFamily="34" charset="-122"/>
+              </a:rPr>
+              <a:t>导致通信量较高；</a:t>
+            </a:r>
+            <a:r>
+              <a:rPr lang="en-US" altLang="zh-CN" sz="1000" b="1" noProof="1">
+                <a:solidFill>
+                  <a:srgbClr val="262626"/>
+                </a:solidFill>
+                <a:latin typeface="微软雅黑" panose="020B0503020204020204" pitchFamily="34" charset="-122"/>
+                <a:ea typeface="微软雅黑" panose="020B0503020204020204" pitchFamily="34" charset="-122"/>
+              </a:rPr>
+              <a:t>MoE: </a:t>
+            </a:r>
+            <a:r>
+              <a:rPr lang="zh-CN" altLang="en-US" sz="1000" noProof="1">
+                <a:solidFill>
+                  <a:srgbClr val="262626"/>
+                </a:solidFill>
+                <a:latin typeface="微软雅黑" panose="020B0503020204020204" pitchFamily="34" charset="-122"/>
+                <a:ea typeface="微软雅黑" panose="020B0503020204020204" pitchFamily="34" charset="-122"/>
+              </a:rPr>
+              <a:t>权重搬运导致访存占比高</a:t>
+            </a:r>
+            <a:endParaRPr lang="en-US" altLang="zh-CN" sz="1000" noProof="1">
+              <a:solidFill>
+                <a:srgbClr val="262626"/>
               </a:solidFill>
               <a:latin typeface="微软雅黑" panose="020B0503020204020204" pitchFamily="34" charset="-122"/>
               <a:ea typeface="微软雅黑" panose="020B0503020204020204" pitchFamily="34" charset="-122"/>
@@ -9854,7 +7884,7 @@
           <p:nvPr>
             <p:extLst>
               <p:ext uri="{D42A27DB-BD31-4B8C-83A1-F6EECF244321}">
-                <p14:modId xmlns:p14="http://schemas.microsoft.com/office/powerpoint/2010/main" val="412562222"/>
+                <p14:modId xmlns:p14="http://schemas.microsoft.com/office/powerpoint/2010/main" val="2832926647"/>
               </p:ext>
             </p:extLst>
           </p:nvPr>
@@ -9868,21 +7898,21 @@
             <a:tbl>
               <a:tblPr/>
               <a:tblGrid>
-                <a:gridCol w="972156">
+                <a:gridCol w="1098918">
                   <a:extLst>
                     <a:ext uri="{9D8B030D-6E8A-4147-A177-3AD203B41FA5}">
                       <a16:colId xmlns:a16="http://schemas.microsoft.com/office/drawing/2014/main" val="20000"/>
                     </a:ext>
                   </a:extLst>
                 </a:gridCol>
-                <a:gridCol w="1820392">
+                <a:gridCol w="1562100">
                   <a:extLst>
                     <a:ext uri="{9D8B030D-6E8A-4147-A177-3AD203B41FA5}">
                       <a16:colId xmlns:a16="http://schemas.microsoft.com/office/drawing/2014/main" val="20001"/>
                     </a:ext>
                   </a:extLst>
                 </a:gridCol>
-                <a:gridCol w="1541458">
+                <a:gridCol w="1672988">
                   <a:extLst>
                     <a:ext uri="{9D8B030D-6E8A-4147-A177-3AD203B41FA5}">
                       <a16:colId xmlns:a16="http://schemas.microsoft.com/office/drawing/2014/main" val="20002"/>
@@ -9958,8 +7988,25 @@
                           <a:latin typeface="微软雅黑" panose="020B0503020204020204" pitchFamily="34" charset="-122"/>
                           <a:ea typeface="微软雅黑" panose="020B0503020204020204" pitchFamily="34" charset="-122"/>
                         </a:rPr>
-                        <a:t>Attention（us / 占比）</a:t>
+                        <a:t>Attention </a:t>
                       </a:r>
+                      <a:r>
+                        <a:rPr lang="en-US" altLang="zh-CN" sz="1000" b="1" noProof="1">
+                          <a:solidFill>
+                            <a:srgbClr val="262626"/>
+                          </a:solidFill>
+                          <a:latin typeface="微软雅黑" panose="020B0503020204020204" pitchFamily="34" charset="-122"/>
+                          <a:ea typeface="微软雅黑" panose="020B0503020204020204" pitchFamily="34" charset="-122"/>
+                        </a:rPr>
+                        <a:t>占比</a:t>
+                      </a:r>
+                      <a:endParaRPr lang="en-US" sz="1000" b="1" noProof="1">
+                        <a:solidFill>
+                          <a:srgbClr val="262626"/>
+                        </a:solidFill>
+                        <a:latin typeface="微软雅黑" panose="020B0503020204020204" pitchFamily="34" charset="-122"/>
+                        <a:ea typeface="微软雅黑" panose="020B0503020204020204" pitchFamily="34" charset="-122"/>
+                      </a:endParaRPr>
                     </a:p>
                   </a:txBody>
                   <a:tcPr anchor="ctr">
@@ -10000,7 +8047,7 @@
                           <a:latin typeface="微软雅黑" panose="020B0503020204020204" pitchFamily="34" charset="-122"/>
                           <a:ea typeface="微软雅黑" panose="020B0503020204020204" pitchFamily="34" charset="-122"/>
                         </a:rPr>
-                        <a:t>MoE（us / 占比）</a:t>
+                        <a:t>MoE 占比</a:t>
                       </a:r>
                     </a:p>
                   </a:txBody>
@@ -10037,7 +8084,7 @@
                       <a:r>
                         <a:rPr lang="en-US" sz="1000" b="1" noProof="1">
                           <a:solidFill>
-                            <a:srgbClr val="4C78A8"/>
+                            <a:srgbClr val="2563EB"/>
                           </a:solidFill>
                           <a:latin typeface="微软雅黑" panose="020B0503020204020204" pitchFamily="34" charset="-122"/>
                           <a:ea typeface="微软雅黑" panose="020B0503020204020204" pitchFamily="34" charset="-122"/>
@@ -10047,12 +8094,32 @@
                       <a:r>
                         <a:rPr lang="en-US" sz="1000" b="1" noProof="1">
                           <a:solidFill>
+                            <a:srgbClr val="4C78A8"/>
+                          </a:solidFill>
+                          <a:latin typeface="微软雅黑" panose="020B0503020204020204" pitchFamily="34" charset="-122"/>
+                          <a:ea typeface="微软雅黑" panose="020B0503020204020204" pitchFamily="34" charset="-122"/>
+                        </a:rPr>
+                        <a:t> </a:t>
+                      </a:r>
+                      <a:r>
+                        <a:rPr lang="en-US" sz="1000" b="1" noProof="1">
+                          <a:solidFill>
                             <a:srgbClr val="262626"/>
                           </a:solidFill>
                           <a:latin typeface="微软雅黑" panose="020B0503020204020204" pitchFamily="34" charset="-122"/>
                           <a:ea typeface="微软雅黑" panose="020B0503020204020204" pitchFamily="34" charset="-122"/>
                         </a:rPr>
-                        <a:t>/</a:t>
+                        <a:t>/ </a:t>
+                      </a:r>
+                      <a:r>
+                        <a:rPr lang="en-US" sz="1000" b="1" noProof="1">
+                          <a:solidFill>
+                            <a:srgbClr val="2CA0BE"/>
+                          </a:solidFill>
+                          <a:latin typeface="微软雅黑" panose="020B0503020204020204" pitchFamily="34" charset="-122"/>
+                          <a:ea typeface="微软雅黑" panose="020B0503020204020204" pitchFamily="34" charset="-122"/>
+                        </a:rPr>
+                        <a:t>访存</a:t>
                       </a:r>
                       <a:r>
                         <a:rPr lang="en-US" sz="1000" b="1" noProof="1">
@@ -10062,7 +8129,7 @@
                           <a:latin typeface="微软雅黑" panose="020B0503020204020204" pitchFamily="34" charset="-122"/>
                           <a:ea typeface="微软雅黑" panose="020B0503020204020204" pitchFamily="34" charset="-122"/>
                         </a:rPr>
-                        <a:t>访存</a:t>
+                        <a:t> </a:t>
                       </a:r>
                       <a:r>
                         <a:rPr lang="en-US" sz="1000" b="1" noProof="1">
@@ -10072,12 +8139,12 @@
                           <a:latin typeface="微软雅黑" panose="020B0503020204020204" pitchFamily="34" charset="-122"/>
                           <a:ea typeface="微软雅黑" panose="020B0503020204020204" pitchFamily="34" charset="-122"/>
                         </a:rPr>
-                        <a:t>/</a:t>
+                        <a:t>/ </a:t>
                       </a:r>
                       <a:r>
                         <a:rPr lang="en-US" sz="1000" b="1" noProof="1">
                           <a:solidFill>
-                            <a:srgbClr val="E35858"/>
+                            <a:srgbClr val="E9590F"/>
                           </a:solidFill>
                           <a:latin typeface="微软雅黑" panose="020B0503020204020204" pitchFamily="34" charset="-122"/>
                           <a:ea typeface="微软雅黑" panose="020B0503020204020204" pitchFamily="34" charset="-122"/>
@@ -10172,17 +8239,7 @@
                       <a:r>
                         <a:rPr lang="en-US" sz="1000" b="1" noProof="1">
                           <a:solidFill>
-                            <a:srgbClr val="262626"/>
-                          </a:solidFill>
-                          <a:latin typeface="微软雅黑" panose="020B0503020204020204" pitchFamily="34" charset="-122"/>
-                          <a:ea typeface="微软雅黑" panose="020B0503020204020204" pitchFamily="34" charset="-122"/>
-                        </a:rPr>
-                        <a:t>2,005,161 / </a:t>
-                      </a:r>
-                      <a:r>
-                        <a:rPr lang="en-US" sz="1000" b="1" noProof="1">
-                          <a:solidFill>
-                            <a:srgbClr val="C00203"/>
+                            <a:schemeClr val="tx1"/>
                           </a:solidFill>
                           <a:latin typeface="微软雅黑" panose="020B0503020204020204" pitchFamily="34" charset="-122"/>
                           <a:ea typeface="微软雅黑" panose="020B0503020204020204" pitchFamily="34" charset="-122"/>
@@ -10225,16 +8282,6 @@
                           <a:spcPct val="125000"/>
                         </a:lnSpc>
                       </a:pPr>
-                      <a:r>
-                        <a:rPr lang="en-US" sz="1000" b="1" noProof="1">
-                          <a:solidFill>
-                            <a:srgbClr val="262626"/>
-                          </a:solidFill>
-                          <a:latin typeface="微软雅黑" panose="020B0503020204020204" pitchFamily="34" charset="-122"/>
-                          <a:ea typeface="微软雅黑" panose="020B0503020204020204" pitchFamily="34" charset="-122"/>
-                        </a:rPr>
-                        <a:t>4,043,506 / </a:t>
-                      </a:r>
                       <a:r>
                         <a:rPr lang="en-US" sz="1000" b="1" noProof="1">
                           <a:solidFill>
@@ -10377,17 +8424,7 @@
                       <a:r>
                         <a:rPr lang="en-US" sz="1000" b="1" noProof="1">
                           <a:solidFill>
-                            <a:srgbClr val="262626"/>
-                          </a:solidFill>
-                          <a:latin typeface="微软雅黑" panose="020B0503020204020204" pitchFamily="34" charset="-122"/>
-                          <a:ea typeface="微软雅黑" panose="020B0503020204020204" pitchFamily="34" charset="-122"/>
-                        </a:rPr>
-                        <a:t>483,203 / </a:t>
-                      </a:r>
-                      <a:r>
-                        <a:rPr lang="en-US" sz="1000" b="1" noProof="1">
-                          <a:solidFill>
-                            <a:srgbClr val="C00203"/>
+                            <a:schemeClr val="tx1"/>
                           </a:solidFill>
                           <a:latin typeface="微软雅黑" panose="020B0503020204020204" pitchFamily="34" charset="-122"/>
                           <a:ea typeface="微软雅黑" panose="020B0503020204020204" pitchFamily="34" charset="-122"/>
@@ -10430,16 +8467,6 @@
                           <a:spcPct val="125000"/>
                         </a:lnSpc>
                       </a:pPr>
-                      <a:r>
-                        <a:rPr lang="en-US" sz="1000" b="1" noProof="1">
-                          <a:solidFill>
-                            <a:srgbClr val="262626"/>
-                          </a:solidFill>
-                          <a:latin typeface="微软雅黑" panose="020B0503020204020204" pitchFamily="34" charset="-122"/>
-                          <a:ea typeface="微软雅黑" panose="020B0503020204020204" pitchFamily="34" charset="-122"/>
-                        </a:rPr>
-                        <a:t>1,159,345 / </a:t>
-                      </a:r>
                       <a:r>
                         <a:rPr lang="en-US" sz="1000" b="1" noProof="1">
                           <a:solidFill>
@@ -10547,7 +8574,7 @@
             <a:avLst/>
           </a:prstGeom>
           <a:solidFill>
-            <a:srgbClr val="4C78A8"/>
+            <a:srgbClr val="2764EB"/>
           </a:solidFill>
           <a:ln w="12700">
             <a:solidFill>
@@ -10584,7 +8611,7 @@
             <a:avLst/>
           </a:prstGeom>
           <a:solidFill>
-            <a:srgbClr val="F2A93B"/>
+            <a:srgbClr val="0A91B3"/>
           </a:solidFill>
           <a:ln w="12700">
             <a:solidFill>
@@ -10621,7 +8648,7 @@
             <a:avLst/>
           </a:prstGeom>
           <a:solidFill>
-            <a:srgbClr val="E45756"/>
+            <a:srgbClr val="EA580D"/>
           </a:solidFill>
           <a:ln w="12700">
             <a:solidFill>
@@ -10674,7 +8701,7 @@
             <a:r>
               <a:rPr lang="en-US" sz="650" b="1" noProof="1">
                 <a:solidFill>
-                  <a:srgbClr val="4C78A8"/>
+                  <a:srgbClr val="2764EB"/>
                 </a:solidFill>
                 <a:latin typeface="微软雅黑"/>
                 <a:ea typeface="微软雅黑"/>
@@ -10694,7 +8721,7 @@
             <a:r>
               <a:rPr lang="en-US" sz="650" b="1" noProof="1">
                 <a:solidFill>
-                  <a:srgbClr val="F2A93B"/>
+                  <a:srgbClr val="0A91B3"/>
                 </a:solidFill>
                 <a:latin typeface="微软雅黑"/>
                 <a:ea typeface="微软雅黑"/>
@@ -10714,7 +8741,7 @@
             <a:r>
               <a:rPr lang="en-US" sz="650" b="1" noProof="1">
                 <a:solidFill>
-                  <a:srgbClr val="E45756"/>
+                  <a:srgbClr val="EA580D"/>
                 </a:solidFill>
                 <a:latin typeface="微软雅黑"/>
                 <a:ea typeface="微软雅黑"/>
@@ -10756,7 +8783,7 @@
             <a:avLst/>
           </a:prstGeom>
           <a:solidFill>
-            <a:srgbClr val="4C78A8"/>
+            <a:srgbClr val="2764EB"/>
           </a:solidFill>
           <a:ln w="12700">
             <a:solidFill>
@@ -10764,6 +8791,13 @@
             </a:solidFill>
           </a:ln>
         </p:spPr>
+        <p:txBody>
+          <a:bodyPr/>
+          <a:lstStyle/>
+          <a:p>
+            <a:endParaRPr lang="zh-CN" altLang="en-US"/>
+          </a:p>
+        </p:txBody>
       </p:sp>
       <p:sp>
         <p:nvSpPr>
@@ -10786,7 +8820,7 @@
             <a:avLst/>
           </a:prstGeom>
           <a:solidFill>
-            <a:srgbClr val="F2A93B"/>
+            <a:srgbClr val="0A91B3"/>
           </a:solidFill>
           <a:ln w="12700">
             <a:solidFill>
@@ -10794,6 +8828,13 @@
             </a:solidFill>
           </a:ln>
         </p:spPr>
+        <p:txBody>
+          <a:bodyPr/>
+          <a:lstStyle/>
+          <a:p>
+            <a:endParaRPr lang="zh-CN" altLang="en-US"/>
+          </a:p>
+        </p:txBody>
       </p:sp>
       <p:sp>
         <p:nvSpPr>
@@ -10816,7 +8857,7 @@
             <a:avLst/>
           </a:prstGeom>
           <a:solidFill>
-            <a:srgbClr val="E45756"/>
+            <a:srgbClr val="EA580D"/>
           </a:solidFill>
           <a:ln w="12700">
             <a:solidFill>
@@ -10869,7 +8910,7 @@
             <a:r>
               <a:rPr lang="en-US" sz="650" b="1" noProof="1">
                 <a:solidFill>
-                  <a:srgbClr val="4C78A8"/>
+                  <a:srgbClr val="2764EB"/>
                 </a:solidFill>
                 <a:latin typeface="微软雅黑"/>
                 <a:ea typeface="微软雅黑"/>
@@ -10889,12 +8930,12 @@
             <a:r>
               <a:rPr lang="en-US" sz="650" b="1" noProof="1">
                 <a:solidFill>
-                  <a:srgbClr val="F2A93B"/>
+                  <a:srgbClr val="0A91B3"/>
                 </a:solidFill>
                 <a:latin typeface="微软雅黑"/>
                 <a:ea typeface="微软雅黑"/>
               </a:rPr>
-              <a:t>47.4</a:t>
+              <a:t>47.4 </a:t>
             </a:r>
             <a:r>
               <a:rPr lang="en-US" sz="650" b="1" noProof="1">
@@ -10904,12 +8945,12 @@
                 <a:latin typeface="微软雅黑"/>
                 <a:ea typeface="微软雅黑"/>
               </a:rPr>
-              <a:t> / </a:t>
+              <a:t>/ </a:t>
             </a:r>
             <a:r>
               <a:rPr lang="en-US" sz="650" b="1" noProof="1">
                 <a:solidFill>
-                  <a:srgbClr val="E45756"/>
+                  <a:srgbClr val="EA580D"/>
                 </a:solidFill>
                 <a:latin typeface="微软雅黑"/>
                 <a:ea typeface="微软雅黑"/>
@@ -10944,8 +8985,8 @@
         </p:nvGrpSpPr>
         <p:grpSpPr>
           <a:xfrm>
-            <a:off x="5216597" y="3975100"/>
-            <a:ext cx="6737716" cy="2692390"/>
+            <a:off x="5270739" y="3975100"/>
+            <a:ext cx="6683573" cy="2692390"/>
             <a:chOff x="2359219" y="1643545"/>
             <a:chExt cx="4765479" cy="5043177"/>
           </a:xfrm>
@@ -11334,7 +9375,7 @@
           <p:nvPr/>
         </p:nvPicPr>
         <p:blipFill>
-          <a:blip r:embed="rId7"/>
+          <a:blip r:embed="rId3"/>
           <a:stretch>
             <a:fillRect/>
           </a:stretch>
@@ -11519,21 +9560,71 @@
             <a:r>
               <a:rPr lang="en-US" altLang="zh-CN" sz="1000" b="1" noProof="1">
                 <a:solidFill>
+                  <a:srgbClr val="C00000"/>
+                </a:solidFill>
+                <a:latin typeface="微软雅黑" panose="020B0503020204020204" pitchFamily="34" charset="-122"/>
+                <a:ea typeface="微软雅黑" panose="020B0503020204020204" pitchFamily="34" charset="-122"/>
+              </a:rPr>
+              <a:t>EP128</a:t>
+            </a:r>
+            <a:r>
+              <a:rPr lang="en-US" altLang="zh-CN" sz="1000" noProof="1">
+                <a:solidFill>
                   <a:srgbClr val="0F1115"/>
                 </a:solidFill>
                 <a:latin typeface="微软雅黑" panose="020B0503020204020204" pitchFamily="34" charset="-122"/>
                 <a:ea typeface="微软雅黑" panose="020B0503020204020204" pitchFamily="34" charset="-122"/>
               </a:rPr>
-              <a:t>EP128</a:t>
-            </a:r>
-            <a:r>
-              <a:rPr lang="en-US" altLang="zh-CN" sz="1000" noProof="1">
+              <a:t> </a:t>
+            </a:r>
+            <a:r>
+              <a:rPr lang="zh-CN" altLang="en-US" sz="1000" noProof="1">
                 <a:solidFill>
                   <a:srgbClr val="0F1115"/>
                 </a:solidFill>
                 <a:latin typeface="微软雅黑" panose="020B0503020204020204" pitchFamily="34" charset="-122"/>
                 <a:ea typeface="微软雅黑" panose="020B0503020204020204" pitchFamily="34" charset="-122"/>
               </a:rPr>
+              <a:t>部署出现严重 </a:t>
+            </a:r>
+            <a:r>
+              <a:rPr lang="zh-CN" altLang="en-US" sz="1000" b="1" noProof="1">
+                <a:solidFill>
+                  <a:srgbClr val="C00000"/>
+                </a:solidFill>
+                <a:latin typeface="微软雅黑" panose="020B0503020204020204" pitchFamily="34" charset="-122"/>
+                <a:ea typeface="微软雅黑" panose="020B0503020204020204" pitchFamily="34" charset="-122"/>
+              </a:rPr>
+              <a:t>负载不均</a:t>
+            </a:r>
+            <a:r>
+              <a:rPr lang="zh-CN" altLang="en-US" sz="1000" noProof="1">
+                <a:solidFill>
+                  <a:srgbClr val="0F1115"/>
+                </a:solidFill>
+                <a:latin typeface="微软雅黑" panose="020B0503020204020204" pitchFamily="34" charset="-122"/>
+                <a:ea typeface="微软雅黑" panose="020B0503020204020204" pitchFamily="34" charset="-122"/>
+              </a:rPr>
+              <a:t>，</a:t>
+            </a:r>
+            <a:r>
+              <a:rPr lang="en-US" altLang="zh-CN" sz="1050" b="1" noProof="1">
+                <a:solidFill>
+                  <a:srgbClr val="0F1115"/>
+                </a:solidFill>
+                <a:latin typeface="微软雅黑" panose="020B0503020204020204" pitchFamily="34" charset="-122"/>
+                <a:ea typeface="微软雅黑" panose="020B0503020204020204" pitchFamily="34" charset="-122"/>
+              </a:rPr>
+              <a:t> EP32</a:t>
+            </a:r>
+            <a:r>
+              <a:rPr lang="zh-CN" altLang="en-US" sz="1000" b="1" noProof="1">
+                <a:solidFill>
+                  <a:srgbClr val="0F1115"/>
+                </a:solidFill>
+                <a:latin typeface="微软雅黑" panose="020B0503020204020204" pitchFamily="34" charset="-122"/>
+                <a:ea typeface="微软雅黑" panose="020B0503020204020204" pitchFamily="34" charset="-122"/>
+              </a:rPr>
               <a:t> </a:t>
             </a:r>
             <a:r>
@@ -11544,47 +9635,7 @@
                 <a:latin typeface="微软雅黑" panose="020B0503020204020204" pitchFamily="34" charset="-122"/>
                 <a:ea typeface="微软雅黑" panose="020B0503020204020204" pitchFamily="34" charset="-122"/>
               </a:rPr>
-              <a:t>大</a:t>
-            </a:r>
-            <a:r>
-              <a:rPr lang="en-US" altLang="zh-CN" sz="1000" noProof="1">
-                <a:solidFill>
-                  <a:srgbClr val="0F1115"/>
-                </a:solidFill>
-                <a:latin typeface="微软雅黑" panose="020B0503020204020204" pitchFamily="34" charset="-122"/>
-                <a:ea typeface="微软雅黑" panose="020B0503020204020204" pitchFamily="34" charset="-122"/>
-              </a:rPr>
-              <a:t>EP</a:t>
-            </a:r>
-            <a:r>
-              <a:rPr lang="zh-CN" altLang="en-US" sz="1000" noProof="1">
-                <a:solidFill>
-                  <a:srgbClr val="0F1115"/>
-                </a:solidFill>
-                <a:latin typeface="微软雅黑" panose="020B0503020204020204" pitchFamily="34" charset="-122"/>
-                <a:ea typeface="微软雅黑" panose="020B0503020204020204" pitchFamily="34" charset="-122"/>
-              </a:rPr>
-              <a:t>部署出现负载不均，</a:t>
-            </a:r>
-            <a:r>
-              <a:rPr lang="en-US" altLang="zh-CN" sz="1050" b="1" noProof="1">
-                <a:solidFill>
-                  <a:srgbClr val="0F1115"/>
-                </a:solidFill>
-                <a:latin typeface="微软雅黑" panose="020B0503020204020204" pitchFamily="34" charset="-122"/>
-                <a:ea typeface="微软雅黑" panose="020B0503020204020204" pitchFamily="34" charset="-122"/>
-              </a:rPr>
-              <a:t> EP32</a:t>
-            </a:r>
-            <a:r>
-              <a:rPr lang="zh-CN" altLang="en-US" sz="1000" noProof="1">
-                <a:solidFill>
-                  <a:srgbClr val="0F1115"/>
-                </a:solidFill>
-                <a:latin typeface="微软雅黑" panose="020B0503020204020204" pitchFamily="34" charset="-122"/>
-                <a:ea typeface="微软雅黑" panose="020B0503020204020204" pitchFamily="34" charset="-122"/>
-              </a:rPr>
-              <a:t>，整体负载较为均衡</a:t>
+              <a:t>整体负载较为均衡</a:t>
             </a:r>
             <a:endParaRPr lang="en-US" altLang="zh-CN" sz="1000" noProof="1">
               <a:solidFill>
@@ -11695,15 +9746,13 @@
           </a:bodyPr>
           <a:lstStyle/>
           <a:p>
-            <a:pPr marL="228600" indent="-228600">
+            <a:pPr>
               <a:lnSpc>
                 <a:spcPct val="140000"/>
               </a:lnSpc>
               <a:spcBef>
                 <a:spcPts val="10"/>
               </a:spcBef>
-              <a:buFont typeface="+mj-lt"/>
-              <a:buAutoNum type="arabicPeriod"/>
             </a:pPr>
             <a:r>
               <a:rPr lang="zh-CN" altLang="en-US" sz="1000" noProof="1">
@@ -11763,7 +9812,7 @@
                 <a:latin typeface="微软雅黑" panose="020B0503020204020204" pitchFamily="34" charset="-122"/>
                 <a:ea typeface="微软雅黑" panose="020B0503020204020204" pitchFamily="34" charset="-122"/>
               </a:rPr>
-              <a:t>都仅占</a:t>
+              <a:t>占比接近</a:t>
             </a:r>
             <a:r>
               <a:rPr lang="en-US" altLang="zh-CN" sz="1000" b="1" noProof="1">
@@ -11773,7 +9822,7 @@
                 <a:latin typeface="微软雅黑" panose="020B0503020204020204" pitchFamily="34" charset="-122"/>
                 <a:ea typeface="微软雅黑" panose="020B0503020204020204" pitchFamily="34" charset="-122"/>
               </a:rPr>
-              <a:t>~20%</a:t>
+              <a:t> 20%</a:t>
             </a:r>
             <a:r>
               <a:rPr lang="zh-CN" altLang="en-US" sz="1000" noProof="1">
@@ -11863,7 +9912,7 @@
                 <a:latin typeface="微软雅黑" panose="020B0503020204020204" pitchFamily="34" charset="-122"/>
                 <a:ea typeface="微软雅黑" panose="020B0503020204020204" pitchFamily="34" charset="-122"/>
               </a:rPr>
-              <a:t>接近 </a:t>
+              <a:t>都接近 </a:t>
             </a:r>
             <a:r>
               <a:rPr lang="en-US" altLang="zh-CN" sz="1000" b="1" noProof="1">
@@ -11874,16 +9923,6 @@
                 <a:ea typeface="微软雅黑" panose="020B0503020204020204" pitchFamily="34" charset="-122"/>
               </a:rPr>
               <a:t>50%</a:t>
-            </a:r>
-            <a:r>
-              <a:rPr lang="zh-CN" altLang="en-US" sz="1000" noProof="1">
-                <a:solidFill>
-                  <a:srgbClr val="0F1115"/>
-                </a:solidFill>
-                <a:latin typeface="微软雅黑" panose="020B0503020204020204" pitchFamily="34" charset="-122"/>
-                <a:ea typeface="微软雅黑" panose="020B0503020204020204" pitchFamily="34" charset="-122"/>
-              </a:rPr>
-              <a:t>；</a:t>
             </a:r>
             <a:endParaRPr lang="en-US" altLang="zh-CN" sz="1000" noProof="1">
               <a:solidFill>
@@ -11891,6 +9930,358 @@
               </a:solidFill>
               <a:latin typeface="微软雅黑" panose="020B0503020204020204" pitchFamily="34" charset="-122"/>
               <a:ea typeface="微软雅黑" panose="020B0503020204020204" pitchFamily="34" charset="-122"/>
+            </a:endParaRPr>
+          </a:p>
+        </p:txBody>
+      </p:sp>
+      <p:pic>
+        <p:nvPicPr>
+          <p:cNvPr id="127" name="图片 126">
+            <a:extLst>
+              <a:ext uri="{FF2B5EF4-FFF2-40B4-BE49-F238E27FC236}">
+                <a16:creationId xmlns:a16="http://schemas.microsoft.com/office/drawing/2014/main" id="{9199927C-B6A7-4AB8-B083-BD190D98B0EE}"/>
+              </a:ext>
+            </a:extLst>
+          </p:cNvPr>
+          <p:cNvPicPr>
+            <a:picLocks noChangeAspect="1"/>
+          </p:cNvPicPr>
+          <p:nvPr/>
+        </p:nvPicPr>
+        <p:blipFill rotWithShape="1">
+          <a:blip r:embed="rId4"/>
+          <a:srcRect t="27492" r="8372" b="53926"/>
+          <a:stretch/>
+        </p:blipFill>
+        <p:spPr>
+          <a:xfrm>
+            <a:off x="2598060" y="2653197"/>
+            <a:ext cx="2487139" cy="1227753"/>
+          </a:xfrm>
+          <a:prstGeom prst="rect">
+            <a:avLst/>
+          </a:prstGeom>
+        </p:spPr>
+      </p:pic>
+      <p:pic>
+        <p:nvPicPr>
+          <p:cNvPr id="3" name="图片 2">
+            <a:extLst>
+              <a:ext uri="{FF2B5EF4-FFF2-40B4-BE49-F238E27FC236}">
+                <a16:creationId xmlns:a16="http://schemas.microsoft.com/office/drawing/2014/main" id="{BFE3918C-A105-4553-9E0D-B5EBE95CF162}"/>
+              </a:ext>
+            </a:extLst>
+          </p:cNvPr>
+          <p:cNvPicPr>
+            <a:picLocks noChangeAspect="1"/>
+          </p:cNvPicPr>
+          <p:nvPr/>
+        </p:nvPicPr>
+        <p:blipFill rotWithShape="1">
+          <a:blip r:embed="rId4"/>
+          <a:srcRect l="2896" t="2498" r="12847" b="80652"/>
+          <a:stretch/>
+        </p:blipFill>
+        <p:spPr>
+          <a:xfrm>
+            <a:off x="347532" y="2684413"/>
+            <a:ext cx="2211962" cy="1076749"/>
+          </a:xfrm>
+          <a:prstGeom prst="rect">
+            <a:avLst/>
+          </a:prstGeom>
+        </p:spPr>
+      </p:pic>
+      <p:pic>
+        <p:nvPicPr>
+          <p:cNvPr id="129" name="图片 128">
+            <a:extLst>
+              <a:ext uri="{FF2B5EF4-FFF2-40B4-BE49-F238E27FC236}">
+                <a16:creationId xmlns:a16="http://schemas.microsoft.com/office/drawing/2014/main" id="{AF32933C-C4CD-420B-B74C-E84F6801FB89}"/>
+              </a:ext>
+            </a:extLst>
+          </p:cNvPr>
+          <p:cNvPicPr>
+            <a:picLocks noChangeAspect="1"/>
+          </p:cNvPicPr>
+          <p:nvPr/>
+        </p:nvPicPr>
+        <p:blipFill rotWithShape="1">
+          <a:blip r:embed="rId4"/>
+          <a:srcRect l="2081" t="81344" r="1536" b="1069"/>
+          <a:stretch/>
+        </p:blipFill>
+        <p:spPr>
+          <a:xfrm>
+            <a:off x="2630331" y="3913515"/>
+            <a:ext cx="2530292" cy="1123807"/>
+          </a:xfrm>
+          <a:prstGeom prst="rect">
+            <a:avLst/>
+          </a:prstGeom>
+        </p:spPr>
+      </p:pic>
+      <p:pic>
+        <p:nvPicPr>
+          <p:cNvPr id="130" name="图片 129">
+            <a:extLst>
+              <a:ext uri="{FF2B5EF4-FFF2-40B4-BE49-F238E27FC236}">
+                <a16:creationId xmlns:a16="http://schemas.microsoft.com/office/drawing/2014/main" id="{1A92E35A-4ACB-402A-B981-70E09130118B}"/>
+              </a:ext>
+            </a:extLst>
+          </p:cNvPr>
+          <p:cNvPicPr>
+            <a:picLocks noChangeAspect="1"/>
+          </p:cNvPicPr>
+          <p:nvPr/>
+        </p:nvPicPr>
+        <p:blipFill rotWithShape="1">
+          <a:blip r:embed="rId4"/>
+          <a:srcRect l="2415" t="54411" r="8066" b="28002"/>
+          <a:stretch/>
+        </p:blipFill>
+        <p:spPr>
+          <a:xfrm>
+            <a:off x="316354" y="3885872"/>
+            <a:ext cx="2350130" cy="1123807"/>
+          </a:xfrm>
+          <a:prstGeom prst="rect">
+            <a:avLst/>
+          </a:prstGeom>
+        </p:spPr>
+      </p:pic>
+      <p:sp>
+        <p:nvSpPr>
+          <p:cNvPr id="44" name="pie-title-d-attn">
+            <a:extLst>
+              <a:ext uri="{FF2B5EF4-FFF2-40B4-BE49-F238E27FC236}">
+                <a16:creationId xmlns:a16="http://schemas.microsoft.com/office/drawing/2014/main" id="{EF42CF0D-2FCD-4F0D-9C00-E72CA5BF31EF}"/>
+              </a:ext>
+            </a:extLst>
+          </p:cNvPr>
+          <p:cNvSpPr txBox="1"/>
+          <p:nvPr/>
+        </p:nvSpPr>
+        <p:spPr>
+          <a:xfrm>
+            <a:off x="-268397" y="3747906"/>
+            <a:ext cx="2717800" cy="165100"/>
+          </a:xfrm>
+          <a:prstGeom prst="rect">
+            <a:avLst/>
+          </a:prstGeom>
+          <a:noFill/>
+          <a:ln>
+            <a:noFill/>
+          </a:ln>
+        </p:spPr>
+        <p:txBody>
+          <a:bodyPr wrap="none" lIns="0" tIns="0" rIns="0" bIns="0" rtlCol="0" anchor="ctr"/>
+          <a:lstStyle/>
+          <a:p>
+            <a:pPr algn="ctr">
+              <a:lnSpc>
+                <a:spcPct val="120000"/>
+              </a:lnSpc>
+            </a:pPr>
+            <a:r>
+              <a:rPr lang="en-US" sz="900" b="1" noProof="1">
+                <a:solidFill>
+                  <a:srgbClr val="262626"/>
+                </a:solidFill>
+                <a:latin typeface="微软雅黑"/>
+                <a:ea typeface="微软雅黑"/>
+              </a:rPr>
+              <a:t>D · Attention（20.0%）</a:t>
+            </a:r>
+            <a:endParaRPr lang="en-US" sz="900" noProof="1"/>
+          </a:p>
+        </p:txBody>
+      </p:sp>
+      <p:sp>
+        <p:nvSpPr>
+          <p:cNvPr id="41" name="pie-title-p-moe">
+            <a:extLst>
+              <a:ext uri="{FF2B5EF4-FFF2-40B4-BE49-F238E27FC236}">
+                <a16:creationId xmlns:a16="http://schemas.microsoft.com/office/drawing/2014/main" id="{B7ECFC09-0B01-42DF-B84B-43669633CD51}"/>
+              </a:ext>
+            </a:extLst>
+          </p:cNvPr>
+          <p:cNvSpPr txBox="1"/>
+          <p:nvPr/>
+        </p:nvSpPr>
+        <p:spPr>
+          <a:xfrm>
+            <a:off x="1880900" y="2547117"/>
+            <a:ext cx="2717800" cy="165100"/>
+          </a:xfrm>
+          <a:prstGeom prst="rect">
+            <a:avLst/>
+          </a:prstGeom>
+          <a:noFill/>
+          <a:ln>
+            <a:noFill/>
+          </a:ln>
+        </p:spPr>
+        <p:txBody>
+          <a:bodyPr wrap="none" lIns="0" tIns="0" rIns="0" bIns="0" rtlCol="0" anchor="ctr"/>
+          <a:lstStyle/>
+          <a:p>
+            <a:pPr algn="ctr">
+              <a:lnSpc>
+                <a:spcPct val="120000"/>
+              </a:lnSpc>
+            </a:pPr>
+            <a:r>
+              <a:rPr lang="en-US" sz="900" b="1" noProof="1">
+                <a:solidFill>
+                  <a:srgbClr val="262626"/>
+                </a:solidFill>
+                <a:latin typeface="微软雅黑"/>
+                <a:ea typeface="微软雅黑"/>
+              </a:rPr>
+              <a:t>P · MoE（50.6%）</a:t>
+            </a:r>
+            <a:endParaRPr lang="en-US" sz="900" noProof="1"/>
+          </a:p>
+        </p:txBody>
+      </p:sp>
+      <p:sp>
+        <p:nvSpPr>
+          <p:cNvPr id="47" name="pie-title-d-moe">
+            <a:extLst>
+              <a:ext uri="{FF2B5EF4-FFF2-40B4-BE49-F238E27FC236}">
+                <a16:creationId xmlns:a16="http://schemas.microsoft.com/office/drawing/2014/main" id="{EF0DD825-8B2D-4152-A1D5-040CC4233478}"/>
+              </a:ext>
+            </a:extLst>
+          </p:cNvPr>
+          <p:cNvSpPr txBox="1"/>
+          <p:nvPr/>
+        </p:nvSpPr>
+        <p:spPr>
+          <a:xfrm>
+            <a:off x="1907744" y="3791598"/>
+            <a:ext cx="2717800" cy="165100"/>
+          </a:xfrm>
+          <a:prstGeom prst="rect">
+            <a:avLst/>
+          </a:prstGeom>
+          <a:noFill/>
+          <a:ln>
+            <a:noFill/>
+          </a:ln>
+        </p:spPr>
+        <p:txBody>
+          <a:bodyPr wrap="none" lIns="0" tIns="0" rIns="0" bIns="0" rtlCol="0" anchor="ctr"/>
+          <a:lstStyle/>
+          <a:p>
+            <a:pPr algn="ctr">
+              <a:lnSpc>
+                <a:spcPct val="120000"/>
+              </a:lnSpc>
+            </a:pPr>
+            <a:r>
+              <a:rPr lang="en-US" sz="900" b="1" noProof="1">
+                <a:solidFill>
+                  <a:srgbClr val="262626"/>
+                </a:solidFill>
+                <a:latin typeface="微软雅黑"/>
+                <a:ea typeface="微软雅黑"/>
+              </a:rPr>
+              <a:t>D · MoE（47.9%）</a:t>
+            </a:r>
+            <a:endParaRPr lang="en-US" sz="900" noProof="1"/>
+          </a:p>
+        </p:txBody>
+      </p:sp>
+      <p:sp>
+        <p:nvSpPr>
+          <p:cNvPr id="37" name="pie-legend">
+            <a:extLst>
+              <a:ext uri="{FF2B5EF4-FFF2-40B4-BE49-F238E27FC236}">
+                <a16:creationId xmlns:a16="http://schemas.microsoft.com/office/drawing/2014/main" id="{4FA41C38-24E8-4C85-A05E-A244668AE097}"/>
+              </a:ext>
+            </a:extLst>
+          </p:cNvPr>
+          <p:cNvSpPr txBox="1"/>
+          <p:nvPr/>
+        </p:nvSpPr>
+        <p:spPr>
+          <a:xfrm>
+            <a:off x="2886077" y="2326787"/>
+            <a:ext cx="2082800" cy="190500"/>
+          </a:xfrm>
+          <a:prstGeom prst="rect">
+            <a:avLst/>
+          </a:prstGeom>
+          <a:noFill/>
+          <a:ln>
+            <a:noFill/>
+          </a:ln>
+        </p:spPr>
+        <p:txBody>
+          <a:bodyPr wrap="none" lIns="0" tIns="0" rIns="0" bIns="0" rtlCol="0" anchor="ctr"/>
+          <a:lstStyle/>
+          <a:p>
+            <a:pPr algn="r">
+              <a:lnSpc>
+                <a:spcPct val="120000"/>
+              </a:lnSpc>
+            </a:pPr>
+            <a:r>
+              <a:rPr lang="en-US" sz="800" b="1" noProof="1">
+                <a:solidFill>
+                  <a:srgbClr val="2563EB"/>
+                </a:solidFill>
+                <a:latin typeface="微软雅黑"/>
+                <a:ea typeface="微软雅黑"/>
+              </a:rPr>
+              <a:t>■ 计算 </a:t>
+            </a:r>
+            <a:r>
+              <a:rPr lang="en-US" sz="800" b="1" noProof="1">
+                <a:solidFill>
+                  <a:srgbClr val="0C91B4"/>
+                </a:solidFill>
+                <a:latin typeface="微软雅黑"/>
+                <a:ea typeface="微软雅黑"/>
+              </a:rPr>
+              <a:t>■ </a:t>
+            </a:r>
+            <a:r>
+              <a:rPr lang="en-US" sz="800" b="1" noProof="1">
+                <a:solidFill>
+                  <a:srgbClr val="2CA0BE"/>
+                </a:solidFill>
+                <a:latin typeface="微软雅黑"/>
+                <a:ea typeface="微软雅黑"/>
+              </a:rPr>
+              <a:t>访存</a:t>
+            </a:r>
+            <a:r>
+              <a:rPr lang="en-US" sz="800" b="1" noProof="1">
+                <a:solidFill>
+                  <a:srgbClr val="0C91B4"/>
+                </a:solidFill>
+                <a:latin typeface="微软雅黑"/>
+                <a:ea typeface="微软雅黑"/>
+              </a:rPr>
+              <a:t> </a:t>
+            </a:r>
+            <a:r>
+              <a:rPr lang="en-US" sz="800" b="1" noProof="1">
+                <a:solidFill>
+                  <a:srgbClr val="E9590F"/>
+                </a:solidFill>
+                <a:latin typeface="微软雅黑"/>
+                <a:ea typeface="微软雅黑"/>
+              </a:rPr>
+              <a:t>■ 通信 </a:t>
+            </a:r>
+            <a:endParaRPr lang="en-US" sz="800" b="1" noProof="1">
+              <a:solidFill>
+                <a:srgbClr val="E9590F"/>
+              </a:solidFill>
             </a:endParaRPr>
           </a:p>
         </p:txBody>
@@ -12276,7 +10667,7 @@
         <p:grpSpPr>
           <a:xfrm>
             <a:off x="5402704" y="1197212"/>
-            <a:ext cx="6525296" cy="5370001"/>
+            <a:ext cx="6525296" cy="2273392"/>
             <a:chOff x="2359219" y="1643545"/>
             <a:chExt cx="4765479" cy="5043177"/>
           </a:xfrm>
@@ -13001,7 +11392,7 @@
                 <a:latin typeface="微软雅黑" panose="020B0503020204020204" pitchFamily="34" charset="-122"/>
                 <a:ea typeface="微软雅黑" panose="020B0503020204020204" pitchFamily="34" charset="-122"/>
               </a:rPr>
-              <a:t> 重计算回滚方案</a:t>
+              <a:t> 回滚方案</a:t>
             </a:r>
           </a:p>
         </p:txBody>
@@ -13021,13 +11412,13 @@
           <p:nvPr>
             <p:extLst>
               <p:ext uri="{D42A27DB-BD31-4B8C-83A1-F6EECF244321}">
-                <p14:modId xmlns:p14="http://schemas.microsoft.com/office/powerpoint/2010/main" val="1938114302"/>
+                <p14:modId xmlns:p14="http://schemas.microsoft.com/office/powerpoint/2010/main" val="3676024988"/>
               </p:ext>
             </p:extLst>
           </p:nvPr>
         </p:nvGraphicFramePr>
         <p:xfrm>
-          <a:off x="845489" y="3732937"/>
+          <a:off x="845489" y="3767305"/>
           <a:ext cx="3773004" cy="2545751"/>
         </p:xfrm>
         <a:graphic>
@@ -13272,7 +11663,7 @@
                           <a:ea typeface="微软雅黑" panose="020B0503020204020204" pitchFamily="34" charset="-122"/>
                           <a:cs typeface="+mn-cs"/>
                         </a:rPr>
-                        <a:t>节省缓存</a:t>
+                        <a:t>节省显存</a:t>
                       </a:r>
                     </a:p>
                   </a:txBody>
@@ -14115,7 +12506,7 @@
                           <a:ea typeface="微软雅黑" panose="020B0503020204020204" pitchFamily="34" charset="-122"/>
                           <a:cs typeface="+mn-cs"/>
                         </a:rPr>
-                        <a:t>correction</a:t>
+                        <a:t>Correction</a:t>
                       </a:r>
                     </a:p>
                   </a:txBody>
@@ -14239,9 +12630,9 @@
                     <a:p>
                       <a:pPr algn="ctr"/>
                       <a:r>
-                        <a:rPr lang="en-US" altLang="zh-CN" sz="1100" b="1" kern="1200" dirty="0">
+                        <a:rPr lang="en-US" altLang="zh-CN" sz="1100" b="0" kern="1200" dirty="0">
                           <a:solidFill>
-                            <a:srgbClr val="C00203"/>
+                            <a:schemeClr val="tx1"/>
                           </a:solidFill>
                           <a:latin typeface="微软雅黑" panose="020B0503020204020204" pitchFamily="34" charset="-122"/>
                           <a:ea typeface="微软雅黑" panose="020B0503020204020204" pitchFamily="34" charset="-122"/>
@@ -14370,7 +12761,7 @@
                     <a:p>
                       <a:pPr algn="ctr"/>
                       <a:r>
-                        <a:rPr lang="en-US" sz="1100" kern="1200" dirty="0" err="1">
+                        <a:rPr lang="en-US" sz="1100" kern="1200" dirty="0">
                           <a:solidFill>
                             <a:srgbClr val="0F1115"/>
                           </a:solidFill>
@@ -14378,18 +12769,7 @@
                           <a:ea typeface="微软雅黑" panose="020B0503020204020204" pitchFamily="34" charset="-122"/>
                           <a:cs typeface="+mn-cs"/>
                         </a:rPr>
-                        <a:t>key+</a:t>
-                      </a:r>
-                      <a:r>
-                        <a:rPr lang="en-US" altLang="zh-CN" sz="1100" kern="1200" dirty="0" err="1">
-                          <a:solidFill>
-                            <a:srgbClr val="0F1115"/>
-                          </a:solidFill>
-                          <a:latin typeface="微软雅黑" panose="020B0503020204020204" pitchFamily="34" charset="-122"/>
-                          <a:ea typeface="微软雅黑" panose="020B0503020204020204" pitchFamily="34" charset="-122"/>
-                          <a:cs typeface="+mn-cs"/>
-                        </a:rPr>
-                        <a:t>raw</a:t>
+                        <a:t>Key +</a:t>
                       </a:r>
                       <a:r>
                         <a:rPr lang="en-US" altLang="zh-CN" sz="1100" kern="1200" dirty="0">
@@ -14400,7 +12780,7 @@
                           <a:ea typeface="微软雅黑" panose="020B0503020204020204" pitchFamily="34" charset="-122"/>
                           <a:cs typeface="+mn-cs"/>
                         </a:rPr>
-                        <a:t> gate</a:t>
+                        <a:t> Gate</a:t>
                       </a:r>
                       <a:endParaRPr lang="en-US" sz="1100" kern="1200" dirty="0">
                         <a:solidFill>
@@ -14548,9 +12928,9 @@
                         <a:defRPr/>
                       </a:pPr>
                       <a:r>
-                        <a:rPr lang="en-US" altLang="zh-CN" sz="1100" b="1" kern="1200" dirty="0">
+                        <a:rPr lang="en-US" altLang="zh-CN" sz="1100" b="0" kern="1200" dirty="0">
                           <a:solidFill>
-                            <a:srgbClr val="C00203"/>
+                            <a:schemeClr val="tx1"/>
                           </a:solidFill>
                           <a:latin typeface="微软雅黑" panose="020B0503020204020204" pitchFamily="34" charset="-122"/>
                           <a:ea typeface="微软雅黑" panose="020B0503020204020204" pitchFamily="34" charset="-122"/>
@@ -14888,26 +13268,15 @@
                         <a:defRPr/>
                       </a:pPr>
                       <a:r>
-                        <a:rPr lang="en-US" altLang="zh-CN" sz="1100" b="0" kern="1200">
+                        <a:rPr lang="en-US" altLang="zh-CN" sz="1100" b="1" kern="1200" dirty="0">
                           <a:solidFill>
-                            <a:schemeClr val="tx1"/>
+                            <a:srgbClr val="C00000"/>
                           </a:solidFill>
                           <a:latin typeface="微软雅黑" panose="020B0503020204020204" pitchFamily="34" charset="-122"/>
                           <a:ea typeface="微软雅黑" panose="020B0503020204020204" pitchFamily="34" charset="-122"/>
                           <a:cs typeface="+mn-cs"/>
                         </a:rPr>
-                        <a:t>~81.7</a:t>
-                      </a:r>
-                      <a:r>
-                        <a:rPr lang="en-US" altLang="zh-CN" sz="1100" b="0" kern="1200" dirty="0">
-                          <a:solidFill>
-                            <a:schemeClr val="tx1"/>
-                          </a:solidFill>
-                          <a:latin typeface="微软雅黑" panose="020B0503020204020204" pitchFamily="34" charset="-122"/>
-                          <a:ea typeface="微软雅黑" panose="020B0503020204020204" pitchFamily="34" charset="-122"/>
-                          <a:cs typeface="+mn-cs"/>
-                        </a:rPr>
-                        <a:t>%</a:t>
+                        <a:t>81.6%</a:t>
                       </a:r>
                     </a:p>
                   </a:txBody>
@@ -15134,7 +13503,7 @@
         </p:nvSpPr>
         <p:spPr>
           <a:xfrm>
-            <a:off x="285235" y="1495392"/>
+            <a:off x="285235" y="1457292"/>
             <a:ext cx="4829038" cy="2142638"/>
           </a:xfrm>
           <a:prstGeom prst="rect">
@@ -15251,7 +13620,7 @@
                 <a:latin typeface="微软雅黑" panose="020B0503020204020204" pitchFamily="34" charset="-122"/>
                 <a:ea typeface="微软雅黑" panose="020B0503020204020204" pitchFamily="34" charset="-122"/>
               </a:rPr>
-              <a:t>KDA </a:t>
+              <a:t>KDA State </a:t>
             </a:r>
             <a:r>
               <a:rPr lang="zh-CN" altLang="en-US" sz="1000" dirty="0">
@@ -15261,7 +13630,37 @@
                 <a:latin typeface="微软雅黑" panose="020B0503020204020204" pitchFamily="34" charset="-122"/>
                 <a:ea typeface="微软雅黑" panose="020B0503020204020204" pitchFamily="34" charset="-122"/>
               </a:rPr>
-              <a:t>的 </a:t>
+              <a:t>需要回滚到 </a:t>
+            </a:r>
+            <a:r>
+              <a:rPr lang="zh-CN" altLang="en-US" sz="1000" b="1" dirty="0">
+                <a:solidFill>
+                  <a:srgbClr val="0F1115"/>
+                </a:solidFill>
+                <a:latin typeface="微软雅黑" panose="020B0503020204020204" pitchFamily="34" charset="-122"/>
+                <a:ea typeface="微软雅黑" panose="020B0503020204020204" pitchFamily="34" charset="-122"/>
+              </a:rPr>
+              <a:t>接收 </a:t>
+            </a:r>
+            <a:r>
+              <a:rPr lang="en-US" altLang="zh-CN" sz="1000" b="1" dirty="0">
+                <a:solidFill>
+                  <a:srgbClr val="0F1115"/>
+                </a:solidFill>
+                <a:latin typeface="微软雅黑" panose="020B0503020204020204" pitchFamily="34" charset="-122"/>
+                <a:ea typeface="微软雅黑" panose="020B0503020204020204" pitchFamily="34" charset="-122"/>
+              </a:rPr>
+              <a:t>Token </a:t>
+            </a:r>
+            <a:r>
+              <a:rPr lang="zh-CN" altLang="en-US" sz="1000" dirty="0">
+                <a:solidFill>
+                  <a:srgbClr val="0F1115"/>
+                </a:solidFill>
+                <a:latin typeface="微软雅黑" panose="020B0503020204020204" pitchFamily="34" charset="-122"/>
+                <a:ea typeface="微软雅黑" panose="020B0503020204020204" pitchFamily="34" charset="-122"/>
+              </a:rPr>
+              <a:t>位置，但主模型验证后</a:t>
             </a:r>
             <a:r>
               <a:rPr lang="en-US" altLang="zh-CN" sz="1000" dirty="0">
@@ -15271,7 +13670,7 @@
                 <a:latin typeface="微软雅黑" panose="020B0503020204020204" pitchFamily="34" charset="-122"/>
                 <a:ea typeface="微软雅黑" panose="020B0503020204020204" pitchFamily="34" charset="-122"/>
               </a:rPr>
-              <a:t>Recurrent State </a:t>
+              <a:t>, KDA State </a:t>
             </a:r>
             <a:r>
               <a:rPr lang="zh-CN" altLang="en-US" sz="1000" dirty="0">
@@ -15281,68 +13680,35 @@
                 <a:latin typeface="微软雅黑" panose="020B0503020204020204" pitchFamily="34" charset="-122"/>
                 <a:ea typeface="微软雅黑" panose="020B0503020204020204" pitchFamily="34" charset="-122"/>
               </a:rPr>
-              <a:t>需要回滚到 </a:t>
-            </a:r>
-            <a:r>
-              <a:rPr lang="zh-CN" altLang="en-US" sz="1000" b="1" dirty="0">
+              <a:t>已更新到最后一个草稿 </a:t>
+            </a:r>
+            <a:r>
+              <a:rPr lang="en-US" altLang="zh-CN" sz="1000" dirty="0">
                 <a:solidFill>
                   <a:srgbClr val="0F1115"/>
                 </a:solidFill>
                 <a:latin typeface="微软雅黑" panose="020B0503020204020204" pitchFamily="34" charset="-122"/>
                 <a:ea typeface="微软雅黑" panose="020B0503020204020204" pitchFamily="34" charset="-122"/>
               </a:rPr>
-              <a:t>接收 </a:t>
-            </a:r>
-            <a:r>
-              <a:rPr lang="en-US" altLang="zh-CN" sz="1000" b="1" dirty="0">
+              <a:t>Token</a:t>
+            </a:r>
+            <a:r>
+              <a:rPr lang="zh-CN" altLang="en-US" sz="1000" dirty="0">
                 <a:solidFill>
                   <a:srgbClr val="0F1115"/>
                 </a:solidFill>
                 <a:latin typeface="微软雅黑" panose="020B0503020204020204" pitchFamily="34" charset="-122"/>
                 <a:ea typeface="微软雅黑" panose="020B0503020204020204" pitchFamily="34" charset="-122"/>
               </a:rPr>
-              <a:t>Token </a:t>
-            </a:r>
-            <a:r>
-              <a:rPr lang="zh-CN" altLang="en-US" sz="1000" dirty="0">
-                <a:solidFill>
-                  <a:srgbClr val="0F1115"/>
-                </a:solidFill>
-                <a:latin typeface="微软雅黑" panose="020B0503020204020204" pitchFamily="34" charset="-122"/>
-                <a:ea typeface="微软雅黑" panose="020B0503020204020204" pitchFamily="34" charset="-122"/>
-              </a:rPr>
-              <a:t>位置，但在主模型验证后</a:t>
-            </a:r>
-            <a:r>
-              <a:rPr lang="en-US" altLang="zh-CN" sz="1000" dirty="0">
-                <a:solidFill>
-                  <a:srgbClr val="0F1115"/>
-                </a:solidFill>
-                <a:latin typeface="微软雅黑" panose="020B0503020204020204" pitchFamily="34" charset="-122"/>
-                <a:ea typeface="微软雅黑" panose="020B0503020204020204" pitchFamily="34" charset="-122"/>
-              </a:rPr>
-              <a:t>, Recurrent State </a:t>
-            </a:r>
-            <a:r>
-              <a:rPr lang="zh-CN" altLang="en-US" sz="1000" dirty="0">
-                <a:solidFill>
-                  <a:srgbClr val="0F1115"/>
-                </a:solidFill>
-                <a:latin typeface="微软雅黑" panose="020B0503020204020204" pitchFamily="34" charset="-122"/>
-                <a:ea typeface="微软雅黑" panose="020B0503020204020204" pitchFamily="34" charset="-122"/>
-              </a:rPr>
-              <a:t>已更新到最后一个草稿 </a:t>
-            </a:r>
-            <a:r>
-              <a:rPr lang="en-US" altLang="zh-CN" sz="1000" dirty="0">
-                <a:solidFill>
-                  <a:srgbClr val="0F1115"/>
-                </a:solidFill>
-                <a:latin typeface="微软雅黑" panose="020B0503020204020204" pitchFamily="34" charset="-122"/>
-                <a:ea typeface="微软雅黑" panose="020B0503020204020204" pitchFamily="34" charset="-122"/>
-              </a:rPr>
-              <a:t>Token</a:t>
-            </a:r>
+              <a:t>位置</a:t>
+            </a:r>
+            <a:endParaRPr lang="en-US" altLang="zh-CN" sz="1000" dirty="0">
+              <a:solidFill>
+                <a:srgbClr val="0F1115"/>
+              </a:solidFill>
+              <a:latin typeface="微软雅黑" panose="020B0503020204020204" pitchFamily="34" charset="-122"/>
+              <a:ea typeface="微软雅黑" panose="020B0503020204020204" pitchFamily="34" charset="-122"/>
+            </a:endParaRPr>
           </a:p>
           <a:p>
             <a:pPr marL="540000" lvl="1" indent="-228600" defTabSz="914034">
@@ -15371,7 +13737,7 @@
                 <a:latin typeface="微软雅黑" panose="020B0503020204020204" pitchFamily="34" charset="-122"/>
                 <a:ea typeface="微软雅黑" panose="020B0503020204020204" pitchFamily="34" charset="-122"/>
               </a:rPr>
-              <a:t>KDA </a:t>
+              <a:t>KDA State </a:t>
             </a:r>
             <a:r>
               <a:rPr lang="zh-CN" altLang="en-US" sz="1000" dirty="0">
@@ -15381,7 +13747,7 @@
                 <a:latin typeface="微软雅黑" panose="020B0503020204020204" pitchFamily="34" charset="-122"/>
                 <a:ea typeface="微软雅黑" panose="020B0503020204020204" pitchFamily="34" charset="-122"/>
               </a:rPr>
-              <a:t>状态，当前 </a:t>
+              <a:t>，当前 </a:t>
             </a:r>
             <a:r>
               <a:rPr lang="en-US" altLang="zh-CN" sz="1000" dirty="0" err="1">
@@ -15451,7 +13817,7 @@
                 <a:latin typeface="微软雅黑" panose="020B0503020204020204" pitchFamily="34" charset="-122"/>
                 <a:ea typeface="微软雅黑" panose="020B0503020204020204" pitchFamily="34" charset="-122"/>
               </a:rPr>
-              <a:t>Recurrent State</a:t>
+              <a:t>KDA State</a:t>
             </a:r>
             <a:r>
               <a:rPr lang="zh-CN" altLang="en-US" sz="1000" dirty="0">
@@ -15492,7 +13858,7 @@
                 <a:latin typeface="微软雅黑" panose="020B0503020204020204" pitchFamily="34" charset="-122"/>
                 <a:ea typeface="微软雅黑" panose="020B0503020204020204" pitchFamily="34" charset="-122"/>
               </a:rPr>
-              <a:t>场景下，需要额外 </a:t>
+              <a:t>场景下，需要 </a:t>
             </a:r>
             <a:r>
               <a:rPr lang="en-US" altLang="zh-CN" sz="1000" b="1" dirty="0">
@@ -15559,7 +13925,7 @@
                 <a:latin typeface="微软雅黑" panose="020B0503020204020204" pitchFamily="34" charset="-122"/>
                 <a:ea typeface="微软雅黑" panose="020B0503020204020204" pitchFamily="34" charset="-122"/>
               </a:rPr>
-              <a:t>技术报告中，提出 </a:t>
+              <a:t>技术报告提出 </a:t>
             </a:r>
             <a:r>
               <a:rPr lang="en-US" altLang="zh-CN" sz="1000" dirty="0">
@@ -15609,7 +13975,7 @@
                 <a:latin typeface="微软雅黑" panose="020B0503020204020204" pitchFamily="34" charset="-122"/>
                 <a:ea typeface="微软雅黑" panose="020B0503020204020204" pitchFamily="34" charset="-122"/>
               </a:rPr>
-              <a:t>Recurrent State</a:t>
+              <a:t>KDA State</a:t>
             </a:r>
             <a:r>
               <a:rPr lang="zh-CN" altLang="en-US" sz="1000" dirty="0">
@@ -15725,7 +14091,7 @@
         </p:nvSpPr>
         <p:spPr>
           <a:xfrm>
-            <a:off x="287071" y="1242259"/>
+            <a:off x="287071" y="1219399"/>
             <a:ext cx="764080" cy="306054"/>
           </a:xfrm>
           <a:prstGeom prst="rect">
@@ -15779,7 +14145,7 @@
         </p:nvSpPr>
         <p:spPr>
           <a:xfrm>
-            <a:off x="2330165" y="3463305"/>
+            <a:off x="2029390" y="3446700"/>
             <a:ext cx="1513020" cy="306174"/>
           </a:xfrm>
           <a:prstGeom prst="rect">
@@ -15793,7 +14159,7 @@
           </a:bodyPr>
           <a:lstStyle/>
           <a:p>
-            <a:pPr defTabSz="914034">
+            <a:pPr algn="ctr" defTabSz="914034">
               <a:lnSpc>
                 <a:spcPct val="150000"/>
               </a:lnSpc>
@@ -16104,12 +14470,150 @@
           </p:txBody>
         </p:sp>
       </p:grpSp>
+      <p:sp>
+        <p:nvSpPr>
+          <p:cNvPr id="4" name="文本框 3">
+            <a:extLst>
+              <a:ext uri="{FF2B5EF4-FFF2-40B4-BE49-F238E27FC236}">
+                <a16:creationId xmlns:a16="http://schemas.microsoft.com/office/drawing/2014/main" id="{E93D2D1D-4EC0-429B-86BE-752EDDB99A27}"/>
+              </a:ext>
+            </a:extLst>
+          </p:cNvPr>
+          <p:cNvSpPr txBox="1"/>
+          <p:nvPr/>
+        </p:nvSpPr>
+        <p:spPr>
+          <a:xfrm>
+            <a:off x="505224" y="6430832"/>
+            <a:ext cx="4571678" cy="153888"/>
+          </a:xfrm>
+          <a:prstGeom prst="rect">
+            <a:avLst/>
+          </a:prstGeom>
+          <a:noFill/>
+        </p:spPr>
+        <p:txBody>
+          <a:bodyPr wrap="square" lIns="0" tIns="0" rIns="0" bIns="0" rtlCol="0">
+            <a:spAutoFit/>
+          </a:bodyPr>
+          <a:lstStyle/>
+          <a:p>
+            <a:r>
+              <a:rPr kumimoji="1" lang="zh-CN" altLang="en-US" sz="1000" dirty="0">
+                <a:solidFill>
+                  <a:srgbClr val="000000"/>
+                </a:solidFill>
+                <a:latin typeface="微软雅黑" panose="020B0503020204020204" pitchFamily="34" charset="-122"/>
+                <a:ea typeface="微软雅黑" panose="020B0503020204020204" pitchFamily="34" charset="-122"/>
+              </a:rPr>
+              <a:t>备注：每次</a:t>
+            </a:r>
+            <a:r>
+              <a:rPr kumimoji="1" lang="en-US" altLang="zh-CN" sz="1000" dirty="0">
+                <a:solidFill>
+                  <a:srgbClr val="000000"/>
+                </a:solidFill>
+                <a:latin typeface="微软雅黑" panose="020B0503020204020204" pitchFamily="34" charset="-122"/>
+                <a:ea typeface="微软雅黑" panose="020B0503020204020204" pitchFamily="34" charset="-122"/>
+              </a:rPr>
+              <a:t>decode </a:t>
+            </a:r>
+            <a:r>
+              <a:rPr kumimoji="1" lang="zh-CN" altLang="en-US" sz="1000" dirty="0">
+                <a:solidFill>
+                  <a:srgbClr val="000000"/>
+                </a:solidFill>
+                <a:latin typeface="微软雅黑" panose="020B0503020204020204" pitchFamily="34" charset="-122"/>
+                <a:ea typeface="微软雅黑" panose="020B0503020204020204" pitchFamily="34" charset="-122"/>
+              </a:rPr>
+              <a:t>缓存</a:t>
+            </a:r>
+            <a:r>
+              <a:rPr kumimoji="1" lang="en-US" altLang="zh-CN" sz="1000" dirty="0">
+                <a:solidFill>
+                  <a:srgbClr val="000000"/>
+                </a:solidFill>
+                <a:latin typeface="微软雅黑" panose="020B0503020204020204" pitchFamily="34" charset="-122"/>
+                <a:ea typeface="微软雅黑" panose="020B0503020204020204" pitchFamily="34" charset="-122"/>
+              </a:rPr>
+              <a:t>6</a:t>
+            </a:r>
+            <a:r>
+              <a:rPr kumimoji="1" lang="zh-CN" altLang="en-US" sz="1000" dirty="0">
+                <a:solidFill>
+                  <a:srgbClr val="000000"/>
+                </a:solidFill>
+                <a:latin typeface="微软雅黑" panose="020B0503020204020204" pitchFamily="34" charset="-122"/>
+                <a:ea typeface="微软雅黑" panose="020B0503020204020204" pitchFamily="34" charset="-122"/>
+              </a:rPr>
+              <a:t>个</a:t>
+            </a:r>
+            <a:r>
+              <a:rPr kumimoji="1" lang="en-US" altLang="zh-CN" sz="1000" dirty="0">
+                <a:solidFill>
+                  <a:srgbClr val="000000"/>
+                </a:solidFill>
+                <a:latin typeface="微软雅黑" panose="020B0503020204020204" pitchFamily="34" charset="-122"/>
+                <a:ea typeface="微软雅黑" panose="020B0503020204020204" pitchFamily="34" charset="-122"/>
+              </a:rPr>
+              <a:t>token</a:t>
+            </a:r>
+            <a:r>
+              <a:rPr kumimoji="1" lang="zh-CN" altLang="en-US" sz="1000" dirty="0">
+                <a:solidFill>
+                  <a:srgbClr val="000000"/>
+                </a:solidFill>
+                <a:latin typeface="微软雅黑" panose="020B0503020204020204" pitchFamily="34" charset="-122"/>
+                <a:ea typeface="微软雅黑" panose="020B0503020204020204" pitchFamily="34" charset="-122"/>
+              </a:rPr>
+              <a:t>，</a:t>
+            </a:r>
+            <a:r>
+              <a:rPr kumimoji="1" lang="en-US" altLang="zh-CN" sz="1000" dirty="0">
+                <a:solidFill>
+                  <a:srgbClr val="000000"/>
+                </a:solidFill>
+                <a:latin typeface="微软雅黑" panose="020B0503020204020204" pitchFamily="34" charset="-122"/>
+                <a:ea typeface="微软雅黑" panose="020B0503020204020204" pitchFamily="34" charset="-122"/>
+              </a:rPr>
+              <a:t>MLA KV, KDA State, key/gate </a:t>
+            </a:r>
+            <a:r>
+              <a:rPr kumimoji="1" lang="zh-CN" altLang="en-US" sz="1000" dirty="0">
+                <a:solidFill>
+                  <a:srgbClr val="000000"/>
+                </a:solidFill>
+                <a:latin typeface="微软雅黑" panose="020B0503020204020204" pitchFamily="34" charset="-122"/>
+                <a:ea typeface="微软雅黑" panose="020B0503020204020204" pitchFamily="34" charset="-122"/>
+              </a:rPr>
+              <a:t>均采用</a:t>
+            </a:r>
+            <a:r>
+              <a:rPr kumimoji="1" lang="en-US" altLang="zh-CN" sz="1000" dirty="0">
+                <a:solidFill>
+                  <a:srgbClr val="000000"/>
+                </a:solidFill>
+                <a:latin typeface="微软雅黑" panose="020B0503020204020204" pitchFamily="34" charset="-122"/>
+                <a:ea typeface="微软雅黑" panose="020B0503020204020204" pitchFamily="34" charset="-122"/>
+              </a:rPr>
+              <a:t>BF16 </a:t>
+            </a:r>
+            <a:endParaRPr kumimoji="1" lang="zh-CN" altLang="en-US" sz="1000" dirty="0">
+              <a:solidFill>
+                <a:srgbClr val="000000"/>
+              </a:solidFill>
+              <a:latin typeface="微软雅黑" panose="020B0503020204020204" pitchFamily="34" charset="-122"/>
+              <a:ea typeface="微软雅黑" panose="020B0503020204020204" pitchFamily="34" charset="-122"/>
+            </a:endParaRPr>
+          </a:p>
+        </p:txBody>
+      </p:sp>
       <p:pic>
         <p:nvPicPr>
-          <p:cNvPr id="3" name="图片 2">
+          <p:cNvPr id="2" name="图片 1">
             <a:extLst>
               <a:ext uri="{FF2B5EF4-FFF2-40B4-BE49-F238E27FC236}">
-                <a16:creationId xmlns:a16="http://schemas.microsoft.com/office/drawing/2014/main" id="{49F2B539-8345-44BC-B634-9C6B86444C48}"/>
+                <a16:creationId xmlns:a16="http://schemas.microsoft.com/office/drawing/2014/main" id="{D7C72F24-7AB3-4F43-8BB1-50AB462A4D82}"/>
               </a:ext>
             </a:extLst>
           </p:cNvPr>
@@ -16126,20 +14630,356 @@
         </p:blipFill>
         <p:spPr>
           <a:xfrm>
-            <a:off x="5708361" y="1395286"/>
-            <a:ext cx="6081978" cy="5033758"/>
+            <a:off x="5593895" y="1347674"/>
+            <a:ext cx="6211994" cy="2045457"/>
           </a:xfrm>
           <a:prstGeom prst="rect">
             <a:avLst/>
           </a:prstGeom>
         </p:spPr>
       </p:pic>
+      <p:grpSp>
+        <p:nvGrpSpPr>
+          <p:cNvPr id="38" name="组合 37">
+            <a:extLst>
+              <a:ext uri="{FF2B5EF4-FFF2-40B4-BE49-F238E27FC236}">
+                <a16:creationId xmlns:a16="http://schemas.microsoft.com/office/drawing/2014/main" id="{C1F9A704-24EA-4232-A8D0-3766F7428BDE}"/>
+              </a:ext>
+            </a:extLst>
+          </p:cNvPr>
+          <p:cNvGrpSpPr/>
+          <p:nvPr/>
+        </p:nvGrpSpPr>
+        <p:grpSpPr>
+          <a:xfrm>
+            <a:off x="5399673" y="3599930"/>
+            <a:ext cx="6525296" cy="3029470"/>
+            <a:chOff x="2359219" y="1643545"/>
+            <a:chExt cx="4765479" cy="5043177"/>
+          </a:xfrm>
+        </p:grpSpPr>
+        <p:sp>
+          <p:nvSpPr>
+            <p:cNvPr id="39" name="矩形 127">
+              <a:extLst>
+                <a:ext uri="{FF2B5EF4-FFF2-40B4-BE49-F238E27FC236}">
+                  <a16:creationId xmlns:a16="http://schemas.microsoft.com/office/drawing/2014/main" id="{CFB109B1-E02C-4821-A7D5-319CB9572F45}"/>
+                </a:ext>
+              </a:extLst>
+            </p:cNvPr>
+            <p:cNvSpPr/>
+            <p:nvPr/>
+          </p:nvSpPr>
+          <p:spPr>
+            <a:xfrm>
+              <a:off x="2359219" y="1647570"/>
+              <a:ext cx="4761052" cy="5035128"/>
+            </a:xfrm>
+            <a:prstGeom prst="rect">
+              <a:avLst/>
+            </a:prstGeom>
+            <a:solidFill>
+              <a:srgbClr val="FFFFFF"/>
+            </a:solidFill>
+            <a:ln w="22225" cap="flat" cmpd="sng" algn="ctr">
+              <a:solidFill>
+                <a:srgbClr val="DDDDDD"/>
+              </a:solidFill>
+              <a:prstDash val="solid"/>
+              <a:miter lim="800000"/>
+            </a:ln>
+            <a:effectLst/>
+          </p:spPr>
+          <p:txBody>
+            <a:bodyPr rot="0" spcFirstLastPara="0" vertOverflow="overflow" horzOverflow="overflow" vert="horz" wrap="square" lIns="91224" tIns="45612" rIns="91224" bIns="45612" numCol="1" spcCol="0" rtlCol="0" fromWordArt="0" anchor="ctr" anchorCtr="0" forceAA="0" compatLnSpc="1">
+              <a:noAutofit/>
+            </a:bodyPr>
+            <a:lstStyle/>
+            <a:p>
+              <a:pPr algn="ctr" defTabSz="911495">
+                <a:defRPr/>
+              </a:pPr>
+              <a:endParaRPr lang="zh-CN" altLang="en-US" sz="1599" kern="0" dirty="0">
+                <a:solidFill>
+                  <a:srgbClr val="666666"/>
+                </a:solidFill>
+                <a:latin typeface="Calibri" panose="020F0502020204030204"/>
+                <a:ea typeface="等线" panose="02010600030101010101" pitchFamily="2" charset="-122"/>
+              </a:endParaRPr>
+            </a:p>
+          </p:txBody>
+        </p:sp>
+        <p:cxnSp>
+          <p:nvCxnSpPr>
+            <p:cNvPr id="40" name="直接连接符 128">
+              <a:extLst>
+                <a:ext uri="{FF2B5EF4-FFF2-40B4-BE49-F238E27FC236}">
+                  <a16:creationId xmlns:a16="http://schemas.microsoft.com/office/drawing/2014/main" id="{899F845B-A212-44E6-B7B7-AFF93A0C69E1}"/>
+                </a:ext>
+              </a:extLst>
+            </p:cNvPr>
+            <p:cNvCxnSpPr/>
+            <p:nvPr/>
+          </p:nvCxnSpPr>
+          <p:spPr>
+            <a:xfrm>
+              <a:off x="2359219" y="1647570"/>
+              <a:ext cx="195024" cy="0"/>
+            </a:xfrm>
+            <a:prstGeom prst="line">
+              <a:avLst/>
+            </a:prstGeom>
+            <a:solidFill>
+              <a:srgbClr val="FFFFFF"/>
+            </a:solidFill>
+            <a:ln w="22225" cap="flat" cmpd="sng" algn="ctr">
+              <a:solidFill>
+                <a:srgbClr val="C00000"/>
+              </a:solidFill>
+              <a:prstDash val="solid"/>
+              <a:miter lim="800000"/>
+            </a:ln>
+            <a:effectLst/>
+          </p:spPr>
+        </p:cxnSp>
+        <p:cxnSp>
+          <p:nvCxnSpPr>
+            <p:cNvPr id="41" name="直接连接符 129">
+              <a:extLst>
+                <a:ext uri="{FF2B5EF4-FFF2-40B4-BE49-F238E27FC236}">
+                  <a16:creationId xmlns:a16="http://schemas.microsoft.com/office/drawing/2014/main" id="{F6246BAF-7836-4014-AD6F-DD0A5D30C802}"/>
+                </a:ext>
+              </a:extLst>
+            </p:cNvPr>
+            <p:cNvCxnSpPr/>
+            <p:nvPr/>
+          </p:nvCxnSpPr>
+          <p:spPr>
+            <a:xfrm>
+              <a:off x="2359219" y="6678673"/>
+              <a:ext cx="195024" cy="0"/>
+            </a:xfrm>
+            <a:prstGeom prst="line">
+              <a:avLst/>
+            </a:prstGeom>
+            <a:solidFill>
+              <a:srgbClr val="FFFFFF"/>
+            </a:solidFill>
+            <a:ln w="22225" cap="flat" cmpd="sng" algn="ctr">
+              <a:solidFill>
+                <a:srgbClr val="C00000"/>
+              </a:solidFill>
+              <a:prstDash val="solid"/>
+              <a:miter lim="800000"/>
+            </a:ln>
+            <a:effectLst/>
+          </p:spPr>
+        </p:cxnSp>
+        <p:cxnSp>
+          <p:nvCxnSpPr>
+            <p:cNvPr id="42" name="直接连接符 130">
+              <a:extLst>
+                <a:ext uri="{FF2B5EF4-FFF2-40B4-BE49-F238E27FC236}">
+                  <a16:creationId xmlns:a16="http://schemas.microsoft.com/office/drawing/2014/main" id="{F1F869DB-B67D-4EA1-AC16-80251C928D9D}"/>
+                </a:ext>
+              </a:extLst>
+            </p:cNvPr>
+            <p:cNvCxnSpPr/>
+            <p:nvPr/>
+          </p:nvCxnSpPr>
+          <p:spPr>
+            <a:xfrm>
+              <a:off x="6929674" y="1647570"/>
+              <a:ext cx="195024" cy="0"/>
+            </a:xfrm>
+            <a:prstGeom prst="line">
+              <a:avLst/>
+            </a:prstGeom>
+            <a:solidFill>
+              <a:srgbClr val="FFFFFF"/>
+            </a:solidFill>
+            <a:ln w="22225" cap="flat" cmpd="sng" algn="ctr">
+              <a:solidFill>
+                <a:srgbClr val="C00000"/>
+              </a:solidFill>
+              <a:prstDash val="solid"/>
+              <a:miter lim="800000"/>
+            </a:ln>
+            <a:effectLst/>
+          </p:spPr>
+        </p:cxnSp>
+        <p:cxnSp>
+          <p:nvCxnSpPr>
+            <p:cNvPr id="43" name="直接连接符 131">
+              <a:extLst>
+                <a:ext uri="{FF2B5EF4-FFF2-40B4-BE49-F238E27FC236}">
+                  <a16:creationId xmlns:a16="http://schemas.microsoft.com/office/drawing/2014/main" id="{416C4A9C-D9C5-4914-B8FC-AAB2A1C4A840}"/>
+                </a:ext>
+              </a:extLst>
+            </p:cNvPr>
+            <p:cNvCxnSpPr/>
+            <p:nvPr/>
+          </p:nvCxnSpPr>
+          <p:spPr>
+            <a:xfrm flipH="1">
+              <a:off x="7119869" y="1643545"/>
+              <a:ext cx="1" cy="781632"/>
+            </a:xfrm>
+            <a:prstGeom prst="line">
+              <a:avLst/>
+            </a:prstGeom>
+            <a:solidFill>
+              <a:srgbClr val="FFFFFF"/>
+            </a:solidFill>
+            <a:ln w="22225" cap="flat" cmpd="sng" algn="ctr">
+              <a:solidFill>
+                <a:srgbClr val="C00000"/>
+              </a:solidFill>
+              <a:prstDash val="solid"/>
+              <a:miter lim="800000"/>
+            </a:ln>
+            <a:effectLst/>
+          </p:spPr>
+        </p:cxnSp>
+        <p:cxnSp>
+          <p:nvCxnSpPr>
+            <p:cNvPr id="44" name="直接连接符 132">
+              <a:extLst>
+                <a:ext uri="{FF2B5EF4-FFF2-40B4-BE49-F238E27FC236}">
+                  <a16:creationId xmlns:a16="http://schemas.microsoft.com/office/drawing/2014/main" id="{FC4BADEB-C468-4FFC-AE84-5F5E8552398A}"/>
+                </a:ext>
+              </a:extLst>
+            </p:cNvPr>
+            <p:cNvCxnSpPr/>
+            <p:nvPr/>
+          </p:nvCxnSpPr>
+          <p:spPr>
+            <a:xfrm flipH="1">
+              <a:off x="2360159" y="1643545"/>
+              <a:ext cx="668" cy="781632"/>
+            </a:xfrm>
+            <a:prstGeom prst="line">
+              <a:avLst/>
+            </a:prstGeom>
+            <a:solidFill>
+              <a:srgbClr val="FFFFFF"/>
+            </a:solidFill>
+            <a:ln w="22225" cap="flat" cmpd="sng" algn="ctr">
+              <a:solidFill>
+                <a:srgbClr val="C00000"/>
+              </a:solidFill>
+              <a:prstDash val="solid"/>
+              <a:miter lim="800000"/>
+            </a:ln>
+            <a:effectLst/>
+          </p:spPr>
+        </p:cxnSp>
+        <p:cxnSp>
+          <p:nvCxnSpPr>
+            <p:cNvPr id="45" name="直接连接符 133">
+              <a:extLst>
+                <a:ext uri="{FF2B5EF4-FFF2-40B4-BE49-F238E27FC236}">
+                  <a16:creationId xmlns:a16="http://schemas.microsoft.com/office/drawing/2014/main" id="{78BFEAA8-590F-4FD0-95A3-15B43853A206}"/>
+                </a:ext>
+              </a:extLst>
+            </p:cNvPr>
+            <p:cNvCxnSpPr/>
+            <p:nvPr/>
+          </p:nvCxnSpPr>
+          <p:spPr>
+            <a:xfrm flipH="1">
+              <a:off x="2360826" y="5892869"/>
+              <a:ext cx="1" cy="781632"/>
+            </a:xfrm>
+            <a:prstGeom prst="line">
+              <a:avLst/>
+            </a:prstGeom>
+            <a:solidFill>
+              <a:srgbClr val="FFFFFF"/>
+            </a:solidFill>
+            <a:ln w="22225" cap="flat" cmpd="sng" algn="ctr">
+              <a:solidFill>
+                <a:srgbClr val="C00000"/>
+              </a:solidFill>
+              <a:prstDash val="solid"/>
+              <a:miter lim="800000"/>
+            </a:ln>
+            <a:effectLst/>
+          </p:spPr>
+        </p:cxnSp>
+        <p:cxnSp>
+          <p:nvCxnSpPr>
+            <p:cNvPr id="46" name="直接连接符 134">
+              <a:extLst>
+                <a:ext uri="{FF2B5EF4-FFF2-40B4-BE49-F238E27FC236}">
+                  <a16:creationId xmlns:a16="http://schemas.microsoft.com/office/drawing/2014/main" id="{447E548E-6C33-422F-8849-B1439874457A}"/>
+                </a:ext>
+              </a:extLst>
+            </p:cNvPr>
+            <p:cNvCxnSpPr/>
+            <p:nvPr/>
+          </p:nvCxnSpPr>
+          <p:spPr>
+            <a:xfrm flipH="1">
+              <a:off x="7119642" y="5905090"/>
+              <a:ext cx="1" cy="781632"/>
+            </a:xfrm>
+            <a:prstGeom prst="line">
+              <a:avLst/>
+            </a:prstGeom>
+            <a:solidFill>
+              <a:srgbClr val="FFFFFF"/>
+            </a:solidFill>
+            <a:ln w="22225" cap="flat" cmpd="sng" algn="ctr">
+              <a:solidFill>
+                <a:srgbClr val="C00000"/>
+              </a:solidFill>
+              <a:prstDash val="solid"/>
+              <a:miter lim="800000"/>
+            </a:ln>
+            <a:effectLst/>
+          </p:spPr>
+        </p:cxnSp>
+        <p:cxnSp>
+          <p:nvCxnSpPr>
+            <p:cNvPr id="47" name="直接连接符 135">
+              <a:extLst>
+                <a:ext uri="{FF2B5EF4-FFF2-40B4-BE49-F238E27FC236}">
+                  <a16:creationId xmlns:a16="http://schemas.microsoft.com/office/drawing/2014/main" id="{BA94BFDC-C197-40F0-A5D3-06C616E97224}"/>
+                </a:ext>
+              </a:extLst>
+            </p:cNvPr>
+            <p:cNvCxnSpPr/>
+            <p:nvPr/>
+          </p:nvCxnSpPr>
+          <p:spPr>
+            <a:xfrm>
+              <a:off x="6928683" y="6686722"/>
+              <a:ext cx="195024" cy="0"/>
+            </a:xfrm>
+            <a:prstGeom prst="line">
+              <a:avLst/>
+            </a:prstGeom>
+            <a:solidFill>
+              <a:srgbClr val="FFFFFF"/>
+            </a:solidFill>
+            <a:ln w="22225" cap="flat" cmpd="sng" algn="ctr">
+              <a:solidFill>
+                <a:srgbClr val="C00000"/>
+              </a:solidFill>
+              <a:prstDash val="solid"/>
+              <a:miter lim="800000"/>
+            </a:ln>
+            <a:effectLst/>
+          </p:spPr>
+        </p:cxnSp>
+      </p:grpSp>
       <p:sp>
         <p:nvSpPr>
-          <p:cNvPr id="4" name="文本框 3">
+          <p:cNvPr id="48" name="文本框 47">
             <a:extLst>
               <a:ext uri="{FF2B5EF4-FFF2-40B4-BE49-F238E27FC236}">
-                <a16:creationId xmlns:a16="http://schemas.microsoft.com/office/drawing/2014/main" id="{E93D2D1D-4EC0-429B-86BE-752EDDB99A27}"/>
+                <a16:creationId xmlns:a16="http://schemas.microsoft.com/office/drawing/2014/main" id="{B7888829-2854-4BA2-90AF-8BB764B5911F}"/>
               </a:ext>
             </a:extLst>
           </p:cNvPr>
@@ -16148,127 +14988,65 @@
         </p:nvSpPr>
         <p:spPr>
           <a:xfrm>
-            <a:off x="566184" y="6354632"/>
-            <a:ext cx="4571678" cy="153888"/>
+            <a:off x="6606849" y="3525925"/>
+            <a:ext cx="4002854" cy="276999"/>
           </a:xfrm>
           <a:prstGeom prst="rect">
             <a:avLst/>
           </a:prstGeom>
-          <a:noFill/>
+          <a:solidFill>
+            <a:schemeClr val="tx2"/>
+          </a:solidFill>
         </p:spPr>
         <p:txBody>
-          <a:bodyPr wrap="square" lIns="0" tIns="0" rIns="0" bIns="0" rtlCol="0">
+          <a:bodyPr wrap="square">
             <a:spAutoFit/>
           </a:bodyPr>
           <a:lstStyle/>
           <a:p>
-            <a:r>
-              <a:rPr kumimoji="1" lang="zh-CN" altLang="en-US" sz="1000" dirty="0">
-                <a:solidFill>
-                  <a:srgbClr val="000000"/>
-                </a:solidFill>
-                <a:latin typeface="微软雅黑" panose="020B0503020204020204" pitchFamily="34" charset="-122"/>
-                <a:ea typeface="微软雅黑" panose="020B0503020204020204" pitchFamily="34" charset="-122"/>
-              </a:rPr>
-              <a:t>备注：每次</a:t>
-            </a:r>
-            <a:r>
-              <a:rPr kumimoji="1" lang="en-US" altLang="zh-CN" sz="1000" dirty="0">
-                <a:solidFill>
-                  <a:srgbClr val="000000"/>
-                </a:solidFill>
-                <a:latin typeface="微软雅黑" panose="020B0503020204020204" pitchFamily="34" charset="-122"/>
-                <a:ea typeface="微软雅黑" panose="020B0503020204020204" pitchFamily="34" charset="-122"/>
-              </a:rPr>
-              <a:t>decode </a:t>
-            </a:r>
-            <a:r>
-              <a:rPr kumimoji="1" lang="zh-CN" altLang="en-US" sz="1000" dirty="0">
-                <a:solidFill>
-                  <a:srgbClr val="000000"/>
-                </a:solidFill>
-                <a:latin typeface="微软雅黑" panose="020B0503020204020204" pitchFamily="34" charset="-122"/>
-                <a:ea typeface="微软雅黑" panose="020B0503020204020204" pitchFamily="34" charset="-122"/>
-              </a:rPr>
-              <a:t>缓存</a:t>
-            </a:r>
-            <a:r>
-              <a:rPr kumimoji="1" lang="en-US" altLang="zh-CN" sz="1000" dirty="0">
-                <a:solidFill>
-                  <a:srgbClr val="000000"/>
-                </a:solidFill>
-                <a:latin typeface="微软雅黑" panose="020B0503020204020204" pitchFamily="34" charset="-122"/>
-                <a:ea typeface="微软雅黑" panose="020B0503020204020204" pitchFamily="34" charset="-122"/>
-              </a:rPr>
-              <a:t>6</a:t>
-            </a:r>
-            <a:r>
-              <a:rPr kumimoji="1" lang="zh-CN" altLang="en-US" sz="1000" dirty="0">
-                <a:solidFill>
-                  <a:srgbClr val="000000"/>
-                </a:solidFill>
-                <a:latin typeface="微软雅黑" panose="020B0503020204020204" pitchFamily="34" charset="-122"/>
-                <a:ea typeface="微软雅黑" panose="020B0503020204020204" pitchFamily="34" charset="-122"/>
-              </a:rPr>
-              <a:t>个</a:t>
-            </a:r>
-            <a:r>
-              <a:rPr kumimoji="1" lang="en-US" altLang="zh-CN" sz="1000" dirty="0">
-                <a:solidFill>
-                  <a:srgbClr val="000000"/>
-                </a:solidFill>
-                <a:latin typeface="微软雅黑" panose="020B0503020204020204" pitchFamily="34" charset="-122"/>
-                <a:ea typeface="微软雅黑" panose="020B0503020204020204" pitchFamily="34" charset="-122"/>
-              </a:rPr>
-              <a:t>token</a:t>
-            </a:r>
-            <a:r>
-              <a:rPr kumimoji="1" lang="zh-CN" altLang="en-US" sz="1000" dirty="0">
-                <a:solidFill>
-                  <a:srgbClr val="000000"/>
-                </a:solidFill>
-                <a:latin typeface="微软雅黑" panose="020B0503020204020204" pitchFamily="34" charset="-122"/>
-                <a:ea typeface="微软雅黑" panose="020B0503020204020204" pitchFamily="34" charset="-122"/>
-              </a:rPr>
-              <a:t>，</a:t>
-            </a:r>
-            <a:r>
-              <a:rPr kumimoji="1" lang="en-US" altLang="zh-CN" sz="1000" dirty="0">
-                <a:solidFill>
-                  <a:srgbClr val="000000"/>
-                </a:solidFill>
-                <a:latin typeface="微软雅黑" panose="020B0503020204020204" pitchFamily="34" charset="-122"/>
-                <a:ea typeface="微软雅黑" panose="020B0503020204020204" pitchFamily="34" charset="-122"/>
-              </a:rPr>
-              <a:t>MLA KV, KDA State, key/gate </a:t>
-            </a:r>
-            <a:r>
-              <a:rPr kumimoji="1" lang="zh-CN" altLang="en-US" sz="1000" dirty="0">
-                <a:solidFill>
-                  <a:srgbClr val="000000"/>
-                </a:solidFill>
-                <a:latin typeface="微软雅黑" panose="020B0503020204020204" pitchFamily="34" charset="-122"/>
-                <a:ea typeface="微软雅黑" panose="020B0503020204020204" pitchFamily="34" charset="-122"/>
-              </a:rPr>
-              <a:t>均采用</a:t>
-            </a:r>
-            <a:r>
-              <a:rPr kumimoji="1" lang="en-US" altLang="zh-CN" sz="1000" dirty="0">
-                <a:solidFill>
-                  <a:srgbClr val="000000"/>
-                </a:solidFill>
-                <a:latin typeface="微软雅黑" panose="020B0503020204020204" pitchFamily="34" charset="-122"/>
-                <a:ea typeface="微软雅黑" panose="020B0503020204020204" pitchFamily="34" charset="-122"/>
-              </a:rPr>
-              <a:t>BF16 </a:t>
-            </a:r>
-            <a:endParaRPr kumimoji="1" lang="zh-CN" altLang="en-US" sz="1000" dirty="0">
-              <a:solidFill>
-                <a:srgbClr val="000000"/>
-              </a:solidFill>
-              <a:latin typeface="微软雅黑" panose="020B0503020204020204" pitchFamily="34" charset="-122"/>
-              <a:ea typeface="微软雅黑" panose="020B0503020204020204" pitchFamily="34" charset="-122"/>
-            </a:endParaRPr>
+            <a:pPr algn="ctr" defTabSz="914034">
+              <a:defRPr/>
+            </a:pPr>
+            <a:r>
+              <a:rPr kumimoji="1" lang="en-US" altLang="zh-CN" sz="1200" b="1" dirty="0">
+                <a:solidFill>
+                  <a:srgbClr val="C00000"/>
+                </a:solidFill>
+                <a:latin typeface="微软雅黑" panose="020B0503020204020204" pitchFamily="34" charset="-122"/>
+                <a:ea typeface="微软雅黑" panose="020B0503020204020204" pitchFamily="34" charset="-122"/>
+              </a:rPr>
+              <a:t>KDA</a:t>
+            </a:r>
+            <a:r>
+              <a:rPr kumimoji="1" lang="zh-CN" altLang="en-US" sz="1200" b="1" dirty="0">
+                <a:solidFill>
+                  <a:srgbClr val="C00000"/>
+                </a:solidFill>
+                <a:latin typeface="微软雅黑" panose="020B0503020204020204" pitchFamily="34" charset="-122"/>
+                <a:ea typeface="微软雅黑" panose="020B0503020204020204" pitchFamily="34" charset="-122"/>
+              </a:rPr>
+              <a:t> </a:t>
+            </a:r>
+            <a:r>
+              <a:rPr kumimoji="1" lang="en-US" altLang="zh-CN" sz="1200" b="1" dirty="0">
+                <a:solidFill>
+                  <a:srgbClr val="C00000"/>
+                </a:solidFill>
+                <a:latin typeface="微软雅黑" panose="020B0503020204020204" pitchFamily="34" charset="-122"/>
+                <a:ea typeface="微软雅黑" panose="020B0503020204020204" pitchFamily="34" charset="-122"/>
+              </a:rPr>
+              <a:t>State </a:t>
+            </a:r>
+            <a:r>
+              <a:rPr kumimoji="1" lang="zh-CN" altLang="en-US" sz="1200" b="1" dirty="0">
+                <a:solidFill>
+                  <a:srgbClr val="C00000"/>
+                </a:solidFill>
+                <a:latin typeface="微软雅黑" panose="020B0503020204020204" pitchFamily="34" charset="-122"/>
+                <a:ea typeface="微软雅黑" panose="020B0503020204020204" pitchFamily="34" charset="-122"/>
+              </a:rPr>
+              <a:t>重建公式</a:t>
+            </a:r>
           </a:p>
         </p:txBody>
       </p:sp>

</xml_diff>